<commit_message>
Enrichit le rapport ML cartons jaunes : 5 nouvelles figures et verification du pipeline
</commit_message>
<xml_diff>
--- a/Cours_IA/Machine_learning/Cartons_Jaunes_FIFA2026/Presentation_ML_FIFA.pptx
+++ b/Cours_IA/Machine_learning/Cartons_Jaunes_FIFA2026/Presentation_ML_FIFA.pptx
@@ -16,6 +16,10 @@
     <p:sldId id="264" r:id="rId15"/>
     <p:sldId id="265" r:id="rId16"/>
     <p:sldId id="266" r:id="rId17"/>
+    <p:sldId id="267" r:id="rId18"/>
+    <p:sldId id="268" r:id="rId19"/>
+    <p:sldId id="269" r:id="rId20"/>
+    <p:sldId id="270" r:id="rId21"/>
   </p:sldIdLst>
   <p:sldSz cx="12191695" cy="6858000" type="screen4x3"/>
   <p:notesSz cx="6858000" cy="9144000"/>
@@ -3535,7 +3539,7 @@
                 </a:solidFill>
                 <a:latin typeface="Calibri"/>
               </a:rPr>
-              <a:t>PARTIE 3 — CLUSTERING</a:t>
+              <a:t>PARTIE 2 — INTERPRÉTABILITÉ</a:t>
             </a:r>
           </a:p>
         </p:txBody>
@@ -3577,14 +3581,14 @@
                 </a:solidFill>
                 <a:latin typeface="Calibri"/>
               </a:rPr>
-              <a:t>KMeans vs DBSCAN</a:t>
+              <a:t>Un piège : le biais de cardinalité</a:t>
             </a:r>
           </a:p>
         </p:txBody>
       </p:sp>
       <p:pic>
         <p:nvPicPr>
-          <p:cNvPr id="6" name="Picture 5" descr="kmeans_clusters.png"/>
+          <p:cNvPr id="6" name="Picture 5" descr="importance_comparaison.png"/>
           <p:cNvPicPr>
             <a:picLocks noChangeAspect="1"/>
           </p:cNvPicPr>
@@ -3598,48 +3602,24 @@
         </p:blipFill>
         <p:spPr>
           <a:xfrm>
-            <a:off x="1080324" y="1371600"/>
-            <a:ext cx="4331592" cy="3383280"/>
+            <a:off x="1949572" y="1371600"/>
+            <a:ext cx="8262375" cy="3566160"/>
           </a:xfrm>
           <a:prstGeom prst="rect">
             <a:avLst/>
           </a:prstGeom>
         </p:spPr>
       </p:pic>
-      <p:pic>
-        <p:nvPicPr>
-          <p:cNvPr id="7" name="Picture 6" descr="dbscan_clusters.png"/>
-          <p:cNvPicPr>
-            <a:picLocks noChangeAspect="1"/>
-          </p:cNvPicPr>
-          <p:nvPr/>
-        </p:nvPicPr>
-        <p:blipFill>
-          <a:blip r:embed="rId3"/>
-          <a:stretch>
-            <a:fillRect/>
-          </a:stretch>
-        </p:blipFill>
-        <p:spPr>
-          <a:xfrm>
-            <a:off x="6749604" y="1371600"/>
-            <a:ext cx="4331592" cy="3383280"/>
-          </a:xfrm>
-          <a:prstGeom prst="rect">
-            <a:avLst/>
-          </a:prstGeom>
-        </p:spPr>
-      </p:pic>
-      <p:sp>
-        <p:nvSpPr>
-          <p:cNvPr id="8" name="TextBox 7"/>
+      <p:sp>
+        <p:nvSpPr>
+          <p:cNvPr id="7" name="TextBox 6"/>
           <p:cNvSpPr txBox="1"/>
           <p:nvPr/>
         </p:nvSpPr>
         <p:spPr>
           <a:xfrm>
-            <a:off x="640080" y="4800600"/>
-            <a:ext cx="5212080" cy="365760"/>
+            <a:off x="457200" y="5120640"/>
+            <a:ext cx="11247120" cy="1325880"/>
           </a:xfrm>
           <a:prstGeom prst="rect">
             <a:avLst/>
@@ -3652,90 +3632,6 @@
           </a:bodyPr>
           <a:lstStyle/>
           <a:p>
-            <a:pPr algn="ctr">
-              <a:spcBef>
-                <a:spcPts val="0"/>
-              </a:spcBef>
-              <a:spcAft>
-                <a:spcPts val="600"/>
-              </a:spcAft>
-            </a:pPr>
-            <a:r>
-              <a:rPr sz="1100" b="0">
-                <a:solidFill>
-                  <a:srgbClr val="555555"/>
-                </a:solidFill>
-                <a:latin typeface="Calibri"/>
-              </a:rPr>
-              <a:t>KMeans (k=4) — silhouette 0,135 (faible)</a:t>
-            </a:r>
-          </a:p>
-        </p:txBody>
-      </p:sp>
-      <p:sp>
-        <p:nvSpPr>
-          <p:cNvPr id="9" name="TextBox 8"/>
-          <p:cNvSpPr txBox="1"/>
-          <p:nvPr/>
-        </p:nvSpPr>
-        <p:spPr>
-          <a:xfrm>
-            <a:off x="6309360" y="4800600"/>
-            <a:ext cx="5212080" cy="365760"/>
-          </a:xfrm>
-          <a:prstGeom prst="rect">
-            <a:avLst/>
-          </a:prstGeom>
-          <a:noFill/>
-        </p:spPr>
-        <p:txBody>
-          <a:bodyPr wrap="square" anchor="t">
-            <a:spAutoFit/>
-          </a:bodyPr>
-          <a:lstStyle/>
-          <a:p>
-            <a:pPr algn="ctr">
-              <a:spcBef>
-                <a:spcPts val="0"/>
-              </a:spcBef>
-              <a:spcAft>
-                <a:spcPts val="600"/>
-              </a:spcAft>
-            </a:pPr>
-            <a:r>
-              <a:rPr sz="1100" b="0">
-                <a:solidFill>
-                  <a:srgbClr val="555555"/>
-                </a:solidFill>
-                <a:latin typeface="Calibri"/>
-              </a:rPr>
-              <a:t>DBSCAN — 2 clusters nets + bruit</a:t>
-            </a:r>
-          </a:p>
-        </p:txBody>
-      </p:sp>
-      <p:sp>
-        <p:nvSpPr>
-          <p:cNvPr id="10" name="TextBox 9"/>
-          <p:cNvSpPr txBox="1"/>
-          <p:nvPr/>
-        </p:nvSpPr>
-        <p:spPr>
-          <a:xfrm>
-            <a:off x="640080" y="5212080"/>
-            <a:ext cx="11064240" cy="1463040"/>
-          </a:xfrm>
-          <a:prstGeom prst="rect">
-            <a:avLst/>
-          </a:prstGeom>
-          <a:noFill/>
-        </p:spPr>
-        <p:txBody>
-          <a:bodyPr wrap="square" anchor="t">
-            <a:spAutoFit/>
-          </a:bodyPr>
-          <a:lstStyle/>
-          <a:p>
             <a:pPr algn="l">
               <a:spcBef>
                 <a:spcPts val="0"/>
@@ -3745,13 +3641,22 @@
               </a:spcAft>
             </a:pPr>
             <a:r>
+              <a:rPr sz="1500" b="1">
+                <a:solidFill>
+                  <a:srgbClr val="2563EB"/>
+                </a:solidFill>
+                <a:latin typeface="Calibri"/>
+              </a:rPr>
+              <a:t>Le diagnostic : </a:t>
+            </a:r>
+            <a:r>
               <a:rPr sz="1500" b="0">
                 <a:solidFill>
                   <a:srgbClr val="1A2B4A"/>
                 </a:solidFill>
                 <a:latin typeface="Calibri"/>
               </a:rPr>
-              <a:t>KMeans ne recouvre pas les postes réels. DBSCAN isole 2 clusters : celui de gauche est enrichi en gardiens (18,2 % vs 6,7 %), mais le taux de cartons y est quasi identique (9,9 % vs 9,6 %) → aucun lien entre structure des données et cartons.</a:t>
+              <a:t>l'importance native place jersey_number en tête — aucun sens footballistique. Cette mesure favorise les variables à nombreuses valeurs distinctes. L'importance par permutation tranche : 0,128 → 0,008, un effondrement d'un facteur ~16. Aucune variable n'a d'effet réellement marquant.</a:t>
             </a:r>
           </a:p>
         </p:txBody>
@@ -3899,7 +3804,7 @@
                 </a:solidFill>
                 <a:latin typeface="Calibri"/>
               </a:rPr>
-              <a:t>CONCLUSION</a:t>
+              <a:t>PARTIE 2 — SHAP</a:t>
             </a:r>
           </a:p>
         </p:txBody>
@@ -3941,21 +3846,45 @@
                 </a:solidFill>
                 <a:latin typeface="Calibri"/>
               </a:rPr>
-              <a:t>Un résultat cohérent et honnête</a:t>
-            </a:r>
-          </a:p>
-        </p:txBody>
-      </p:sp>
-      <p:sp>
-        <p:nvSpPr>
-          <p:cNvPr id="6" name="TextBox 5"/>
+              <a:t>Interprétation globale</a:t>
+            </a:r>
+          </a:p>
+        </p:txBody>
+      </p:sp>
+      <p:pic>
+        <p:nvPicPr>
+          <p:cNvPr id="6" name="Picture 5" descr="shap_summary_plot.png"/>
+          <p:cNvPicPr>
+            <a:picLocks noChangeAspect="1"/>
+          </p:cNvPicPr>
+          <p:nvPr/>
+        </p:nvPicPr>
+        <p:blipFill>
+          <a:blip r:embed="rId2"/>
+          <a:stretch>
+            <a:fillRect/>
+          </a:stretch>
+        </p:blipFill>
+        <p:spPr>
+          <a:xfrm>
+            <a:off x="1045297" y="1280160"/>
+            <a:ext cx="4310205" cy="5120640"/>
+          </a:xfrm>
+          <a:prstGeom prst="rect">
+            <a:avLst/>
+          </a:prstGeom>
+        </p:spPr>
+      </p:pic>
+      <p:sp>
+        <p:nvSpPr>
+          <p:cNvPr id="7" name="TextBox 6"/>
           <p:cNvSpPr txBox="1"/>
           <p:nvPr/>
         </p:nvSpPr>
         <p:spPr>
           <a:xfrm>
-            <a:off x="548640" y="1280160"/>
-            <a:ext cx="11247120" cy="4206240"/>
+            <a:off x="6126480" y="1554480"/>
+            <a:ext cx="5577840" cy="4572000"/>
           </a:xfrm>
           <a:prstGeom prst="rect">
             <a:avLst/>
@@ -3977,13 +3906,32 @@
               </a:spcAft>
             </a:pPr>
             <a:r>
+              <a:rPr sz="1800" b="1">
+                <a:solidFill>
+                  <a:srgbClr val="2563EB"/>
+                </a:solidFill>
+                <a:latin typeface="Calibri"/>
+              </a:rPr>
+              <a:t>Comment lire</a:t>
+            </a:r>
+          </a:p>
+          <a:p>
+            <a:pPr algn="l">
+              <a:spcBef>
+                <a:spcPts val="0"/>
+              </a:spcBef>
+              <a:spcAft>
+                <a:spcPts val="1000"/>
+              </a:spcAft>
+            </a:pPr>
+            <a:r>
               <a:rPr sz="1500" b="0">
                 <a:solidFill>
                   <a:srgbClr val="1A2B4A"/>
                 </a:solidFill>
                 <a:latin typeface="Calibri"/>
               </a:rPr>
-              <a:t>•  Toutes les analyses convergent : corrélation nulle, AUC ≈ 0,5, importances minuscules,</a:t>
+              <a:t>Chaque point = un joueur. Rouge = valeur haute de la variable, bleu = valeur basse.</a:t>
             </a:r>
           </a:p>
           <a:p>
@@ -3996,13 +3944,13 @@
               </a:spcAft>
             </a:pPr>
             <a:r>
-              <a:rPr sz="1300" b="0">
-                <a:solidFill>
-                  <a:srgbClr val="555555"/>
-                </a:solidFill>
-                <a:latin typeface="Calibri"/>
-              </a:rPr>
-              <a:t>–  SHAP faible, clustering sans lien avec la cible.</a:t>
+              <a:rPr sz="1500" b="0">
+                <a:solidFill>
+                  <a:srgbClr val="1A2B4A"/>
+                </a:solidFill>
+                <a:latin typeface="Calibri"/>
+              </a:rPr>
+              <a:t>À droite = pousse vers « carton », à gauche = vers « pas de carton ».</a:t>
             </a:r>
           </a:p>
           <a:p>
@@ -4021,7 +3969,7 @@
                 </a:solidFill>
                 <a:latin typeface="Calibri"/>
               </a:rPr>
-              <a:t>•  → Les cartons jaunes ne sont pas prédictibles à partir de ces variables.</a:t>
+              <a:t>defensive_contribution donne la relation la plus cohérente : rouge à droite, bleu à gauche — plus d'engagement défensif, plus de risque.</a:t>
             </a:r>
           </a:p>
           <a:p>
@@ -4034,122 +3982,133 @@
               </a:spcAft>
             </a:pPr>
             <a:r>
-              <a:rPr sz="1300" b="0">
-                <a:solidFill>
-                  <a:srgbClr val="555555"/>
-                </a:solidFill>
-                <a:latin typeface="Calibri"/>
-              </a:rPr>
-              <a:t>–  Facteurs probables absents du dataset : décision arbitrale, contexte et tension du match.</a:t>
-            </a:r>
-          </a:p>
-          <a:p>
-            <a:pPr algn="l">
-              <a:spcBef>
-                <a:spcPts val="0"/>
-              </a:spcBef>
-              <a:spcAft>
-                <a:spcPts val="1000"/>
-              </a:spcAft>
-            </a:pPr>
-            <a:r>
-              <a:rPr sz="1500" b="0">
+              <a:rPr sz="1500" b="1">
                 <a:solidFill>
                   <a:srgbClr val="1A2B4A"/>
                 </a:solidFill>
                 <a:latin typeface="Calibri"/>
               </a:rPr>
-              <a:t>•  Ce que le projet démontre malgré tout :</a:t>
-            </a:r>
-          </a:p>
-          <a:p>
-            <a:pPr algn="l">
-              <a:spcBef>
-                <a:spcPts val="0"/>
-              </a:spcBef>
-              <a:spcAft>
-                <a:spcPts val="1000"/>
-              </a:spcAft>
-            </a:pPr>
-            <a:r>
-              <a:rPr sz="1300" b="0">
-                <a:solidFill>
-                  <a:srgbClr val="555555"/>
-                </a:solidFill>
-                <a:latin typeface="Calibri"/>
-              </a:rPr>
-              <a:t>–  le piège de l'accuracy sur classes déséquilibrées ;</a:t>
-            </a:r>
-          </a:p>
-          <a:p>
-            <a:pPr algn="l">
-              <a:spcBef>
-                <a:spcPts val="0"/>
-              </a:spcBef>
-              <a:spcAft>
-                <a:spcPts val="1000"/>
-              </a:spcAft>
-            </a:pPr>
-            <a:r>
-              <a:rPr sz="1300" b="0">
-                <a:solidFill>
-                  <a:srgbClr val="555555"/>
-                </a:solidFill>
-                <a:latin typeface="Calibri"/>
-              </a:rPr>
-              <a:t>–  le rééquilibrage (class_weight / sample_weight) et l'arbitrage précision / rappel ;</a:t>
-            </a:r>
-          </a:p>
-          <a:p>
-            <a:pPr algn="l">
-              <a:spcBef>
-                <a:spcPts val="0"/>
-              </a:spcBef>
-              <a:spcAft>
-                <a:spcPts val="1000"/>
-              </a:spcAft>
-            </a:pPr>
-            <a:r>
-              <a:rPr sz="1300" b="0">
-                <a:solidFill>
-                  <a:srgbClr val="555555"/>
-                </a:solidFill>
-                <a:latin typeface="Calibri"/>
-              </a:rPr>
-              <a:t>–  le biais de cardinalité des importances, corrigé par permutation ;</a:t>
-            </a:r>
-          </a:p>
-          <a:p>
-            <a:pPr algn="l">
-              <a:spcBef>
-                <a:spcPts val="0"/>
-              </a:spcBef>
-              <a:spcAft>
-                <a:spcPts val="1000"/>
-              </a:spcAft>
-            </a:pPr>
-            <a:r>
-              <a:rPr sz="1300" b="0">
-                <a:solidFill>
-                  <a:srgbClr val="555555"/>
-                </a:solidFill>
-                <a:latin typeface="Calibri"/>
-              </a:rPr>
-              <a:t>–  la différence KMeans (convexe) vs DBSCAN (densité).</a:t>
-            </a:r>
-          </a:p>
-        </p:txBody>
-      </p:sp>
-      <p:sp>
-        <p:nvSpPr>
-          <p:cNvPr id="7" name="TextBox 6"/>
+              <a:t>Mais l'échelle (−0,04 à +0,03) confirme un signal très faible.</a:t>
+            </a:r>
+          </a:p>
+        </p:txBody>
+      </p:sp>
+    </p:spTree>
+  </p:cSld>
+  <p:clrMapOvr>
+    <a:masterClrMapping/>
+  </p:clrMapOvr>
+</p:sld>
+</file>
+
+<file path=ppt/slides/slide12.xml><?xml version="1.0" encoding="utf-8"?>
+<p:sld xmlns:a="http://schemas.openxmlformats.org/drawingml/2006/main" xmlns:p="http://schemas.openxmlformats.org/presentationml/2006/main" xmlns:r="http://schemas.openxmlformats.org/officeDocument/2006/relationships">
+  <p:cSld>
+    <p:spTree>
+      <p:nvGrpSpPr>
+        <p:cNvPr id="1" name=""/>
+        <p:cNvGrpSpPr/>
+        <p:nvPr/>
+      </p:nvGrpSpPr>
+      <p:grpSpPr/>
+      <p:sp>
+        <p:nvSpPr>
+          <p:cNvPr id="2" name="Rectangle 1"/>
+          <p:cNvSpPr/>
+          <p:nvPr/>
+        </p:nvSpPr>
+        <p:spPr>
+          <a:xfrm>
+            <a:off x="0" y="0"/>
+            <a:ext cx="12191695" cy="1051560"/>
+          </a:xfrm>
+          <a:prstGeom prst="rect">
+            <a:avLst/>
+          </a:prstGeom>
+          <a:solidFill>
+            <a:srgbClr val="1A2B4A"/>
+          </a:solidFill>
+          <a:ln>
+            <a:noFill/>
+          </a:ln>
+          <a:effectLst/>
+        </p:spPr>
+        <p:style>
+          <a:lnRef idx="1">
+            <a:schemeClr val="accent1"/>
+          </a:lnRef>
+          <a:fillRef idx="3">
+            <a:schemeClr val="accent1"/>
+          </a:fillRef>
+          <a:effectRef idx="2">
+            <a:schemeClr val="accent1"/>
+          </a:effectRef>
+          <a:fontRef idx="minor">
+            <a:schemeClr val="lt1"/>
+          </a:fontRef>
+        </p:style>
+        <p:txBody>
+          <a:bodyPr rtlCol="0" anchor="ctr"/>
+          <a:lstStyle/>
+          <a:p>
+            <a:pPr algn="ctr"/>
+          </a:p>
+        </p:txBody>
+      </p:sp>
+      <p:sp>
+        <p:nvSpPr>
+          <p:cNvPr id="3" name="Rectangle 2"/>
+          <p:cNvSpPr/>
+          <p:nvPr/>
+        </p:nvSpPr>
+        <p:spPr>
+          <a:xfrm>
+            <a:off x="0" y="1051560"/>
+            <a:ext cx="12191695" cy="50800"/>
+          </a:xfrm>
+          <a:prstGeom prst="rect">
+            <a:avLst/>
+          </a:prstGeom>
+          <a:solidFill>
+            <a:srgbClr val="2563EB"/>
+          </a:solidFill>
+          <a:ln>
+            <a:noFill/>
+          </a:ln>
+          <a:effectLst/>
+        </p:spPr>
+        <p:style>
+          <a:lnRef idx="1">
+            <a:schemeClr val="accent1"/>
+          </a:lnRef>
+          <a:fillRef idx="3">
+            <a:schemeClr val="accent1"/>
+          </a:fillRef>
+          <a:effectRef idx="2">
+            <a:schemeClr val="accent1"/>
+          </a:effectRef>
+          <a:fontRef idx="minor">
+            <a:schemeClr val="lt1"/>
+          </a:fontRef>
+        </p:style>
+        <p:txBody>
+          <a:bodyPr rtlCol="0" anchor="ctr"/>
+          <a:lstStyle/>
+          <a:p>
+            <a:pPr algn="ctr"/>
+          </a:p>
+        </p:txBody>
+      </p:sp>
+      <p:sp>
+        <p:nvSpPr>
+          <p:cNvPr id="4" name="TextBox 3"/>
           <p:cNvSpPr txBox="1"/>
           <p:nvPr/>
         </p:nvSpPr>
         <p:spPr>
           <a:xfrm>
-            <a:off x="548640" y="5806440"/>
-            <a:ext cx="11155680" cy="731520"/>
+            <a:off x="548640" y="109728"/>
+            <a:ext cx="10972800" cy="365760"/>
           </a:xfrm>
           <a:prstGeom prst="rect">
             <a:avLst/>
@@ -4162,6 +4121,470 @@
           </a:bodyPr>
           <a:lstStyle/>
           <a:p>
+            <a:pPr algn="l">
+              <a:spcBef>
+                <a:spcPts val="0"/>
+              </a:spcBef>
+              <a:spcAft>
+                <a:spcPts val="600"/>
+              </a:spcAft>
+            </a:pPr>
+            <a:r>
+              <a:rPr sz="1300" b="1">
+                <a:solidFill>
+                  <a:srgbClr val="9DB8E8"/>
+                </a:solidFill>
+                <a:latin typeface="Calibri"/>
+              </a:rPr>
+              <a:t>PARTIE 2 — CAS INDIVIDUEL</a:t>
+            </a:r>
+          </a:p>
+        </p:txBody>
+      </p:sp>
+      <p:sp>
+        <p:nvSpPr>
+          <p:cNvPr id="5" name="TextBox 4"/>
+          <p:cNvSpPr txBox="1"/>
+          <p:nvPr/>
+        </p:nvSpPr>
+        <p:spPr>
+          <a:xfrm>
+            <a:off x="548640" y="384048"/>
+            <a:ext cx="11155680" cy="640080"/>
+          </a:xfrm>
+          <a:prstGeom prst="rect">
+            <a:avLst/>
+          </a:prstGeom>
+          <a:noFill/>
+        </p:spPr>
+        <p:txBody>
+          <a:bodyPr wrap="square" anchor="t">
+            <a:spAutoFit/>
+          </a:bodyPr>
+          <a:lstStyle/>
+          <a:p>
+            <a:pPr algn="l">
+              <a:spcBef>
+                <a:spcPts val="0"/>
+              </a:spcBef>
+              <a:spcAft>
+                <a:spcPts val="600"/>
+              </a:spcAft>
+            </a:pPr>
+            <a:r>
+              <a:rPr sz="2600" b="1">
+                <a:solidFill>
+                  <a:srgbClr val="FFFFFF"/>
+                </a:solidFill>
+                <a:latin typeface="Calibri"/>
+              </a:rPr>
+              <a:t>SHAP waterfall — un joueur</a:t>
+            </a:r>
+          </a:p>
+        </p:txBody>
+      </p:sp>
+      <p:pic>
+        <p:nvPicPr>
+          <p:cNvPr id="6" name="Picture 5" descr="shap_waterfall_joueur0.png"/>
+          <p:cNvPicPr>
+            <a:picLocks noChangeAspect="1"/>
+          </p:cNvPicPr>
+          <p:nvPr/>
+        </p:nvPicPr>
+        <p:blipFill>
+          <a:blip r:embed="rId2"/>
+          <a:stretch>
+            <a:fillRect/>
+          </a:stretch>
+        </p:blipFill>
+        <p:spPr>
+          <a:xfrm>
+            <a:off x="640080" y="1371600"/>
+            <a:ext cx="6284821" cy="4754880"/>
+          </a:xfrm>
+          <a:prstGeom prst="rect">
+            <a:avLst/>
+          </a:prstGeom>
+        </p:spPr>
+      </p:pic>
+      <p:sp>
+        <p:nvSpPr>
+          <p:cNvPr id="7" name="TextBox 6"/>
+          <p:cNvSpPr txBox="1"/>
+          <p:nvPr/>
+        </p:nvSpPr>
+        <p:spPr>
+          <a:xfrm>
+            <a:off x="7498079" y="1463040"/>
+            <a:ext cx="4206240" cy="4572000"/>
+          </a:xfrm>
+          <a:prstGeom prst="rect">
+            <a:avLst/>
+          </a:prstGeom>
+          <a:noFill/>
+        </p:spPr>
+        <p:txBody>
+          <a:bodyPr wrap="square" anchor="t">
+            <a:spAutoFit/>
+          </a:bodyPr>
+          <a:lstStyle/>
+          <a:p>
+            <a:pPr algn="l">
+              <a:spcBef>
+                <a:spcPts val="0"/>
+              </a:spcBef>
+              <a:spcAft>
+                <a:spcPts val="1000"/>
+              </a:spcAft>
+            </a:pPr>
+            <a:r>
+              <a:rPr sz="1800" b="1">
+                <a:solidFill>
+                  <a:srgbClr val="2563EB"/>
+                </a:solidFill>
+                <a:latin typeface="Calibri"/>
+              </a:rPr>
+              <a:t>Comment lire</a:t>
+            </a:r>
+          </a:p>
+          <a:p>
+            <a:pPr algn="l">
+              <a:spcBef>
+                <a:spcPts val="0"/>
+              </a:spcBef>
+              <a:spcAft>
+                <a:spcPts val="1000"/>
+              </a:spcAft>
+            </a:pPr>
+            <a:r>
+              <a:rPr sz="1500" b="0">
+                <a:solidFill>
+                  <a:srgbClr val="1A2B4A"/>
+                </a:solidFill>
+                <a:latin typeface="Calibri"/>
+              </a:rPr>
+              <a:t>On part de la prédiction moyenne (0,5) pour arriver à celle du joueur (0,443).</a:t>
+            </a:r>
+          </a:p>
+          <a:p>
+            <a:pPr algn="l">
+              <a:spcBef>
+                <a:spcPts val="0"/>
+              </a:spcBef>
+              <a:spcAft>
+                <a:spcPts val="1000"/>
+              </a:spcAft>
+            </a:pPr>
+            <a:r>
+              <a:rPr sz="1500" b="1">
+                <a:solidFill>
+                  <a:srgbClr val="1D4ED8"/>
+                </a:solidFill>
+                <a:latin typeface="Calibri"/>
+              </a:rPr>
+              <a:t>Bleu → pousse vers « pas de carton »</a:t>
+            </a:r>
+          </a:p>
+          <a:p>
+            <a:pPr algn="l">
+              <a:spcBef>
+                <a:spcPts val="0"/>
+              </a:spcBef>
+              <a:spcAft>
+                <a:spcPts val="1000"/>
+              </a:spcAft>
+            </a:pPr>
+            <a:r>
+              <a:rPr sz="1500" b="1">
+                <a:solidFill>
+                  <a:srgbClr val="C02A2A"/>
+                </a:solidFill>
+                <a:latin typeface="Calibri"/>
+              </a:rPr>
+              <a:t>Rouge → pousse vers « carton »</a:t>
+            </a:r>
+          </a:p>
+          <a:p>
+            <a:pPr algn="l">
+              <a:spcBef>
+                <a:spcPts val="0"/>
+              </a:spcBef>
+              <a:spcAft>
+                <a:spcPts val="1000"/>
+              </a:spcAft>
+            </a:pPr>
+            <a:r>
+              <a:rPr sz="1500" b="0">
+                <a:solidFill>
+                  <a:srgbClr val="1A2B4A"/>
+                </a:solidFill>
+                <a:latin typeface="Calibri"/>
+              </a:rPr>
+              <a:t>Ici : un creativity_score très élevé (99) réduit le risque. total_minutes_tournament pousse en sens inverse, mais de façon négligeable.</a:t>
+            </a:r>
+          </a:p>
+        </p:txBody>
+      </p:sp>
+    </p:spTree>
+  </p:cSld>
+  <p:clrMapOvr>
+    <a:masterClrMapping/>
+  </p:clrMapOvr>
+</p:sld>
+</file>
+
+<file path=ppt/slides/slide13.xml><?xml version="1.0" encoding="utf-8"?>
+<p:sld xmlns:a="http://schemas.openxmlformats.org/drawingml/2006/main" xmlns:p="http://schemas.openxmlformats.org/presentationml/2006/main" xmlns:r="http://schemas.openxmlformats.org/officeDocument/2006/relationships">
+  <p:cSld>
+    <p:spTree>
+      <p:nvGrpSpPr>
+        <p:cNvPr id="1" name=""/>
+        <p:cNvGrpSpPr/>
+        <p:nvPr/>
+      </p:nvGrpSpPr>
+      <p:grpSpPr/>
+      <p:sp>
+        <p:nvSpPr>
+          <p:cNvPr id="2" name="Rectangle 1"/>
+          <p:cNvSpPr/>
+          <p:nvPr/>
+        </p:nvSpPr>
+        <p:spPr>
+          <a:xfrm>
+            <a:off x="0" y="0"/>
+            <a:ext cx="12191695" cy="1051560"/>
+          </a:xfrm>
+          <a:prstGeom prst="rect">
+            <a:avLst/>
+          </a:prstGeom>
+          <a:solidFill>
+            <a:srgbClr val="1A2B4A"/>
+          </a:solidFill>
+          <a:ln>
+            <a:noFill/>
+          </a:ln>
+          <a:effectLst/>
+        </p:spPr>
+        <p:style>
+          <a:lnRef idx="1">
+            <a:schemeClr val="accent1"/>
+          </a:lnRef>
+          <a:fillRef idx="3">
+            <a:schemeClr val="accent1"/>
+          </a:fillRef>
+          <a:effectRef idx="2">
+            <a:schemeClr val="accent1"/>
+          </a:effectRef>
+          <a:fontRef idx="minor">
+            <a:schemeClr val="lt1"/>
+          </a:fontRef>
+        </p:style>
+        <p:txBody>
+          <a:bodyPr rtlCol="0" anchor="ctr"/>
+          <a:lstStyle/>
+          <a:p>
+            <a:pPr algn="ctr"/>
+          </a:p>
+        </p:txBody>
+      </p:sp>
+      <p:sp>
+        <p:nvSpPr>
+          <p:cNvPr id="3" name="Rectangle 2"/>
+          <p:cNvSpPr/>
+          <p:nvPr/>
+        </p:nvSpPr>
+        <p:spPr>
+          <a:xfrm>
+            <a:off x="0" y="1051560"/>
+            <a:ext cx="12191695" cy="50800"/>
+          </a:xfrm>
+          <a:prstGeom prst="rect">
+            <a:avLst/>
+          </a:prstGeom>
+          <a:solidFill>
+            <a:srgbClr val="2563EB"/>
+          </a:solidFill>
+          <a:ln>
+            <a:noFill/>
+          </a:ln>
+          <a:effectLst/>
+        </p:spPr>
+        <p:style>
+          <a:lnRef idx="1">
+            <a:schemeClr val="accent1"/>
+          </a:lnRef>
+          <a:fillRef idx="3">
+            <a:schemeClr val="accent1"/>
+          </a:fillRef>
+          <a:effectRef idx="2">
+            <a:schemeClr val="accent1"/>
+          </a:effectRef>
+          <a:fontRef idx="minor">
+            <a:schemeClr val="lt1"/>
+          </a:fontRef>
+        </p:style>
+        <p:txBody>
+          <a:bodyPr rtlCol="0" anchor="ctr"/>
+          <a:lstStyle/>
+          <a:p>
+            <a:pPr algn="ctr"/>
+          </a:p>
+        </p:txBody>
+      </p:sp>
+      <p:sp>
+        <p:nvSpPr>
+          <p:cNvPr id="4" name="TextBox 3"/>
+          <p:cNvSpPr txBox="1"/>
+          <p:nvPr/>
+        </p:nvSpPr>
+        <p:spPr>
+          <a:xfrm>
+            <a:off x="548640" y="109728"/>
+            <a:ext cx="10972800" cy="365760"/>
+          </a:xfrm>
+          <a:prstGeom prst="rect">
+            <a:avLst/>
+          </a:prstGeom>
+          <a:noFill/>
+        </p:spPr>
+        <p:txBody>
+          <a:bodyPr wrap="square" anchor="t">
+            <a:spAutoFit/>
+          </a:bodyPr>
+          <a:lstStyle/>
+          <a:p>
+            <a:pPr algn="l">
+              <a:spcBef>
+                <a:spcPts val="0"/>
+              </a:spcBef>
+              <a:spcAft>
+                <a:spcPts val="600"/>
+              </a:spcAft>
+            </a:pPr>
+            <a:r>
+              <a:rPr sz="1300" b="1">
+                <a:solidFill>
+                  <a:srgbClr val="9DB8E8"/>
+                </a:solidFill>
+                <a:latin typeface="Calibri"/>
+              </a:rPr>
+              <a:t>PARTIE 3 — NON SUPERVISÉ</a:t>
+            </a:r>
+          </a:p>
+        </p:txBody>
+      </p:sp>
+      <p:sp>
+        <p:nvSpPr>
+          <p:cNvPr id="5" name="TextBox 4"/>
+          <p:cNvSpPr txBox="1"/>
+          <p:nvPr/>
+        </p:nvSpPr>
+        <p:spPr>
+          <a:xfrm>
+            <a:off x="548640" y="384048"/>
+            <a:ext cx="11155680" cy="640080"/>
+          </a:xfrm>
+          <a:prstGeom prst="rect">
+            <a:avLst/>
+          </a:prstGeom>
+          <a:noFill/>
+        </p:spPr>
+        <p:txBody>
+          <a:bodyPr wrap="square" anchor="t">
+            <a:spAutoFit/>
+          </a:bodyPr>
+          <a:lstStyle/>
+          <a:p>
+            <a:pPr algn="l">
+              <a:spcBef>
+                <a:spcPts val="0"/>
+              </a:spcBef>
+              <a:spcAft>
+                <a:spcPts val="600"/>
+              </a:spcAft>
+            </a:pPr>
+            <a:r>
+              <a:rPr sz="2600" b="1">
+                <a:solidFill>
+                  <a:srgbClr val="FFFFFF"/>
+                </a:solidFill>
+                <a:latin typeface="Calibri"/>
+              </a:rPr>
+              <a:t>PCA — réduction de dimension</a:t>
+            </a:r>
+          </a:p>
+        </p:txBody>
+      </p:sp>
+      <p:pic>
+        <p:nvPicPr>
+          <p:cNvPr id="6" name="Picture 5" descr="pca_variance_expliquee.png"/>
+          <p:cNvPicPr>
+            <a:picLocks noChangeAspect="1"/>
+          </p:cNvPicPr>
+          <p:nvPr/>
+        </p:nvPicPr>
+        <p:blipFill>
+          <a:blip r:embed="rId2"/>
+          <a:stretch>
+            <a:fillRect/>
+          </a:stretch>
+        </p:blipFill>
+        <p:spPr>
+          <a:xfrm>
+            <a:off x="548640" y="1325880"/>
+            <a:ext cx="5394960" cy="3220656"/>
+          </a:xfrm>
+          <a:prstGeom prst="rect">
+            <a:avLst/>
+          </a:prstGeom>
+        </p:spPr>
+      </p:pic>
+      <p:pic>
+        <p:nvPicPr>
+          <p:cNvPr id="7" name="Picture 6" descr="pca_par_poste.png"/>
+          <p:cNvPicPr>
+            <a:picLocks noChangeAspect="1"/>
+          </p:cNvPicPr>
+          <p:nvPr/>
+        </p:nvPicPr>
+        <p:blipFill>
+          <a:blip r:embed="rId3"/>
+          <a:stretch>
+            <a:fillRect/>
+          </a:stretch>
+        </p:blipFill>
+        <p:spPr>
+          <a:xfrm>
+            <a:off x="6726765" y="1325880"/>
+            <a:ext cx="4560150" cy="3566160"/>
+          </a:xfrm>
+          <a:prstGeom prst="rect">
+            <a:avLst/>
+          </a:prstGeom>
+        </p:spPr>
+      </p:pic>
+      <p:sp>
+        <p:nvSpPr>
+          <p:cNvPr id="8" name="TextBox 7"/>
+          <p:cNvSpPr txBox="1"/>
+          <p:nvPr/>
+        </p:nvSpPr>
+        <p:spPr>
+          <a:xfrm>
+            <a:off x="548640" y="5029200"/>
+            <a:ext cx="5394960" cy="365760"/>
+          </a:xfrm>
+          <a:prstGeom prst="rect">
+            <a:avLst/>
+          </a:prstGeom>
+          <a:noFill/>
+        </p:spPr>
+        <p:txBody>
+          <a:bodyPr wrap="square" anchor="t">
+            <a:spAutoFit/>
+          </a:bodyPr>
+          <a:lstStyle/>
+          <a:p>
             <a:pPr algn="ctr">
               <a:spcBef>
                 <a:spcPts val="0"/>
@@ -4171,13 +4594,896 @@
               </a:spcAft>
             </a:pPr>
             <a:r>
+              <a:rPr sz="1100" b="0">
+                <a:solidFill>
+                  <a:srgbClr val="555555"/>
+                </a:solidFill>
+                <a:latin typeface="Calibri"/>
+              </a:rPr>
+              <a:t>2 composantes = 30,8 % de l'information</a:t>
+            </a:r>
+          </a:p>
+        </p:txBody>
+      </p:sp>
+      <p:sp>
+        <p:nvSpPr>
+          <p:cNvPr id="9" name="TextBox 8"/>
+          <p:cNvSpPr txBox="1"/>
+          <p:nvPr/>
+        </p:nvSpPr>
+        <p:spPr>
+          <a:xfrm>
+            <a:off x="6309360" y="5029200"/>
+            <a:ext cx="5394960" cy="365760"/>
+          </a:xfrm>
+          <a:prstGeom prst="rect">
+            <a:avLst/>
+          </a:prstGeom>
+          <a:noFill/>
+        </p:spPr>
+        <p:txBody>
+          <a:bodyPr wrap="square" anchor="t">
+            <a:spAutoFit/>
+          </a:bodyPr>
+          <a:lstStyle/>
+          <a:p>
+            <a:pPr algn="ctr">
+              <a:spcBef>
+                <a:spcPts val="0"/>
+              </a:spcBef>
+              <a:spcAft>
+                <a:spcPts val="600"/>
+              </a:spcAft>
+            </a:pPr>
+            <a:r>
+              <a:rPr sz="1100" b="0">
+                <a:solidFill>
+                  <a:srgbClr val="555555"/>
+                </a:solidFill>
+                <a:latin typeface="Calibri"/>
+              </a:rPr>
+              <a:t>Coloré par poste : les gardiens (rose) se détachent</a:t>
+            </a:r>
+          </a:p>
+        </p:txBody>
+      </p:sp>
+      <p:sp>
+        <p:nvSpPr>
+          <p:cNvPr id="10" name="TextBox 9"/>
+          <p:cNvSpPr txBox="1"/>
+          <p:nvPr/>
+        </p:nvSpPr>
+        <p:spPr>
+          <a:xfrm>
+            <a:off x="548640" y="5321808"/>
+            <a:ext cx="11155680" cy="1325880"/>
+          </a:xfrm>
+          <a:prstGeom prst="rect">
+            <a:avLst/>
+          </a:prstGeom>
+          <a:noFill/>
+        </p:spPr>
+        <p:txBody>
+          <a:bodyPr wrap="square" anchor="t">
+            <a:spAutoFit/>
+          </a:bodyPr>
+          <a:lstStyle/>
+          <a:p>
+            <a:pPr algn="l">
+              <a:spcBef>
+                <a:spcPts val="0"/>
+              </a:spcBef>
+              <a:spcAft>
+                <a:spcPts val="400"/>
+              </a:spcAft>
+            </a:pPr>
+            <a:r>
+              <a:rPr sz="1500" b="1">
+                <a:solidFill>
+                  <a:srgbClr val="2563EB"/>
+                </a:solidFill>
+                <a:latin typeface="Calibri"/>
+              </a:rPr>
+              <a:t>À retenir : </a:t>
+            </a:r>
+            <a:r>
+              <a:rPr sz="1500" b="0">
+                <a:solidFill>
+                  <a:srgbClr val="1A2B4A"/>
+                </a:solidFill>
+                <a:latin typeface="Calibri"/>
+              </a:rPr>
+              <a:t>la cible n'est pas utilisée pour construire les groupes — elle ne sert qu'à interpréter après coup. Malgré 70 % d'information perdue, une structure nette apparaît, expliquée par le poste des joueurs.</a:t>
+            </a:r>
+          </a:p>
+        </p:txBody>
+      </p:sp>
+    </p:spTree>
+  </p:cSld>
+  <p:clrMapOvr>
+    <a:masterClrMapping/>
+  </p:clrMapOvr>
+</p:sld>
+</file>
+
+<file path=ppt/slides/slide14.xml><?xml version="1.0" encoding="utf-8"?>
+<p:sld xmlns:a="http://schemas.openxmlformats.org/drawingml/2006/main" xmlns:p="http://schemas.openxmlformats.org/presentationml/2006/main" xmlns:r="http://schemas.openxmlformats.org/officeDocument/2006/relationships">
+  <p:cSld>
+    <p:spTree>
+      <p:nvGrpSpPr>
+        <p:cNvPr id="1" name=""/>
+        <p:cNvGrpSpPr/>
+        <p:nvPr/>
+      </p:nvGrpSpPr>
+      <p:grpSpPr/>
+      <p:sp>
+        <p:nvSpPr>
+          <p:cNvPr id="2" name="Rectangle 1"/>
+          <p:cNvSpPr/>
+          <p:nvPr/>
+        </p:nvSpPr>
+        <p:spPr>
+          <a:xfrm>
+            <a:off x="0" y="0"/>
+            <a:ext cx="12191695" cy="1051560"/>
+          </a:xfrm>
+          <a:prstGeom prst="rect">
+            <a:avLst/>
+          </a:prstGeom>
+          <a:solidFill>
+            <a:srgbClr val="1A2B4A"/>
+          </a:solidFill>
+          <a:ln>
+            <a:noFill/>
+          </a:ln>
+          <a:effectLst/>
+        </p:spPr>
+        <p:style>
+          <a:lnRef idx="1">
+            <a:schemeClr val="accent1"/>
+          </a:lnRef>
+          <a:fillRef idx="3">
+            <a:schemeClr val="accent1"/>
+          </a:fillRef>
+          <a:effectRef idx="2">
+            <a:schemeClr val="accent1"/>
+          </a:effectRef>
+          <a:fontRef idx="minor">
+            <a:schemeClr val="lt1"/>
+          </a:fontRef>
+        </p:style>
+        <p:txBody>
+          <a:bodyPr rtlCol="0" anchor="ctr"/>
+          <a:lstStyle/>
+          <a:p>
+            <a:pPr algn="ctr"/>
+          </a:p>
+        </p:txBody>
+      </p:sp>
+      <p:sp>
+        <p:nvSpPr>
+          <p:cNvPr id="3" name="Rectangle 2"/>
+          <p:cNvSpPr/>
+          <p:nvPr/>
+        </p:nvSpPr>
+        <p:spPr>
+          <a:xfrm>
+            <a:off x="0" y="1051560"/>
+            <a:ext cx="12191695" cy="50800"/>
+          </a:xfrm>
+          <a:prstGeom prst="rect">
+            <a:avLst/>
+          </a:prstGeom>
+          <a:solidFill>
+            <a:srgbClr val="2563EB"/>
+          </a:solidFill>
+          <a:ln>
+            <a:noFill/>
+          </a:ln>
+          <a:effectLst/>
+        </p:spPr>
+        <p:style>
+          <a:lnRef idx="1">
+            <a:schemeClr val="accent1"/>
+          </a:lnRef>
+          <a:fillRef idx="3">
+            <a:schemeClr val="accent1"/>
+          </a:fillRef>
+          <a:effectRef idx="2">
+            <a:schemeClr val="accent1"/>
+          </a:effectRef>
+          <a:fontRef idx="minor">
+            <a:schemeClr val="lt1"/>
+          </a:fontRef>
+        </p:style>
+        <p:txBody>
+          <a:bodyPr rtlCol="0" anchor="ctr"/>
+          <a:lstStyle/>
+          <a:p>
+            <a:pPr algn="ctr"/>
+          </a:p>
+        </p:txBody>
+      </p:sp>
+      <p:sp>
+        <p:nvSpPr>
+          <p:cNvPr id="4" name="TextBox 3"/>
+          <p:cNvSpPr txBox="1"/>
+          <p:nvPr/>
+        </p:nvSpPr>
+        <p:spPr>
+          <a:xfrm>
+            <a:off x="548640" y="109728"/>
+            <a:ext cx="10972800" cy="365760"/>
+          </a:xfrm>
+          <a:prstGeom prst="rect">
+            <a:avLst/>
+          </a:prstGeom>
+          <a:noFill/>
+        </p:spPr>
+        <p:txBody>
+          <a:bodyPr wrap="square" anchor="t">
+            <a:spAutoFit/>
+          </a:bodyPr>
+          <a:lstStyle/>
+          <a:p>
+            <a:pPr algn="l">
+              <a:spcBef>
+                <a:spcPts val="0"/>
+              </a:spcBef>
+              <a:spcAft>
+                <a:spcPts val="600"/>
+              </a:spcAft>
+            </a:pPr>
+            <a:r>
+              <a:rPr sz="1300" b="1">
+                <a:solidFill>
+                  <a:srgbClr val="9DB8E8"/>
+                </a:solidFill>
+                <a:latin typeface="Calibri"/>
+              </a:rPr>
+              <a:t>PARTIE 3 — CLUSTERING</a:t>
+            </a:r>
+          </a:p>
+        </p:txBody>
+      </p:sp>
+      <p:sp>
+        <p:nvSpPr>
+          <p:cNvPr id="5" name="TextBox 4"/>
+          <p:cNvSpPr txBox="1"/>
+          <p:nvPr/>
+        </p:nvSpPr>
+        <p:spPr>
+          <a:xfrm>
+            <a:off x="548640" y="384048"/>
+            <a:ext cx="11155680" cy="640080"/>
+          </a:xfrm>
+          <a:prstGeom prst="rect">
+            <a:avLst/>
+          </a:prstGeom>
+          <a:noFill/>
+        </p:spPr>
+        <p:txBody>
+          <a:bodyPr wrap="square" anchor="t">
+            <a:spAutoFit/>
+          </a:bodyPr>
+          <a:lstStyle/>
+          <a:p>
+            <a:pPr algn="l">
+              <a:spcBef>
+                <a:spcPts val="0"/>
+              </a:spcBef>
+              <a:spcAft>
+                <a:spcPts val="600"/>
+              </a:spcAft>
+            </a:pPr>
+            <a:r>
+              <a:rPr sz="2600" b="1">
+                <a:solidFill>
+                  <a:srgbClr val="FFFFFF"/>
+                </a:solidFill>
+                <a:latin typeface="Calibri"/>
+              </a:rPr>
+              <a:t>KMeans vs DBSCAN</a:t>
+            </a:r>
+          </a:p>
+        </p:txBody>
+      </p:sp>
+      <p:pic>
+        <p:nvPicPr>
+          <p:cNvPr id="6" name="Picture 5" descr="kmeans_clusters.png"/>
+          <p:cNvPicPr>
+            <a:picLocks noChangeAspect="1"/>
+          </p:cNvPicPr>
+          <p:nvPr/>
+        </p:nvPicPr>
+        <p:blipFill>
+          <a:blip r:embed="rId2"/>
+          <a:stretch>
+            <a:fillRect/>
+          </a:stretch>
+        </p:blipFill>
+        <p:spPr>
+          <a:xfrm>
+            <a:off x="1151674" y="1325880"/>
+            <a:ext cx="4097452" cy="3200400"/>
+          </a:xfrm>
+          <a:prstGeom prst="rect">
+            <a:avLst/>
+          </a:prstGeom>
+        </p:spPr>
+      </p:pic>
+      <p:pic>
+        <p:nvPicPr>
+          <p:cNvPr id="7" name="Picture 6" descr="dbscan_clusters.png"/>
+          <p:cNvPicPr>
+            <a:picLocks noChangeAspect="1"/>
+          </p:cNvPicPr>
+          <p:nvPr/>
+        </p:nvPicPr>
+        <p:blipFill>
+          <a:blip r:embed="rId3"/>
+          <a:stretch>
+            <a:fillRect/>
+          </a:stretch>
+        </p:blipFill>
+        <p:spPr>
+          <a:xfrm>
+            <a:off x="6820954" y="1325880"/>
+            <a:ext cx="4097452" cy="3200400"/>
+          </a:xfrm>
+          <a:prstGeom prst="rect">
+            <a:avLst/>
+          </a:prstGeom>
+        </p:spPr>
+      </p:pic>
+      <p:sp>
+        <p:nvSpPr>
+          <p:cNvPr id="8" name="TextBox 7"/>
+          <p:cNvSpPr txBox="1"/>
+          <p:nvPr/>
+        </p:nvSpPr>
+        <p:spPr>
+          <a:xfrm>
+            <a:off x="640080" y="4617720"/>
+            <a:ext cx="5120640" cy="365760"/>
+          </a:xfrm>
+          <a:prstGeom prst="rect">
+            <a:avLst/>
+          </a:prstGeom>
+          <a:noFill/>
+        </p:spPr>
+        <p:txBody>
+          <a:bodyPr wrap="square" anchor="t">
+            <a:spAutoFit/>
+          </a:bodyPr>
+          <a:lstStyle/>
+          <a:p>
+            <a:pPr algn="ctr">
+              <a:spcBef>
+                <a:spcPts val="0"/>
+              </a:spcBef>
+              <a:spcAft>
+                <a:spcPts val="600"/>
+              </a:spcAft>
+            </a:pPr>
+            <a:r>
+              <a:rPr sz="1100" b="0">
+                <a:solidFill>
+                  <a:srgbClr val="555555"/>
+                </a:solidFill>
+                <a:latin typeface="Calibri"/>
+              </a:rPr>
+              <a:t>KMeans (k=4) — silhouette 0,135 : groupes chevauchants</a:t>
+            </a:r>
+          </a:p>
+        </p:txBody>
+      </p:sp>
+      <p:sp>
+        <p:nvSpPr>
+          <p:cNvPr id="9" name="TextBox 8"/>
+          <p:cNvSpPr txBox="1"/>
+          <p:nvPr/>
+        </p:nvSpPr>
+        <p:spPr>
+          <a:xfrm>
+            <a:off x="6309360" y="4617720"/>
+            <a:ext cx="5120640" cy="365760"/>
+          </a:xfrm>
+          <a:prstGeom prst="rect">
+            <a:avLst/>
+          </a:prstGeom>
+          <a:noFill/>
+        </p:spPr>
+        <p:txBody>
+          <a:bodyPr wrap="square" anchor="t">
+            <a:spAutoFit/>
+          </a:bodyPr>
+          <a:lstStyle/>
+          <a:p>
+            <a:pPr algn="ctr">
+              <a:spcBef>
+                <a:spcPts val="0"/>
+              </a:spcBef>
+              <a:spcAft>
+                <a:spcPts val="600"/>
+              </a:spcAft>
+            </a:pPr>
+            <a:r>
+              <a:rPr sz="1100" b="0">
+                <a:solidFill>
+                  <a:srgbClr val="555555"/>
+                </a:solidFill>
+                <a:latin typeface="Calibri"/>
+              </a:rPr>
+              <a:t>DBSCAN — 2 clusters nets + 27 points de bruit</a:t>
+            </a:r>
+          </a:p>
+        </p:txBody>
+      </p:sp>
+      <p:sp>
+        <p:nvSpPr>
+          <p:cNvPr id="10" name="TextBox 9"/>
+          <p:cNvSpPr txBox="1"/>
+          <p:nvPr/>
+        </p:nvSpPr>
+        <p:spPr>
+          <a:xfrm>
+            <a:off x="640080" y="5074920"/>
+            <a:ext cx="11064240" cy="1554480"/>
+          </a:xfrm>
+          <a:prstGeom prst="rect">
+            <a:avLst/>
+          </a:prstGeom>
+          <a:noFill/>
+        </p:spPr>
+        <p:txBody>
+          <a:bodyPr wrap="square" anchor="t">
+            <a:spAutoFit/>
+          </a:bodyPr>
+          <a:lstStyle/>
+          <a:p>
+            <a:pPr algn="l">
+              <a:spcBef>
+                <a:spcPts val="0"/>
+              </a:spcBef>
+              <a:spcAft>
+                <a:spcPts val="500"/>
+              </a:spcAft>
+            </a:pPr>
+            <a:r>
+              <a:rPr sz="1500" b="0">
+                <a:solidFill>
+                  <a:srgbClr val="1A2B4A"/>
+                </a:solidFill>
+                <a:latin typeface="Calibri"/>
+              </a:rPr>
+              <a:t>KMeans cherche des groupes convexes de taille comparable : il ne retrouve pas les postes réels. DBSCAN raisonne par densité et isole 2 clusters nets.</a:t>
+            </a:r>
+          </a:p>
+          <a:p>
+            <a:pPr algn="l">
+              <a:spcBef>
+                <a:spcPts val="0"/>
+              </a:spcBef>
+              <a:spcAft>
+                <a:spcPts val="500"/>
+              </a:spcAft>
+            </a:pPr>
+            <a:r>
+              <a:rPr sz="1500" b="1">
+                <a:solidFill>
+                  <a:srgbClr val="1A2B4A"/>
+                </a:solidFill>
+                <a:latin typeface="Calibri"/>
+              </a:rPr>
+              <a:t>Le cluster isolé est 3× plus riche en gardiens (18,2 % contre 6,7 %) — mais le taux de cartons y est quasi identique (9,9 % vs 9,6 %) : la structure reflète le poste, pas les cartons.</a:t>
+            </a:r>
+          </a:p>
+        </p:txBody>
+      </p:sp>
+    </p:spTree>
+  </p:cSld>
+  <p:clrMapOvr>
+    <a:masterClrMapping/>
+  </p:clrMapOvr>
+</p:sld>
+</file>
+
+<file path=ppt/slides/slide15.xml><?xml version="1.0" encoding="utf-8"?>
+<p:sld xmlns:a="http://schemas.openxmlformats.org/drawingml/2006/main" xmlns:p="http://schemas.openxmlformats.org/presentationml/2006/main" xmlns:r="http://schemas.openxmlformats.org/officeDocument/2006/relationships">
+  <p:cSld>
+    <p:spTree>
+      <p:nvGrpSpPr>
+        <p:cNvPr id="1" name=""/>
+        <p:cNvGrpSpPr/>
+        <p:nvPr/>
+      </p:nvGrpSpPr>
+      <p:grpSpPr/>
+      <p:sp>
+        <p:nvSpPr>
+          <p:cNvPr id="2" name="Rectangle 1"/>
+          <p:cNvSpPr/>
+          <p:nvPr/>
+        </p:nvSpPr>
+        <p:spPr>
+          <a:xfrm>
+            <a:off x="0" y="0"/>
+            <a:ext cx="12191695" cy="1051560"/>
+          </a:xfrm>
+          <a:prstGeom prst="rect">
+            <a:avLst/>
+          </a:prstGeom>
+          <a:solidFill>
+            <a:srgbClr val="1A2B4A"/>
+          </a:solidFill>
+          <a:ln>
+            <a:noFill/>
+          </a:ln>
+          <a:effectLst/>
+        </p:spPr>
+        <p:style>
+          <a:lnRef idx="1">
+            <a:schemeClr val="accent1"/>
+          </a:lnRef>
+          <a:fillRef idx="3">
+            <a:schemeClr val="accent1"/>
+          </a:fillRef>
+          <a:effectRef idx="2">
+            <a:schemeClr val="accent1"/>
+          </a:effectRef>
+          <a:fontRef idx="minor">
+            <a:schemeClr val="lt1"/>
+          </a:fontRef>
+        </p:style>
+        <p:txBody>
+          <a:bodyPr rtlCol="0" anchor="ctr"/>
+          <a:lstStyle/>
+          <a:p>
+            <a:pPr algn="ctr"/>
+          </a:p>
+        </p:txBody>
+      </p:sp>
+      <p:sp>
+        <p:nvSpPr>
+          <p:cNvPr id="3" name="Rectangle 2"/>
+          <p:cNvSpPr/>
+          <p:nvPr/>
+        </p:nvSpPr>
+        <p:spPr>
+          <a:xfrm>
+            <a:off x="0" y="1051560"/>
+            <a:ext cx="12191695" cy="50800"/>
+          </a:xfrm>
+          <a:prstGeom prst="rect">
+            <a:avLst/>
+          </a:prstGeom>
+          <a:solidFill>
+            <a:srgbClr val="2563EB"/>
+          </a:solidFill>
+          <a:ln>
+            <a:noFill/>
+          </a:ln>
+          <a:effectLst/>
+        </p:spPr>
+        <p:style>
+          <a:lnRef idx="1">
+            <a:schemeClr val="accent1"/>
+          </a:lnRef>
+          <a:fillRef idx="3">
+            <a:schemeClr val="accent1"/>
+          </a:fillRef>
+          <a:effectRef idx="2">
+            <a:schemeClr val="accent1"/>
+          </a:effectRef>
+          <a:fontRef idx="minor">
+            <a:schemeClr val="lt1"/>
+          </a:fontRef>
+        </p:style>
+        <p:txBody>
+          <a:bodyPr rtlCol="0" anchor="ctr"/>
+          <a:lstStyle/>
+          <a:p>
+            <a:pPr algn="ctr"/>
+          </a:p>
+        </p:txBody>
+      </p:sp>
+      <p:sp>
+        <p:nvSpPr>
+          <p:cNvPr id="4" name="TextBox 3"/>
+          <p:cNvSpPr txBox="1"/>
+          <p:nvPr/>
+        </p:nvSpPr>
+        <p:spPr>
+          <a:xfrm>
+            <a:off x="548640" y="109728"/>
+            <a:ext cx="10972800" cy="365760"/>
+          </a:xfrm>
+          <a:prstGeom prst="rect">
+            <a:avLst/>
+          </a:prstGeom>
+          <a:noFill/>
+        </p:spPr>
+        <p:txBody>
+          <a:bodyPr wrap="square" anchor="t">
+            <a:spAutoFit/>
+          </a:bodyPr>
+          <a:lstStyle/>
+          <a:p>
+            <a:pPr algn="l">
+              <a:spcBef>
+                <a:spcPts val="0"/>
+              </a:spcBef>
+              <a:spcAft>
+                <a:spcPts val="600"/>
+              </a:spcAft>
+            </a:pPr>
+            <a:r>
+              <a:rPr sz="1300" b="1">
+                <a:solidFill>
+                  <a:srgbClr val="9DB8E8"/>
+                </a:solidFill>
+                <a:latin typeface="Calibri"/>
+              </a:rPr>
+              <a:t>CONCLUSION</a:t>
+            </a:r>
+          </a:p>
+        </p:txBody>
+      </p:sp>
+      <p:sp>
+        <p:nvSpPr>
+          <p:cNvPr id="5" name="TextBox 4"/>
+          <p:cNvSpPr txBox="1"/>
+          <p:nvPr/>
+        </p:nvSpPr>
+        <p:spPr>
+          <a:xfrm>
+            <a:off x="548640" y="384048"/>
+            <a:ext cx="11155680" cy="640080"/>
+          </a:xfrm>
+          <a:prstGeom prst="rect">
+            <a:avLst/>
+          </a:prstGeom>
+          <a:noFill/>
+        </p:spPr>
+        <p:txBody>
+          <a:bodyPr wrap="square" anchor="t">
+            <a:spAutoFit/>
+          </a:bodyPr>
+          <a:lstStyle/>
+          <a:p>
+            <a:pPr algn="l">
+              <a:spcBef>
+                <a:spcPts val="0"/>
+              </a:spcBef>
+              <a:spcAft>
+                <a:spcPts val="600"/>
+              </a:spcAft>
+            </a:pPr>
+            <a:r>
+              <a:rPr sz="2600" b="1">
+                <a:solidFill>
+                  <a:srgbClr val="FFFFFF"/>
+                </a:solidFill>
+                <a:latin typeface="Calibri"/>
+              </a:rPr>
+              <a:t>Quatre approches, un même constat</a:t>
+            </a:r>
+          </a:p>
+        </p:txBody>
+      </p:sp>
+      <p:sp>
+        <p:nvSpPr>
+          <p:cNvPr id="6" name="TextBox 5"/>
+          <p:cNvSpPr txBox="1"/>
+          <p:nvPr/>
+        </p:nvSpPr>
+        <p:spPr>
+          <a:xfrm>
+            <a:off x="548640" y="1280160"/>
+            <a:ext cx="11247120" cy="3931920"/>
+          </a:xfrm>
+          <a:prstGeom prst="rect">
+            <a:avLst/>
+          </a:prstGeom>
+          <a:noFill/>
+        </p:spPr>
+        <p:txBody>
+          <a:bodyPr wrap="square" anchor="t">
+            <a:spAutoFit/>
+          </a:bodyPr>
+          <a:lstStyle/>
+          <a:p>
+            <a:pPr algn="l">
+              <a:spcBef>
+                <a:spcPts val="0"/>
+              </a:spcBef>
+              <a:spcAft>
+                <a:spcPts val="900"/>
+              </a:spcAft>
+            </a:pPr>
+            <a:r>
+              <a:rPr sz="1550" b="0">
+                <a:solidFill>
+                  <a:srgbClr val="1A2B4A"/>
+                </a:solidFill>
+                <a:latin typeface="Calibri"/>
+              </a:rPr>
+              <a:t>•  Corrélation : aucune variable au-dessus de |0,04|.</a:t>
+            </a:r>
+          </a:p>
+          <a:p>
+            <a:pPr algn="l">
+              <a:spcBef>
+                <a:spcPts val="0"/>
+              </a:spcBef>
+              <a:spcAft>
+                <a:spcPts val="900"/>
+              </a:spcAft>
+            </a:pPr>
+            <a:r>
+              <a:rPr sz="1550" b="0">
+                <a:solidFill>
+                  <a:srgbClr val="1A2B4A"/>
+                </a:solidFill>
+                <a:latin typeface="Calibri"/>
+              </a:rPr>
+              <a:t>•  Modèles supervisés : AUC de 0,506 à 0,546, à peine mieux que le hasard.</a:t>
+            </a:r>
+          </a:p>
+          <a:p>
+            <a:pPr algn="l">
+              <a:spcBef>
+                <a:spcPts val="0"/>
+              </a:spcBef>
+              <a:spcAft>
+                <a:spcPts val="900"/>
+              </a:spcAft>
+            </a:pPr>
+            <a:r>
+              <a:rPr sz="1550" b="0">
+                <a:solidFill>
+                  <a:srgbClr val="1A2B4A"/>
+                </a:solidFill>
+                <a:latin typeface="Calibri"/>
+              </a:rPr>
+              <a:t>•  Permutation &amp; SHAP : effets individuels minuscules.</a:t>
+            </a:r>
+          </a:p>
+          <a:p>
+            <a:pPr algn="l">
+              <a:spcBef>
+                <a:spcPts val="0"/>
+              </a:spcBef>
+              <a:spcAft>
+                <a:spcPts val="900"/>
+              </a:spcAft>
+            </a:pPr>
+            <a:r>
+              <a:rPr sz="1550" b="0">
+                <a:solidFill>
+                  <a:srgbClr val="1A2B4A"/>
+                </a:solidFill>
+                <a:latin typeface="Calibri"/>
+              </a:rPr>
+              <a:t>•  Clustering : la structure reflète le poste, pas les cartons.</a:t>
+            </a:r>
+          </a:p>
+          <a:p>
+            <a:pPr algn="l">
+              <a:spcBef>
+                <a:spcPts val="0"/>
+              </a:spcBef>
+              <a:spcAft>
+                <a:spcPts val="900"/>
+              </a:spcAft>
+            </a:pPr>
+            <a:r>
+              <a:rPr sz="1550" b="0">
+                <a:solidFill>
+                  <a:srgbClr val="1A2B4A"/>
+                </a:solidFill>
+                <a:latin typeface="Calibri"/>
+              </a:rPr>
+              <a:t>•  → Les cartons jaunes ne sont pas prédictibles à partir de ces variables.</a:t>
+            </a:r>
+          </a:p>
+          <a:p>
+            <a:pPr algn="l">
+              <a:spcBef>
+                <a:spcPts val="0"/>
+              </a:spcBef>
+              <a:spcAft>
+                <a:spcPts val="900"/>
+              </a:spcAft>
+            </a:pPr>
+            <a:r>
+              <a:rPr sz="1400" b="0">
+                <a:solidFill>
+                  <a:srgbClr val="555555"/>
+                </a:solidFill>
+                <a:latin typeface="Calibri"/>
+              </a:rPr>
+              <a:t>–  La convergence de 4 méthodes différentes rend le constat solide : ce n'est pas un modèle mal réglé.</a:t>
+            </a:r>
+          </a:p>
+          <a:p>
+            <a:pPr algn="l">
+              <a:spcBef>
+                <a:spcPts val="0"/>
+              </a:spcBef>
+              <a:spcAft>
+                <a:spcPts val="900"/>
+              </a:spcAft>
+            </a:pPr>
+            <a:r>
+              <a:rPr sz="1400" b="0">
+                <a:solidFill>
+                  <a:srgbClr val="555555"/>
+                </a:solidFill>
+                <a:latin typeface="Calibri"/>
+              </a:rPr>
+              <a:t>–  Facteurs probables absents du dataset : décision de l'arbitre, contexte et tension du match.</a:t>
+            </a:r>
+          </a:p>
+        </p:txBody>
+      </p:sp>
+      <p:sp>
+        <p:nvSpPr>
+          <p:cNvPr id="7" name="TextBox 6"/>
+          <p:cNvSpPr txBox="1"/>
+          <p:nvPr/>
+        </p:nvSpPr>
+        <p:spPr>
+          <a:xfrm>
+            <a:off x="548640" y="5257800"/>
+            <a:ext cx="11155680" cy="1188720"/>
+          </a:xfrm>
+          <a:prstGeom prst="rect">
+            <a:avLst/>
+          </a:prstGeom>
+          <a:noFill/>
+        </p:spPr>
+        <p:txBody>
+          <a:bodyPr wrap="square" anchor="t">
+            <a:spAutoFit/>
+          </a:bodyPr>
+          <a:lstStyle/>
+          <a:p>
+            <a:pPr algn="ctr">
+              <a:spcBef>
+                <a:spcPts val="0"/>
+              </a:spcBef>
+              <a:spcAft>
+                <a:spcPts val="600"/>
+              </a:spcAft>
+            </a:pPr>
+            <a:r>
+              <a:rPr sz="1400" b="0">
+                <a:solidFill>
+                  <a:srgbClr val="555555"/>
+                </a:solidFill>
+                <a:latin typeface="Calibri"/>
+              </a:rPr>
+              <a:t>Pipeline ré-exécuté indépendamment : tous les chiffres sont reproduits à l'identique.</a:t>
+            </a:r>
+          </a:p>
+          <a:p>
+            <a:pPr algn="ctr">
+              <a:spcBef>
+                <a:spcPts val="0"/>
+              </a:spcBef>
+              <a:spcAft>
+                <a:spcPts val="600"/>
+              </a:spcAft>
+            </a:pPr>
+            <a:r>
               <a:rPr sz="1600" b="1">
                 <a:solidFill>
                   <a:srgbClr val="2563EB"/>
                 </a:solidFill>
                 <a:latin typeface="Calibri"/>
               </a:rPr>
-              <a:t>Un score faible + une démarche rigoureuse = un résultat de data science parfaitement valable.</a:t>
+              <a:t>Un faible pouvoir prédictif, établi rigoureusement et interprété lucidement, reste un résultat valable.</a:t>
             </a:r>
           </a:p>
         </p:txBody>
@@ -4367,21 +5673,45 @@
                 </a:solidFill>
                 <a:latin typeface="Calibri"/>
               </a:rPr>
-              <a:t>Données et objectif</a:t>
-            </a:r>
-          </a:p>
-        </p:txBody>
-      </p:sp>
-      <p:sp>
-        <p:nvSpPr>
-          <p:cNvPr id="6" name="TextBox 5"/>
+              <a:t>Un jeu de données très déséquilibré</a:t>
+            </a:r>
+          </a:p>
+        </p:txBody>
+      </p:sp>
+      <p:pic>
+        <p:nvPicPr>
+          <p:cNvPr id="6" name="Picture 5" descr="repartition_classes.png"/>
+          <p:cNvPicPr>
+            <a:picLocks noChangeAspect="1"/>
+          </p:cNvPicPr>
+          <p:nvPr/>
+        </p:nvPicPr>
+        <p:blipFill>
+          <a:blip r:embed="rId2"/>
+          <a:stretch>
+            <a:fillRect/>
+          </a:stretch>
+        </p:blipFill>
+        <p:spPr>
+          <a:xfrm>
+            <a:off x="640080" y="1371600"/>
+            <a:ext cx="5669280" cy="3748742"/>
+          </a:xfrm>
+          <a:prstGeom prst="rect">
+            <a:avLst/>
+          </a:prstGeom>
+        </p:spPr>
+      </p:pic>
+      <p:sp>
+        <p:nvSpPr>
+          <p:cNvPr id="7" name="TextBox 6"/>
           <p:cNvSpPr txBox="1"/>
           <p:nvPr/>
         </p:nvSpPr>
         <p:spPr>
           <a:xfrm>
-            <a:off x="640080" y="1371600"/>
-            <a:ext cx="10972800" cy="4937760"/>
+            <a:off x="6675120" y="1554480"/>
+            <a:ext cx="4937760" cy="4572000"/>
           </a:xfrm>
           <a:prstGeom prst="rect">
             <a:avLst/>
@@ -4399,17 +5729,36 @@
                 <a:spcPts val="0"/>
               </a:spcBef>
               <a:spcAft>
-                <a:spcPts val="1000"/>
-              </a:spcAft>
-            </a:pPr>
-            <a:r>
-              <a:rPr sz="1600" b="0">
+                <a:spcPts val="1100"/>
+              </a:spcAft>
+            </a:pPr>
+            <a:r>
+              <a:rPr sz="1800" b="1">
+                <a:solidFill>
+                  <a:srgbClr val="2563EB"/>
+                </a:solidFill>
+                <a:latin typeface="Calibri"/>
+              </a:rPr>
+              <a:t>Le fil rouge du projet</a:t>
+            </a:r>
+          </a:p>
+          <a:p>
+            <a:pPr algn="l">
+              <a:spcBef>
+                <a:spcPts val="0"/>
+              </a:spcBef>
+              <a:spcAft>
+                <a:spcPts val="1100"/>
+              </a:spcAft>
+            </a:pPr>
+            <a:r>
+              <a:rPr sz="1500" b="0">
                 <a:solidFill>
                   <a:srgbClr val="1A2B4A"/>
                 </a:solidFill>
                 <a:latin typeface="Calibri"/>
               </a:rPr>
-              <a:t>•  Objectif : prédire si un joueur reçoit un carton jaune lors d'un match.</a:t>
+              <a:t>La cible yellow_cards vaut 1 dans seulement 9,8 % des cas.</a:t>
             </a:r>
           </a:p>
           <a:p>
@@ -4418,17 +5767,17 @@
                 <a:spcPts val="0"/>
               </a:spcBef>
               <a:spcAft>
-                <a:spcPts val="1000"/>
-              </a:spcAft>
-            </a:pPr>
-            <a:r>
-              <a:rPr sz="1600" b="0">
+                <a:spcPts val="1100"/>
+              </a:spcAft>
+            </a:pPr>
+            <a:r>
+              <a:rPr sz="1500" b="1">
                 <a:solidFill>
                   <a:srgbClr val="1A2B4A"/>
                 </a:solidFill>
                 <a:latin typeface="Calibri"/>
               </a:rPr>
-              <a:t>•  Dataset : 54 600 lignes × 75 colonnes, 1 248 joueurs, 0 valeur manquante.</a:t>
+              <a:t>Conséquence : l'accuracy est trompeuse.</a:t>
             </a:r>
           </a:p>
           <a:p>
@@ -4437,17 +5786,17 @@
                 <a:spcPts val="0"/>
               </a:spcBef>
               <a:spcAft>
-                <a:spcPts val="1000"/>
-              </a:spcAft>
-            </a:pPr>
-            <a:r>
-              <a:rPr sz="1400" b="0">
-                <a:solidFill>
-                  <a:srgbClr val="555555"/>
-                </a:solidFill>
-                <a:latin typeface="Calibri"/>
-              </a:rPr>
-              <a:t>–  Cible yellow_cards déséquilibrée : ~90 % de 0, ~10 % de 1.</a:t>
+                <a:spcPts val="1100"/>
+              </a:spcAft>
+            </a:pPr>
+            <a:r>
+              <a:rPr sz="1500" b="0">
+                <a:solidFill>
+                  <a:srgbClr val="1A2B4A"/>
+                </a:solidFill>
+                <a:latin typeface="Calibri"/>
+              </a:rPr>
+              <a:t>Un modèle qui prédirait toujours « pas de carton » obtiendrait déjà 90,2 % d'accuracy — sans rien apprendre.</a:t>
             </a:r>
           </a:p>
           <a:p>
@@ -4456,112 +5805,17 @@
                 <a:spcPts val="0"/>
               </a:spcBef>
               <a:spcAft>
-                <a:spcPts val="1000"/>
-              </a:spcAft>
-            </a:pPr>
-            <a:r>
-              <a:rPr sz="1600" b="0">
-                <a:solidFill>
-                  <a:srgbClr val="1A2B4A"/>
-                </a:solidFill>
-                <a:latin typeface="Calibri"/>
-              </a:rPr>
-              <a:t>•  Conséquence clé : l'accuracy est trompeuse.</a:t>
-            </a:r>
-          </a:p>
-          <a:p>
-            <a:pPr algn="l">
-              <a:spcBef>
-                <a:spcPts val="0"/>
-              </a:spcBef>
-              <a:spcAft>
-                <a:spcPts val="1000"/>
-              </a:spcAft>
-            </a:pPr>
-            <a:r>
-              <a:rPr sz="1400" b="0">
-                <a:solidFill>
-                  <a:srgbClr val="555555"/>
-                </a:solidFill>
-                <a:latin typeface="Calibri"/>
-              </a:rPr>
-              <a:t>–  Un modèle « toujours 0 » atteint déjà ~90 % d'accuracy sans rien apprendre.</a:t>
-            </a:r>
-          </a:p>
-          <a:p>
-            <a:pPr algn="l">
-              <a:spcBef>
-                <a:spcPts val="0"/>
-              </a:spcBef>
-              <a:spcAft>
-                <a:spcPts val="1000"/>
-              </a:spcAft>
-            </a:pPr>
-            <a:r>
-              <a:rPr sz="1400" b="0">
-                <a:solidFill>
-                  <a:srgbClr val="555555"/>
-                </a:solidFill>
-                <a:latin typeface="Calibri"/>
-              </a:rPr>
-              <a:t>–  → Métrique retenue : le F1-score (équilibre précision / rappel).</a:t>
-            </a:r>
-          </a:p>
-          <a:p>
-            <a:pPr algn="l">
-              <a:spcBef>
-                <a:spcPts val="0"/>
-              </a:spcBef>
-              <a:spcAft>
-                <a:spcPts val="1000"/>
-              </a:spcAft>
-            </a:pPr>
-            <a:r>
-              <a:rPr sz="1600" b="0">
-                <a:solidFill>
-                  <a:srgbClr val="1A2B4A"/>
-                </a:solidFill>
-                <a:latin typeface="Calibri"/>
-              </a:rPr>
-              <a:t>•  Exploration : données propres, aucune valeur aberrante.</a:t>
-            </a:r>
-          </a:p>
-          <a:p>
-            <a:pPr algn="l">
-              <a:spcBef>
-                <a:spcPts val="0"/>
-              </a:spcBef>
-              <a:spcAft>
-                <a:spcPts val="1000"/>
-              </a:spcAft>
-            </a:pPr>
-            <a:r>
-              <a:rPr sz="1400" b="0">
-                <a:solidFill>
-                  <a:srgbClr val="555555"/>
-                </a:solidFill>
-                <a:latin typeface="Calibri"/>
-              </a:rPr>
-              <a:t>–  Corrélation de chaque variable avec la cible quasi nulle (&lt; 0,04).</a:t>
-            </a:r>
-          </a:p>
-          <a:p>
-            <a:pPr algn="l">
-              <a:spcBef>
-                <a:spcPts val="0"/>
-              </a:spcBef>
-              <a:spcAft>
-                <a:spcPts val="1000"/>
-              </a:spcAft>
-            </a:pPr>
-            <a:r>
-              <a:rPr sz="1400" b="0">
-                <a:solidFill>
-                  <a:srgbClr val="555555"/>
-                </a:solidFill>
-                <a:latin typeface="Calibri"/>
-              </a:rPr>
-              <a:t>–  → Problème difficile : il faudra des modèles captant des combinaisons de variables.</a:t>
+                <a:spcPts val="1100"/>
+              </a:spcAft>
+            </a:pPr>
+            <a:r>
+              <a:rPr sz="1500" b="1">
+                <a:solidFill>
+                  <a:srgbClr val="2563EB"/>
+                </a:solidFill>
+                <a:latin typeface="Calibri"/>
+              </a:rPr>
+              <a:t>→ On raisonne donc en précision / rappel / F1 tout au long du projet.</a:t>
             </a:r>
           </a:p>
         </p:txBody>
@@ -4709,7 +5963,7 @@
                 </a:solidFill>
                 <a:latin typeface="Calibri"/>
               </a:rPr>
-              <a:t>PRÉPARATION</a:t>
+              <a:t>EXPLORATION</a:t>
             </a:r>
           </a:p>
         </p:txBody>
@@ -4751,21 +6005,45 @@
                 </a:solidFill>
                 <a:latin typeface="Calibri"/>
               </a:rPr>
-              <a:t>Encodage &amp; séparation train / test</a:t>
-            </a:r>
-          </a:p>
-        </p:txBody>
-      </p:sp>
-      <p:sp>
-        <p:nvSpPr>
-          <p:cNvPr id="6" name="TextBox 5"/>
+              <a:t>Aucune variable n'est corrélée à la cible</a:t>
+            </a:r>
+          </a:p>
+        </p:txBody>
+      </p:sp>
+      <p:pic>
+        <p:nvPicPr>
+          <p:cNvPr id="6" name="Picture 5" descr="correlations_cible.png"/>
+          <p:cNvPicPr>
+            <a:picLocks noChangeAspect="1"/>
+          </p:cNvPicPr>
+          <p:nvPr/>
+        </p:nvPicPr>
+        <p:blipFill>
+          <a:blip r:embed="rId2"/>
+          <a:stretch>
+            <a:fillRect/>
+          </a:stretch>
+        </p:blipFill>
+        <p:spPr>
+          <a:xfrm>
+            <a:off x="548640" y="1325880"/>
+            <a:ext cx="6583680" cy="4828032"/>
+          </a:xfrm>
+          <a:prstGeom prst="rect">
+            <a:avLst/>
+          </a:prstGeom>
+        </p:spPr>
+      </p:pic>
+      <p:sp>
+        <p:nvSpPr>
+          <p:cNvPr id="7" name="TextBox 6"/>
           <p:cNvSpPr txBox="1"/>
           <p:nvPr/>
         </p:nvSpPr>
         <p:spPr>
           <a:xfrm>
-            <a:off x="640080" y="1371600"/>
-            <a:ext cx="10972800" cy="4937760"/>
+            <a:off x="7406640" y="1554480"/>
+            <a:ext cx="4297680" cy="4572000"/>
           </a:xfrm>
           <a:prstGeom prst="rect">
             <a:avLst/>
@@ -4783,17 +6061,36 @@
                 <a:spcPts val="0"/>
               </a:spcBef>
               <a:spcAft>
-                <a:spcPts val="1000"/>
-              </a:spcAft>
-            </a:pPr>
-            <a:r>
-              <a:rPr sz="1600" b="0">
+                <a:spcPts val="1100"/>
+              </a:spcAft>
+            </a:pPr>
+            <a:r>
+              <a:rPr sz="1800" b="1">
+                <a:solidFill>
+                  <a:srgbClr val="2563EB"/>
+                </a:solidFill>
+                <a:latin typeface="Calibri"/>
+              </a:rPr>
+              <a:t>Ce que ça dit</a:t>
+            </a:r>
+          </a:p>
+          <a:p>
+            <a:pPr algn="l">
+              <a:spcBef>
+                <a:spcPts val="0"/>
+              </a:spcBef>
+              <a:spcAft>
+                <a:spcPts val="1100"/>
+              </a:spcAft>
+            </a:pPr>
+            <a:r>
+              <a:rPr sz="1500" b="0">
                 <a:solidFill>
                   <a:srgbClr val="1A2B4A"/>
                 </a:solidFill>
                 <a:latin typeface="Calibri"/>
               </a:rPr>
-              <a:t>•  Variables exclues : identifiants (player_id, name, match_id, date, stade, ville)</a:t>
+              <a:t>Toutes les corrélations restent sous |0,04| : aucun lien linéaire exploitable.</a:t>
             </a:r>
           </a:p>
           <a:p>
@@ -4802,17 +6099,17 @@
                 <a:spcPts val="0"/>
               </a:spcBef>
               <a:spcAft>
-                <a:spcPts val="1000"/>
-              </a:spcAft>
-            </a:pPr>
-            <a:r>
-              <a:rPr sz="1400" b="0">
-                <a:solidFill>
-                  <a:srgbClr val="555555"/>
-                </a:solidFill>
-                <a:latin typeface="Calibri"/>
-              </a:rPr>
-              <a:t>–  et forte cardinalité (nationality, club_name, team, opponent_team).</a:t>
+                <a:spcPts val="1100"/>
+              </a:spcAft>
+            </a:pPr>
+            <a:r>
+              <a:rPr sz="1500" b="0">
+                <a:solidFill>
+                  <a:srgbClr val="1A2B4A"/>
+                </a:solidFill>
+                <a:latin typeface="Calibri"/>
+              </a:rPr>
+              <a:t>Mais une cohérence apparaît : les variables défensives (dégagements, tacles, interceptions) sont les seules du côté positif.</a:t>
             </a:r>
           </a:p>
           <a:p>
@@ -4821,93 +6118,17 @@
                 <a:spcPts val="0"/>
               </a:spcBef>
               <a:spcAft>
-                <a:spcPts val="1000"/>
-              </a:spcAft>
-            </a:pPr>
-            <a:r>
-              <a:rPr sz="1600" b="0">
+                <a:spcPts val="1100"/>
+              </a:spcAft>
+            </a:pPr>
+            <a:r>
+              <a:rPr sz="1500" b="0">
                 <a:solidFill>
                   <a:srgbClr val="1A2B4A"/>
                 </a:solidFill>
                 <a:latin typeface="Calibri"/>
               </a:rPr>
-              <a:t>•  Variables encodées en one-hot : position, preferred_foot, tournament_stage, match_result.</a:t>
-            </a:r>
-          </a:p>
-          <a:p>
-            <a:pPr algn="l">
-              <a:spcBef>
-                <a:spcPts val="0"/>
-              </a:spcBef>
-              <a:spcAft>
-                <a:spcPts val="1000"/>
-              </a:spcAft>
-            </a:pPr>
-            <a:r>
-              <a:rPr sz="1600" b="0">
-                <a:solidFill>
-                  <a:srgbClr val="1A2B4A"/>
-                </a:solidFill>
-                <a:latin typeface="Calibri"/>
-              </a:rPr>
-              <a:t>•  Séparation train / test PAR JOUEUR (et non ligne par ligne).</a:t>
-            </a:r>
-          </a:p>
-          <a:p>
-            <a:pPr algn="l">
-              <a:spcBef>
-                <a:spcPts val="0"/>
-              </a:spcBef>
-              <a:spcAft>
-                <a:spcPts val="1000"/>
-              </a:spcAft>
-            </a:pPr>
-            <a:r>
-              <a:rPr sz="1400" b="0">
-                <a:solidFill>
-                  <a:srgbClr val="555555"/>
-                </a:solidFill>
-                <a:latin typeface="Calibri"/>
-              </a:rPr>
-              <a:t>–  Un joueur apparaît ~44 fois → un split naïf mettrait le même joueur des deux côtés.</a:t>
-            </a:r>
-          </a:p>
-          <a:p>
-            <a:pPr algn="l">
-              <a:spcBef>
-                <a:spcPts val="0"/>
-              </a:spcBef>
-              <a:spcAft>
-                <a:spcPts val="1000"/>
-              </a:spcAft>
-            </a:pPr>
-            <a:r>
-              <a:rPr sz="1400" b="0">
-                <a:solidFill>
-                  <a:srgbClr val="555555"/>
-                </a:solidFill>
-                <a:latin typeface="Calibri"/>
-              </a:rPr>
-              <a:t>–  C'est une fuite de données : le modèle « reconnaîtrait » le joueur au lieu de généraliser.</a:t>
-            </a:r>
-          </a:p>
-          <a:p>
-            <a:pPr algn="l">
-              <a:spcBef>
-                <a:spcPts val="0"/>
-              </a:spcBef>
-              <a:spcAft>
-                <a:spcPts val="1000"/>
-              </a:spcAft>
-            </a:pPr>
-            <a:r>
-              <a:rPr sz="1400" b="0">
-                <a:solidFill>
-                  <a:srgbClr val="555555"/>
-                </a:solidFill>
-                <a:latin typeface="Calibri"/>
-              </a:rPr>
-              <a:t>–  Résultat : 43 726 lignes d'entraînement · 10 874 de test (joueurs inédits).</a:t>
+              <a:t>Ça ne condamne pas le projet : la corrélation ne voit que les liens simples. D'où le recours aux arbres, qui captent des combinaisons.</a:t>
             </a:r>
           </a:p>
         </p:txBody>
@@ -5055,7 +6276,7 @@
                 </a:solidFill>
                 <a:latin typeface="Calibri"/>
               </a:rPr>
-              <a:t>PARTIE 1 — SUPERVISÉ</a:t>
+              <a:t>PRÉPARATION</a:t>
             </a:r>
           </a:p>
         </p:txBody>
@@ -5097,7 +6318,7 @@
                 </a:solidFill>
                 <a:latin typeface="Calibri"/>
               </a:rPr>
-              <a:t>Trois modèles réglés par GridSearchCV</a:t>
+              <a:t>Encodage &amp; séparation train / test</a:t>
             </a:r>
           </a:p>
         </p:txBody>
@@ -5129,7 +6350,7 @@
                 <a:spcPts val="0"/>
               </a:spcBef>
               <a:spcAft>
-                <a:spcPts val="1000"/>
+                <a:spcPts val="900"/>
               </a:spcAft>
             </a:pPr>
             <a:r>
@@ -5139,7 +6360,7 @@
                 </a:solidFill>
                 <a:latin typeface="Calibri"/>
               </a:rPr>
-              <a:t>•  Arbre de décision · Forêt aléatoire · Gradient Boosting.</a:t>
+              <a:t>•  Exclus : identifiants (player_id, name, match_id, date, stade, ville)</a:t>
             </a:r>
           </a:p>
           <a:p>
@@ -5148,7 +6369,26 @@
                 <a:spcPts val="0"/>
               </a:spcBef>
               <a:spcAft>
-                <a:spcPts val="1000"/>
+                <a:spcPts val="900"/>
+              </a:spcAft>
+            </a:pPr>
+            <a:r>
+              <a:rPr sz="1450" b="0">
+                <a:solidFill>
+                  <a:srgbClr val="555555"/>
+                </a:solidFill>
+                <a:latin typeface="Calibri"/>
+              </a:rPr>
+              <a:t>–  et forte cardinalité : nationality (48), club_name (122), team, opponent_team.</a:t>
+            </a:r>
+          </a:p>
+          <a:p>
+            <a:pPr algn="l">
+              <a:spcBef>
+                <a:spcPts val="0"/>
+              </a:spcBef>
+              <a:spcAft>
+                <a:spcPts val="900"/>
               </a:spcAft>
             </a:pPr>
             <a:r>
@@ -5158,7 +6398,7 @@
                 </a:solidFill>
                 <a:latin typeface="Calibri"/>
               </a:rPr>
-              <a:t>•  GridSearchCV avec scoring = "f1", validation croisée, même jeu de test final.</a:t>
+              <a:t>•  Encodés en one-hot : position, preferred_foot, tournament_stage, match_result.</a:t>
             </a:r>
           </a:p>
           <a:p>
@@ -5167,7 +6407,7 @@
                 <a:spcPts val="0"/>
               </a:spcBef>
               <a:spcAft>
-                <a:spcPts val="1000"/>
+                <a:spcPts val="900"/>
               </a:spcAft>
             </a:pPr>
             <a:r>
@@ -5177,7 +6417,7 @@
                 </a:solidFill>
                 <a:latin typeface="Calibri"/>
               </a:rPr>
-              <a:t>•  Gestion du déséquilibre des classes :</a:t>
+              <a:t>•  Séparation train / test PAR JOUEUR — pas ligne par ligne.</a:t>
             </a:r>
           </a:p>
           <a:p>
@@ -5186,17 +6426,17 @@
                 <a:spcPts val="0"/>
               </a:spcBef>
               <a:spcAft>
-                <a:spcPts val="1000"/>
-              </a:spcAft>
-            </a:pPr>
-            <a:r>
-              <a:rPr sz="1400" b="0">
+                <a:spcPts val="900"/>
+              </a:spcAft>
+            </a:pPr>
+            <a:r>
+              <a:rPr sz="1450" b="0">
                 <a:solidFill>
                   <a:srgbClr val="555555"/>
                 </a:solidFill>
                 <a:latin typeface="Calibri"/>
               </a:rPr>
-              <a:t>–  Random Forest → class_weight = "balanced".</a:t>
+              <a:t>–  Un joueur apparaît ~44 fois : un split naïf le mettrait des deux côtés.</a:t>
             </a:r>
           </a:p>
           <a:p>
@@ -5205,17 +6445,17 @@
                 <a:spcPts val="0"/>
               </a:spcBef>
               <a:spcAft>
-                <a:spcPts val="1000"/>
-              </a:spcAft>
-            </a:pPr>
-            <a:r>
-              <a:rPr sz="1400" b="0">
+                <a:spcPts val="900"/>
+              </a:spcAft>
+            </a:pPr>
+            <a:r>
+              <a:rPr sz="1450" b="0">
                 <a:solidFill>
                   <a:srgbClr val="555555"/>
                 </a:solidFill>
                 <a:latin typeface="Calibri"/>
               </a:rPr>
-              <a:t>–  Gradient Boosting → sample_weight équilibré (pas de class_weight natif).</a:t>
+              <a:t>–  C'est une fuite de données — le modèle le reconnaîtrait au lieu de généraliser.</a:t>
             </a:r>
           </a:p>
           <a:p>
@@ -5224,36 +6464,17 @@
                 <a:spcPts val="0"/>
               </a:spcBef>
               <a:spcAft>
-                <a:spcPts val="1000"/>
-              </a:spcAft>
-            </a:pPr>
-            <a:r>
-              <a:rPr sz="1400" b="0">
+                <a:spcPts val="900"/>
+              </a:spcAft>
+            </a:pPr>
+            <a:r>
+              <a:rPr sz="1450" b="0">
                 <a:solidFill>
                   <a:srgbClr val="555555"/>
                 </a:solidFill>
                 <a:latin typeface="Calibri"/>
               </a:rPr>
-              <a:t>–  Sans cette correction, la forêt prédit toujours 0 → F1 = 0.</a:t>
-            </a:r>
-          </a:p>
-          <a:p>
-            <a:pPr algn="l">
-              <a:spcBef>
-                <a:spcPts val="0"/>
-              </a:spcBef>
-              <a:spcAft>
-                <a:spcPts val="1000"/>
-              </a:spcAft>
-            </a:pPr>
-            <a:r>
-              <a:rPr sz="1600" b="0">
-                <a:solidFill>
-                  <a:srgbClr val="1A2B4A"/>
-                </a:solidFill>
-                <a:latin typeface="Calibri"/>
-              </a:rPr>
-              <a:t>•  Astuce : n_jobs = -1 parallélise GridSearchCV sur tous les cœurs.</a:t>
+              <a:t>–  Résultat : 43 726 / 10 874 lignes, et zéro joueur en commun (vérifié).</a:t>
             </a:r>
           </a:p>
         </p:txBody>
@@ -5401,6 +6622,352 @@
                 </a:solidFill>
                 <a:latin typeface="Calibri"/>
               </a:rPr>
+              <a:t>PARTIE 1 — SUPERVISÉ</a:t>
+            </a:r>
+          </a:p>
+        </p:txBody>
+      </p:sp>
+      <p:sp>
+        <p:nvSpPr>
+          <p:cNvPr id="5" name="TextBox 4"/>
+          <p:cNvSpPr txBox="1"/>
+          <p:nvPr/>
+        </p:nvSpPr>
+        <p:spPr>
+          <a:xfrm>
+            <a:off x="548640" y="384048"/>
+            <a:ext cx="11155680" cy="640080"/>
+          </a:xfrm>
+          <a:prstGeom prst="rect">
+            <a:avLst/>
+          </a:prstGeom>
+          <a:noFill/>
+        </p:spPr>
+        <p:txBody>
+          <a:bodyPr wrap="square" anchor="t">
+            <a:spAutoFit/>
+          </a:bodyPr>
+          <a:lstStyle/>
+          <a:p>
+            <a:pPr algn="l">
+              <a:spcBef>
+                <a:spcPts val="0"/>
+              </a:spcBef>
+              <a:spcAft>
+                <a:spcPts val="600"/>
+              </a:spcAft>
+            </a:pPr>
+            <a:r>
+              <a:rPr sz="2600" b="1">
+                <a:solidFill>
+                  <a:srgbClr val="FFFFFF"/>
+                </a:solidFill>
+                <a:latin typeface="Calibri"/>
+              </a:rPr>
+              <a:t>Trois modèles réglés par GridSearchCV</a:t>
+            </a:r>
+          </a:p>
+        </p:txBody>
+      </p:sp>
+      <p:sp>
+        <p:nvSpPr>
+          <p:cNvPr id="6" name="TextBox 5"/>
+          <p:cNvSpPr txBox="1"/>
+          <p:nvPr/>
+        </p:nvSpPr>
+        <p:spPr>
+          <a:xfrm>
+            <a:off x="640080" y="1371600"/>
+            <a:ext cx="10972800" cy="4937760"/>
+          </a:xfrm>
+          <a:prstGeom prst="rect">
+            <a:avLst/>
+          </a:prstGeom>
+          <a:noFill/>
+        </p:spPr>
+        <p:txBody>
+          <a:bodyPr wrap="square" anchor="t">
+            <a:spAutoFit/>
+          </a:bodyPr>
+          <a:lstStyle/>
+          <a:p>
+            <a:pPr algn="l">
+              <a:spcBef>
+                <a:spcPts val="0"/>
+              </a:spcBef>
+              <a:spcAft>
+                <a:spcPts val="900"/>
+              </a:spcAft>
+            </a:pPr>
+            <a:r>
+              <a:rPr sz="1600" b="0">
+                <a:solidFill>
+                  <a:srgbClr val="1A2B4A"/>
+                </a:solidFill>
+                <a:latin typeface="Calibri"/>
+              </a:rPr>
+              <a:t>•  Arbre de décision · Forêt aléatoire · Gradient Boosting.</a:t>
+            </a:r>
+          </a:p>
+          <a:p>
+            <a:pPr algn="l">
+              <a:spcBef>
+                <a:spcPts val="0"/>
+              </a:spcBef>
+              <a:spcAft>
+                <a:spcPts val="900"/>
+              </a:spcAft>
+            </a:pPr>
+            <a:r>
+              <a:rPr sz="1600" b="0">
+                <a:solidFill>
+                  <a:srgbClr val="1A2B4A"/>
+                </a:solidFill>
+                <a:latin typeface="Calibri"/>
+              </a:rPr>
+              <a:t>•  GridSearchCV avec scoring = "f1", validation croisée, même jeu de test final.</a:t>
+            </a:r>
+          </a:p>
+          <a:p>
+            <a:pPr algn="l">
+              <a:spcBef>
+                <a:spcPts val="0"/>
+              </a:spcBef>
+              <a:spcAft>
+                <a:spcPts val="900"/>
+              </a:spcAft>
+            </a:pPr>
+            <a:r>
+              <a:rPr sz="1600" b="0">
+                <a:solidFill>
+                  <a:srgbClr val="1A2B4A"/>
+                </a:solidFill>
+                <a:latin typeface="Calibri"/>
+              </a:rPr>
+              <a:t>•  Le piège du déséquilibre, concrètement :</a:t>
+            </a:r>
+          </a:p>
+          <a:p>
+            <a:pPr algn="l">
+              <a:spcBef>
+                <a:spcPts val="0"/>
+              </a:spcBef>
+              <a:spcAft>
+                <a:spcPts val="900"/>
+              </a:spcAft>
+            </a:pPr>
+            <a:r>
+              <a:rPr sz="1450" b="0">
+                <a:solidFill>
+                  <a:srgbClr val="555555"/>
+                </a:solidFill>
+                <a:latin typeface="Calibri"/>
+              </a:rPr>
+              <a:t>–  sans correction, la forêt prédit toujours 0 → F1 = 0.</a:t>
+            </a:r>
+          </a:p>
+          <a:p>
+            <a:pPr algn="l">
+              <a:spcBef>
+                <a:spcPts val="0"/>
+              </a:spcBef>
+              <a:spcAft>
+                <a:spcPts val="900"/>
+              </a:spcAft>
+            </a:pPr>
+            <a:r>
+              <a:rPr sz="1450" b="0">
+                <a:solidFill>
+                  <a:srgbClr val="555555"/>
+                </a:solidFill>
+                <a:latin typeface="Calibri"/>
+              </a:rPr>
+              <a:t>–  Random Forest → class_weight = "balanced".</a:t>
+            </a:r>
+          </a:p>
+          <a:p>
+            <a:pPr algn="l">
+              <a:spcBef>
+                <a:spcPts val="0"/>
+              </a:spcBef>
+              <a:spcAft>
+                <a:spcPts val="900"/>
+              </a:spcAft>
+            </a:pPr>
+            <a:r>
+              <a:rPr sz="1450" b="0">
+                <a:solidFill>
+                  <a:srgbClr val="555555"/>
+                </a:solidFill>
+                <a:latin typeface="Calibri"/>
+              </a:rPr>
+              <a:t>–  Gradient Boosting → sample_weight équilibré (pas de class_weight natif).</a:t>
+            </a:r>
+          </a:p>
+          <a:p>
+            <a:pPr algn="l">
+              <a:spcBef>
+                <a:spcPts val="0"/>
+              </a:spcBef>
+              <a:spcAft>
+                <a:spcPts val="900"/>
+              </a:spcAft>
+            </a:pPr>
+            <a:r>
+              <a:rPr sz="1450" b="0">
+                <a:solidFill>
+                  <a:srgbClr val="555555"/>
+                </a:solidFill>
+                <a:latin typeface="Calibri"/>
+              </a:rPr>
+              <a:t>–  Les erreurs sur la classe rare pèsent alors ~9× plus.</a:t>
+            </a:r>
+          </a:p>
+        </p:txBody>
+      </p:sp>
+    </p:spTree>
+  </p:cSld>
+  <p:clrMapOvr>
+    <a:masterClrMapping/>
+  </p:clrMapOvr>
+</p:sld>
+</file>
+
+<file path=ppt/slides/slide6.xml><?xml version="1.0" encoding="utf-8"?>
+<p:sld xmlns:a="http://schemas.openxmlformats.org/drawingml/2006/main" xmlns:p="http://schemas.openxmlformats.org/presentationml/2006/main" xmlns:r="http://schemas.openxmlformats.org/officeDocument/2006/relationships">
+  <p:cSld>
+    <p:spTree>
+      <p:nvGrpSpPr>
+        <p:cNvPr id="1" name=""/>
+        <p:cNvGrpSpPr/>
+        <p:nvPr/>
+      </p:nvGrpSpPr>
+      <p:grpSpPr/>
+      <p:sp>
+        <p:nvSpPr>
+          <p:cNvPr id="2" name="Rectangle 1"/>
+          <p:cNvSpPr/>
+          <p:nvPr/>
+        </p:nvSpPr>
+        <p:spPr>
+          <a:xfrm>
+            <a:off x="0" y="0"/>
+            <a:ext cx="12191695" cy="1051560"/>
+          </a:xfrm>
+          <a:prstGeom prst="rect">
+            <a:avLst/>
+          </a:prstGeom>
+          <a:solidFill>
+            <a:srgbClr val="1A2B4A"/>
+          </a:solidFill>
+          <a:ln>
+            <a:noFill/>
+          </a:ln>
+          <a:effectLst/>
+        </p:spPr>
+        <p:style>
+          <a:lnRef idx="1">
+            <a:schemeClr val="accent1"/>
+          </a:lnRef>
+          <a:fillRef idx="3">
+            <a:schemeClr val="accent1"/>
+          </a:fillRef>
+          <a:effectRef idx="2">
+            <a:schemeClr val="accent1"/>
+          </a:effectRef>
+          <a:fontRef idx="minor">
+            <a:schemeClr val="lt1"/>
+          </a:fontRef>
+        </p:style>
+        <p:txBody>
+          <a:bodyPr rtlCol="0" anchor="ctr"/>
+          <a:lstStyle/>
+          <a:p>
+            <a:pPr algn="ctr"/>
+          </a:p>
+        </p:txBody>
+      </p:sp>
+      <p:sp>
+        <p:nvSpPr>
+          <p:cNvPr id="3" name="Rectangle 2"/>
+          <p:cNvSpPr/>
+          <p:nvPr/>
+        </p:nvSpPr>
+        <p:spPr>
+          <a:xfrm>
+            <a:off x="0" y="1051560"/>
+            <a:ext cx="12191695" cy="50800"/>
+          </a:xfrm>
+          <a:prstGeom prst="rect">
+            <a:avLst/>
+          </a:prstGeom>
+          <a:solidFill>
+            <a:srgbClr val="2563EB"/>
+          </a:solidFill>
+          <a:ln>
+            <a:noFill/>
+          </a:ln>
+          <a:effectLst/>
+        </p:spPr>
+        <p:style>
+          <a:lnRef idx="1">
+            <a:schemeClr val="accent1"/>
+          </a:lnRef>
+          <a:fillRef idx="3">
+            <a:schemeClr val="accent1"/>
+          </a:fillRef>
+          <a:effectRef idx="2">
+            <a:schemeClr val="accent1"/>
+          </a:effectRef>
+          <a:fontRef idx="minor">
+            <a:schemeClr val="lt1"/>
+          </a:fontRef>
+        </p:style>
+        <p:txBody>
+          <a:bodyPr rtlCol="0" anchor="ctr"/>
+          <a:lstStyle/>
+          <a:p>
+            <a:pPr algn="ctr"/>
+          </a:p>
+        </p:txBody>
+      </p:sp>
+      <p:sp>
+        <p:nvSpPr>
+          <p:cNvPr id="4" name="TextBox 3"/>
+          <p:cNvSpPr txBox="1"/>
+          <p:nvPr/>
+        </p:nvSpPr>
+        <p:spPr>
+          <a:xfrm>
+            <a:off x="548640" y="109728"/>
+            <a:ext cx="10972800" cy="365760"/>
+          </a:xfrm>
+          <a:prstGeom prst="rect">
+            <a:avLst/>
+          </a:prstGeom>
+          <a:noFill/>
+        </p:spPr>
+        <p:txBody>
+          <a:bodyPr wrap="square" anchor="t">
+            <a:spAutoFit/>
+          </a:bodyPr>
+          <a:lstStyle/>
+          <a:p>
+            <a:pPr algn="l">
+              <a:spcBef>
+                <a:spcPts val="0"/>
+              </a:spcBef>
+              <a:spcAft>
+                <a:spcPts val="600"/>
+              </a:spcAft>
+            </a:pPr>
+            <a:r>
+              <a:rPr sz="1300" b="1">
+                <a:solidFill>
+                  <a:srgbClr val="9DB8E8"/>
+                </a:solidFill>
+                <a:latin typeface="Calibri"/>
+              </a:rPr>
               <a:t>PARTIE 1 — RÉSULTATS</a:t>
             </a:r>
           </a:p>
@@ -5457,8 +7024,8 @@
           <p:nvPr/>
         </p:nvGraphicFramePr>
         <p:xfrm>
-          <a:off x="502920" y="1325880"/>
-          <a:ext cx="5486400" cy="2926080"/>
+          <a:off x="457200" y="1371600"/>
+          <a:ext cx="5120640" cy="2834640"/>
         </p:xfrm>
         <a:graphic>
           <a:graphicData uri="http://schemas.openxmlformats.org/drawingml/2006/table">
@@ -5467,12 +7034,12 @@
                 <a:tableStyleId>{5C22544A-7EE6-4342-B048-85BDC9FD1C3A}</a:tableStyleId>
               </a:tblPr>
               <a:tblGrid>
-                <a:gridCol w="1371600"/>
-                <a:gridCol w="1371600"/>
-                <a:gridCol w="1371600"/>
-                <a:gridCol w="1371600"/>
+                <a:gridCol w="1280160"/>
+                <a:gridCol w="1280160"/>
+                <a:gridCol w="1280160"/>
+                <a:gridCol w="1280160"/>
               </a:tblGrid>
-              <a:tr h="487680">
+              <a:tr h="472440">
                 <a:tc>
                   <a:txBody>
                     <a:bodyPr/>
@@ -5480,7 +7047,7 @@
                     <a:p>
                       <a:pPr algn="ctr"/>
                       <a:r>
-                        <a:rPr sz="1300" b="1">
+                        <a:rPr sz="1250" b="1">
                           <a:solidFill>
                             <a:srgbClr val="FFFFFF"/>
                           </a:solidFill>
@@ -5502,7 +7069,7 @@
                     <a:p>
                       <a:pPr algn="ctr"/>
                       <a:r>
-                        <a:rPr sz="1300" b="1">
+                        <a:rPr sz="1250" b="1">
                           <a:solidFill>
                             <a:srgbClr val="FFFFFF"/>
                           </a:solidFill>
@@ -5524,7 +7091,7 @@
                     <a:p>
                       <a:pPr algn="ctr"/>
                       <a:r>
-                        <a:rPr sz="1300" b="1">
+                        <a:rPr sz="1250" b="1">
                           <a:solidFill>
                             <a:srgbClr val="FFFFFF"/>
                           </a:solidFill>
@@ -5546,7 +7113,7 @@
                     <a:p>
                       <a:pPr algn="ctr"/>
                       <a:r>
-                        <a:rPr sz="1300" b="1">
+                        <a:rPr sz="1250" b="1">
                           <a:solidFill>
                             <a:srgbClr val="FFFFFF"/>
                           </a:solidFill>
@@ -5562,7 +7129,7 @@
                   </a:tcPr>
                 </a:tc>
               </a:tr>
-              <a:tr h="487680">
+              <a:tr h="472440">
                 <a:tc>
                   <a:txBody>
                     <a:bodyPr/>
@@ -5570,7 +7137,7 @@
                     <a:p>
                       <a:pPr algn="l"/>
                       <a:r>
-                        <a:rPr sz="1250" b="1">
+                        <a:rPr sz="1200" b="1">
                           <a:solidFill>
                             <a:srgbClr val="1A2B4A"/>
                           </a:solidFill>
@@ -5592,7 +7159,7 @@
                     <a:p>
                       <a:pPr algn="ctr"/>
                       <a:r>
-                        <a:rPr sz="1250" b="0">
+                        <a:rPr sz="1200" b="0">
                           <a:solidFill>
                             <a:srgbClr val="1A2B4A"/>
                           </a:solidFill>
@@ -5614,7 +7181,7 @@
                     <a:p>
                       <a:pPr algn="ctr"/>
                       <a:r>
-                        <a:rPr sz="1250" b="0">
+                        <a:rPr sz="1200" b="0">
                           <a:solidFill>
                             <a:srgbClr val="1A2B4A"/>
                           </a:solidFill>
@@ -5636,7 +7203,7 @@
                     <a:p>
                       <a:pPr algn="ctr"/>
                       <a:r>
-                        <a:rPr sz="1250" b="0">
+                        <a:rPr sz="1200" b="0">
                           <a:solidFill>
                             <a:srgbClr val="1A2B4A"/>
                           </a:solidFill>
@@ -5652,7 +7219,7 @@
                   </a:tcPr>
                 </a:tc>
               </a:tr>
-              <a:tr h="487680">
+              <a:tr h="472440">
                 <a:tc>
                   <a:txBody>
                     <a:bodyPr/>
@@ -5660,7 +7227,7 @@
                     <a:p>
                       <a:pPr algn="l"/>
                       <a:r>
-                        <a:rPr sz="1250" b="1">
+                        <a:rPr sz="1200" b="1">
                           <a:solidFill>
                             <a:srgbClr val="1A2B4A"/>
                           </a:solidFill>
@@ -5682,7 +7249,7 @@
                     <a:p>
                       <a:pPr algn="ctr"/>
                       <a:r>
-                        <a:rPr sz="1250" b="0">
+                        <a:rPr sz="1200" b="0">
                           <a:solidFill>
                             <a:srgbClr val="1A2B4A"/>
                           </a:solidFill>
@@ -5704,7 +7271,7 @@
                     <a:p>
                       <a:pPr algn="ctr"/>
                       <a:r>
-                        <a:rPr sz="1250" b="0">
+                        <a:rPr sz="1200" b="0">
                           <a:solidFill>
                             <a:srgbClr val="1A2B4A"/>
                           </a:solidFill>
@@ -5726,7 +7293,7 @@
                     <a:p>
                       <a:pPr algn="ctr"/>
                       <a:r>
-                        <a:rPr sz="1250" b="0">
+                        <a:rPr sz="1200" b="0">
                           <a:solidFill>
                             <a:srgbClr val="1A2B4A"/>
                           </a:solidFill>
@@ -5742,7 +7309,7 @@
                   </a:tcPr>
                 </a:tc>
               </a:tr>
-              <a:tr h="487680">
+              <a:tr h="472440">
                 <a:tc>
                   <a:txBody>
                     <a:bodyPr/>
@@ -5750,7 +7317,7 @@
                     <a:p>
                       <a:pPr algn="l"/>
                       <a:r>
-                        <a:rPr sz="1250" b="1">
+                        <a:rPr sz="1200" b="1">
                           <a:solidFill>
                             <a:srgbClr val="1A2B4A"/>
                           </a:solidFill>
@@ -5772,7 +7339,7 @@
                     <a:p>
                       <a:pPr algn="ctr"/>
                       <a:r>
-                        <a:rPr sz="1250" b="0">
+                        <a:rPr sz="1200" b="0">
                           <a:solidFill>
                             <a:srgbClr val="1A2B4A"/>
                           </a:solidFill>
@@ -5794,7 +7361,7 @@
                     <a:p>
                       <a:pPr algn="ctr"/>
                       <a:r>
-                        <a:rPr sz="1250" b="0">
+                        <a:rPr sz="1200" b="0">
                           <a:solidFill>
                             <a:srgbClr val="1A2B4A"/>
                           </a:solidFill>
@@ -5816,7 +7383,7 @@
                     <a:p>
                       <a:pPr algn="ctr"/>
                       <a:r>
-                        <a:rPr sz="1250" b="0">
+                        <a:rPr sz="1200" b="0">
                           <a:solidFill>
                             <a:srgbClr val="1A2B4A"/>
                           </a:solidFill>
@@ -5832,7 +7399,7 @@
                   </a:tcPr>
                 </a:tc>
               </a:tr>
-              <a:tr h="487680">
+              <a:tr h="472440">
                 <a:tc>
                   <a:txBody>
                     <a:bodyPr/>
@@ -5840,7 +7407,7 @@
                     <a:p>
                       <a:pPr algn="l"/>
                       <a:r>
-                        <a:rPr sz="1250" b="1">
+                        <a:rPr sz="1200" b="1">
                           <a:solidFill>
                             <a:srgbClr val="1A2B4A"/>
                           </a:solidFill>
@@ -5862,7 +7429,7 @@
                     <a:p>
                       <a:pPr algn="ctr"/>
                       <a:r>
-                        <a:rPr sz="1250" b="0">
+                        <a:rPr sz="1200" b="0">
                           <a:solidFill>
                             <a:srgbClr val="1A2B4A"/>
                           </a:solidFill>
@@ -5884,7 +7451,7 @@
                     <a:p>
                       <a:pPr algn="ctr"/>
                       <a:r>
-                        <a:rPr sz="1250" b="0">
+                        <a:rPr sz="1200" b="0">
                           <a:solidFill>
                             <a:srgbClr val="1A2B4A"/>
                           </a:solidFill>
@@ -5906,7 +7473,7 @@
                     <a:p>
                       <a:pPr algn="ctr"/>
                       <a:r>
-                        <a:rPr sz="1250" b="0">
+                        <a:rPr sz="1200" b="0">
                           <a:solidFill>
                             <a:srgbClr val="1A2B4A"/>
                           </a:solidFill>
@@ -5922,7 +7489,7 @@
                   </a:tcPr>
                 </a:tc>
               </a:tr>
-              <a:tr h="487680">
+              <a:tr h="472440">
                 <a:tc>
                   <a:txBody>
                     <a:bodyPr/>
@@ -5930,7 +7497,7 @@
                     <a:p>
                       <a:pPr algn="l"/>
                       <a:r>
-                        <a:rPr sz="1250" b="1">
+                        <a:rPr sz="1200" b="1">
                           <a:solidFill>
                             <a:srgbClr val="1A2B4A"/>
                           </a:solidFill>
@@ -5952,7 +7519,7 @@
                     <a:p>
                       <a:pPr algn="ctr"/>
                       <a:r>
-                        <a:rPr sz="1250" b="0">
+                        <a:rPr sz="1200" b="0">
                           <a:solidFill>
                             <a:srgbClr val="1A2B4A"/>
                           </a:solidFill>
@@ -5974,7 +7541,7 @@
                     <a:p>
                       <a:pPr algn="ctr"/>
                       <a:r>
-                        <a:rPr sz="1250" b="0">
+                        <a:rPr sz="1200" b="0">
                           <a:solidFill>
                             <a:srgbClr val="1A2B4A"/>
                           </a:solidFill>
@@ -5996,7 +7563,7 @@
                     <a:p>
                       <a:pPr algn="ctr"/>
                       <a:r>
-                        <a:rPr sz="1250" b="0">
+                        <a:rPr sz="1200" b="0">
                           <a:solidFill>
                             <a:srgbClr val="1A2B4A"/>
                           </a:solidFill>
@@ -6018,7 +7585,7 @@
       </p:graphicFrame>
       <p:pic>
         <p:nvPicPr>
-          <p:cNvPr id="7" name="Picture 6" descr="comparaison_matrices_confusion.png"/>
+          <p:cNvPr id="7" name="Picture 6" descr="comparaison_metriques.png"/>
           <p:cNvPicPr>
             <a:picLocks noChangeAspect="1"/>
           </p:cNvPicPr>
@@ -6032,8 +7599,8 @@
         </p:blipFill>
         <p:spPr>
           <a:xfrm>
-            <a:off x="6309360" y="1828800"/>
-            <a:ext cx="5486400" cy="1828800"/>
+            <a:off x="5852160" y="1371600"/>
+            <a:ext cx="5852160" cy="3057285"/>
           </a:xfrm>
           <a:prstGeom prst="rect">
             <a:avLst/>
@@ -6048,8 +7615,8 @@
         </p:nvSpPr>
         <p:spPr>
           <a:xfrm>
-            <a:off x="6309360" y="4160520"/>
-            <a:ext cx="5486400" cy="365760"/>
+            <a:off x="457200" y="4526280"/>
+            <a:ext cx="11247120" cy="1325880"/>
           </a:xfrm>
           <a:prstGeom prst="rect">
             <a:avLst/>
@@ -6062,48 +7629,6 @@
           </a:bodyPr>
           <a:lstStyle/>
           <a:p>
-            <a:pPr algn="ctr">
-              <a:spcBef>
-                <a:spcPts val="0"/>
-              </a:spcBef>
-              <a:spcAft>
-                <a:spcPts val="600"/>
-              </a:spcAft>
-            </a:pPr>
-            <a:r>
-              <a:rPr sz="1100" b="0">
-                <a:solidFill>
-                  <a:srgbClr val="555555"/>
-                </a:solidFill>
-                <a:latin typeface="Calibri"/>
-              </a:rPr>
-              <a:t>Matrices de confusion — diagonale = correct, hors-diagonale = erreurs</a:t>
-            </a:r>
-          </a:p>
-        </p:txBody>
-      </p:sp>
-      <p:sp>
-        <p:nvSpPr>
-          <p:cNvPr id="9" name="TextBox 8"/>
-          <p:cNvSpPr txBox="1"/>
-          <p:nvPr/>
-        </p:nvSpPr>
-        <p:spPr>
-          <a:xfrm>
-            <a:off x="502920" y="4480560"/>
-            <a:ext cx="11155680" cy="2011680"/>
-          </a:xfrm>
-          <a:prstGeom prst="rect">
-            <a:avLst/>
-          </a:prstGeom>
-          <a:noFill/>
-        </p:spPr>
-        <p:txBody>
-          <a:bodyPr wrap="square" anchor="t">
-            <a:spAutoFit/>
-          </a:bodyPr>
-          <a:lstStyle/>
-          <a:p>
             <a:pPr algn="l">
               <a:spcBef>
                 <a:spcPts val="0"/>
@@ -6128,423 +7653,7 @@
                 </a:solidFill>
                 <a:latin typeface="Calibri"/>
               </a:rPr>
-              <a:t>l'arbre a la meilleure accuracy mais ne détecte que 125 cartons / 1000 (rappel 12,5 %). Le rééquilibrage fait monter le rappel de RF et GB à ~40 %. Meilleur F1 : Random Forest (0,181).</a:t>
-            </a:r>
-          </a:p>
-        </p:txBody>
-      </p:sp>
-    </p:spTree>
-  </p:cSld>
-  <p:clrMapOvr>
-    <a:masterClrMapping/>
-  </p:clrMapOvr>
-</p:sld>
-</file>
-
-<file path=ppt/slides/slide6.xml><?xml version="1.0" encoding="utf-8"?>
-<p:sld xmlns:a="http://schemas.openxmlformats.org/drawingml/2006/main" xmlns:p="http://schemas.openxmlformats.org/presentationml/2006/main" xmlns:r="http://schemas.openxmlformats.org/officeDocument/2006/relationships">
-  <p:cSld>
-    <p:spTree>
-      <p:nvGrpSpPr>
-        <p:cNvPr id="1" name=""/>
-        <p:cNvGrpSpPr/>
-        <p:nvPr/>
-      </p:nvGrpSpPr>
-      <p:grpSpPr/>
-      <p:sp>
-        <p:nvSpPr>
-          <p:cNvPr id="2" name="Rectangle 1"/>
-          <p:cNvSpPr/>
-          <p:nvPr/>
-        </p:nvSpPr>
-        <p:spPr>
-          <a:xfrm>
-            <a:off x="0" y="0"/>
-            <a:ext cx="12191695" cy="1051560"/>
-          </a:xfrm>
-          <a:prstGeom prst="rect">
-            <a:avLst/>
-          </a:prstGeom>
-          <a:solidFill>
-            <a:srgbClr val="1A2B4A"/>
-          </a:solidFill>
-          <a:ln>
-            <a:noFill/>
-          </a:ln>
-          <a:effectLst/>
-        </p:spPr>
-        <p:style>
-          <a:lnRef idx="1">
-            <a:schemeClr val="accent1"/>
-          </a:lnRef>
-          <a:fillRef idx="3">
-            <a:schemeClr val="accent1"/>
-          </a:fillRef>
-          <a:effectRef idx="2">
-            <a:schemeClr val="accent1"/>
-          </a:effectRef>
-          <a:fontRef idx="minor">
-            <a:schemeClr val="lt1"/>
-          </a:fontRef>
-        </p:style>
-        <p:txBody>
-          <a:bodyPr rtlCol="0" anchor="ctr"/>
-          <a:lstStyle/>
-          <a:p>
-            <a:pPr algn="ctr"/>
-          </a:p>
-        </p:txBody>
-      </p:sp>
-      <p:sp>
-        <p:nvSpPr>
-          <p:cNvPr id="3" name="Rectangle 2"/>
-          <p:cNvSpPr/>
-          <p:nvPr/>
-        </p:nvSpPr>
-        <p:spPr>
-          <a:xfrm>
-            <a:off x="0" y="1051560"/>
-            <a:ext cx="12191695" cy="50800"/>
-          </a:xfrm>
-          <a:prstGeom prst="rect">
-            <a:avLst/>
-          </a:prstGeom>
-          <a:solidFill>
-            <a:srgbClr val="2563EB"/>
-          </a:solidFill>
-          <a:ln>
-            <a:noFill/>
-          </a:ln>
-          <a:effectLst/>
-        </p:spPr>
-        <p:style>
-          <a:lnRef idx="1">
-            <a:schemeClr val="accent1"/>
-          </a:lnRef>
-          <a:fillRef idx="3">
-            <a:schemeClr val="accent1"/>
-          </a:fillRef>
-          <a:effectRef idx="2">
-            <a:schemeClr val="accent1"/>
-          </a:effectRef>
-          <a:fontRef idx="minor">
-            <a:schemeClr val="lt1"/>
-          </a:fontRef>
-        </p:style>
-        <p:txBody>
-          <a:bodyPr rtlCol="0" anchor="ctr"/>
-          <a:lstStyle/>
-          <a:p>
-            <a:pPr algn="ctr"/>
-          </a:p>
-        </p:txBody>
-      </p:sp>
-      <p:sp>
-        <p:nvSpPr>
-          <p:cNvPr id="4" name="TextBox 3"/>
-          <p:cNvSpPr txBox="1"/>
-          <p:nvPr/>
-        </p:nvSpPr>
-        <p:spPr>
-          <a:xfrm>
-            <a:off x="548640" y="109728"/>
-            <a:ext cx="10972800" cy="365760"/>
-          </a:xfrm>
-          <a:prstGeom prst="rect">
-            <a:avLst/>
-          </a:prstGeom>
-          <a:noFill/>
-        </p:spPr>
-        <p:txBody>
-          <a:bodyPr wrap="square" anchor="t">
-            <a:spAutoFit/>
-          </a:bodyPr>
-          <a:lstStyle/>
-          <a:p>
-            <a:pPr algn="l">
-              <a:spcBef>
-                <a:spcPts val="0"/>
-              </a:spcBef>
-              <a:spcAft>
-                <a:spcPts val="600"/>
-              </a:spcAft>
-            </a:pPr>
-            <a:r>
-              <a:rPr sz="1300" b="1">
-                <a:solidFill>
-                  <a:srgbClr val="9DB8E8"/>
-                </a:solidFill>
-                <a:latin typeface="Calibri"/>
-              </a:rPr>
-              <a:t>PARTIE 1 — INTERPRÉTATION</a:t>
-            </a:r>
-          </a:p>
-        </p:txBody>
-      </p:sp>
-      <p:sp>
-        <p:nvSpPr>
-          <p:cNvPr id="5" name="TextBox 4"/>
-          <p:cNvSpPr txBox="1"/>
-          <p:nvPr/>
-        </p:nvSpPr>
-        <p:spPr>
-          <a:xfrm>
-            <a:off x="548640" y="384048"/>
-            <a:ext cx="11155680" cy="640080"/>
-          </a:xfrm>
-          <a:prstGeom prst="rect">
-            <a:avLst/>
-          </a:prstGeom>
-          <a:noFill/>
-        </p:spPr>
-        <p:txBody>
-          <a:bodyPr wrap="square" anchor="t">
-            <a:spAutoFit/>
-          </a:bodyPr>
-          <a:lstStyle/>
-          <a:p>
-            <a:pPr algn="l">
-              <a:spcBef>
-                <a:spcPts val="0"/>
-              </a:spcBef>
-              <a:spcAft>
-                <a:spcPts val="600"/>
-              </a:spcAft>
-            </a:pPr>
-            <a:r>
-              <a:rPr sz="2600" b="1">
-                <a:solidFill>
-                  <a:srgbClr val="FFFFFF"/>
-                </a:solidFill>
-                <a:latin typeface="Calibri"/>
-              </a:rPr>
-              <a:t>Faux positifs / faux négatifs &amp; ROC</a:t>
-            </a:r>
-          </a:p>
-        </p:txBody>
-      </p:sp>
-      <p:sp>
-        <p:nvSpPr>
-          <p:cNvPr id="6" name="TextBox 5"/>
-          <p:cNvSpPr txBox="1"/>
-          <p:nvPr/>
-        </p:nvSpPr>
-        <p:spPr>
-          <a:xfrm>
-            <a:off x="548640" y="1280160"/>
-            <a:ext cx="5852160" cy="2743200"/>
-          </a:xfrm>
-          <a:prstGeom prst="rect">
-            <a:avLst/>
-          </a:prstGeom>
-          <a:noFill/>
-        </p:spPr>
-        <p:txBody>
-          <a:bodyPr wrap="square" anchor="t">
-            <a:spAutoFit/>
-          </a:bodyPr>
-          <a:lstStyle/>
-          <a:p>
-            <a:pPr algn="l">
-              <a:spcBef>
-                <a:spcPts val="0"/>
-              </a:spcBef>
-              <a:spcAft>
-                <a:spcPts val="1000"/>
-              </a:spcAft>
-            </a:pPr>
-            <a:r>
-              <a:rPr sz="1500" b="0">
-                <a:solidFill>
-                  <a:srgbClr val="1A2B4A"/>
-                </a:solidFill>
-                <a:latin typeface="Calibri"/>
-              </a:rPr>
-              <a:t>•  Faux positif = accuser un joueur à tort · Faux négatif = rater un vrai carton.</a:t>
-            </a:r>
-          </a:p>
-          <a:p>
-            <a:pPr algn="l">
-              <a:spcBef>
-                <a:spcPts val="0"/>
-              </a:spcBef>
-              <a:spcAft>
-                <a:spcPts val="1000"/>
-              </a:spcAft>
-            </a:pPr>
-            <a:r>
-              <a:rPr sz="1300" b="0">
-                <a:solidFill>
-                  <a:srgbClr val="555555"/>
-                </a:solidFill>
-                <a:latin typeface="Calibri"/>
-              </a:rPr>
-              <a:t>–  Ici le faux positif est jugé plus grave (ne pas pénaliser injustement).</a:t>
-            </a:r>
-          </a:p>
-          <a:p>
-            <a:pPr algn="l">
-              <a:spcBef>
-                <a:spcPts val="0"/>
-              </a:spcBef>
-              <a:spcAft>
-                <a:spcPts val="1000"/>
-              </a:spcAft>
-            </a:pPr>
-            <a:r>
-              <a:rPr sz="1300" b="0">
-                <a:solidFill>
-                  <a:srgbClr val="555555"/>
-                </a:solidFill>
-                <a:latin typeface="Calibri"/>
-              </a:rPr>
-              <a:t>–  Random Forest : ~3 098 faux positifs contre 593 faux négatifs.</a:t>
-            </a:r>
-          </a:p>
-          <a:p>
-            <a:pPr algn="l">
-              <a:spcBef>
-                <a:spcPts val="0"/>
-              </a:spcBef>
-              <a:spcAft>
-                <a:spcPts val="1000"/>
-              </a:spcAft>
-            </a:pPr>
-            <a:r>
-              <a:rPr sz="1300" b="0">
-                <a:solidFill>
-                  <a:srgbClr val="555555"/>
-                </a:solidFill>
-                <a:latin typeface="Calibri"/>
-              </a:rPr>
-              <a:t>–  → Le F1 n'est pas aligné sur la priorité métier : viser la précision serait préférable.</a:t>
-            </a:r>
-          </a:p>
-        </p:txBody>
-      </p:sp>
-      <p:pic>
-        <p:nvPicPr>
-          <p:cNvPr id="7" name="Picture 6" descr="courbe_roc.png"/>
-          <p:cNvPicPr>
-            <a:picLocks noChangeAspect="1"/>
-          </p:cNvPicPr>
-          <p:nvPr/>
-        </p:nvPicPr>
-        <p:blipFill>
-          <a:blip r:embed="rId2"/>
-          <a:stretch>
-            <a:fillRect/>
-          </a:stretch>
-        </p:blipFill>
-        <p:spPr>
-          <a:xfrm>
-            <a:off x="6644640" y="1371600"/>
-            <a:ext cx="4907280" cy="4206240"/>
-          </a:xfrm>
-          <a:prstGeom prst="rect">
-            <a:avLst/>
-          </a:prstGeom>
-        </p:spPr>
-      </p:pic>
-      <p:sp>
-        <p:nvSpPr>
-          <p:cNvPr id="8" name="TextBox 7"/>
-          <p:cNvSpPr txBox="1"/>
-          <p:nvPr/>
-        </p:nvSpPr>
-        <p:spPr>
-          <a:xfrm>
-            <a:off x="6492240" y="5623560"/>
-            <a:ext cx="5212080" cy="365760"/>
-          </a:xfrm>
-          <a:prstGeom prst="rect">
-            <a:avLst/>
-          </a:prstGeom>
-          <a:noFill/>
-        </p:spPr>
-        <p:txBody>
-          <a:bodyPr wrap="square" anchor="t">
-            <a:spAutoFit/>
-          </a:bodyPr>
-          <a:lstStyle/>
-          <a:p>
-            <a:pPr algn="ctr">
-              <a:spcBef>
-                <a:spcPts val="0"/>
-              </a:spcBef>
-              <a:spcAft>
-                <a:spcPts val="600"/>
-              </a:spcAft>
-            </a:pPr>
-            <a:r>
-              <a:rPr sz="1100" b="0">
-                <a:solidFill>
-                  <a:srgbClr val="555555"/>
-                </a:solidFill>
-                <a:latin typeface="Calibri"/>
-              </a:rPr>
-              <a:t>AUC 0,506 / 0,546 / 0,543 ≈ 0,5 : discrimination faible</a:t>
-            </a:r>
-          </a:p>
-        </p:txBody>
-      </p:sp>
-      <p:sp>
-        <p:nvSpPr>
-          <p:cNvPr id="9" name="TextBox 8"/>
-          <p:cNvSpPr txBox="1"/>
-          <p:nvPr/>
-        </p:nvSpPr>
-        <p:spPr>
-          <a:xfrm>
-            <a:off x="548640" y="4206240"/>
-            <a:ext cx="5852160" cy="2194560"/>
-          </a:xfrm>
-          <a:prstGeom prst="rect">
-            <a:avLst/>
-          </a:prstGeom>
-          <a:noFill/>
-        </p:spPr>
-        <p:txBody>
-          <a:bodyPr wrap="square" anchor="t">
-            <a:spAutoFit/>
-          </a:bodyPr>
-          <a:lstStyle/>
-          <a:p>
-            <a:pPr algn="l">
-              <a:spcBef>
-                <a:spcPts val="0"/>
-              </a:spcBef>
-              <a:spcAft>
-                <a:spcPts val="400"/>
-              </a:spcAft>
-            </a:pPr>
-            <a:r>
-              <a:rPr sz="1500" b="1">
-                <a:solidFill>
-                  <a:srgbClr val="2563EB"/>
-                </a:solidFill>
-                <a:latin typeface="Calibri"/>
-              </a:rPr>
-              <a:t>AUC ≈ 0,5</a:t>
-            </a:r>
-          </a:p>
-          <a:p>
-            <a:pPr algn="l">
-              <a:spcBef>
-                <a:spcPts val="0"/>
-              </a:spcBef>
-              <a:spcAft>
-                <a:spcPts val="400"/>
-              </a:spcAft>
-            </a:pPr>
-            <a:r>
-              <a:rPr sz="1400" b="0">
-                <a:solidFill>
-                  <a:srgbClr val="1A2B4A"/>
-                </a:solidFill>
-                <a:latin typeface="Calibri"/>
-              </a:rPr>
-              <a:t>Les meilleurs modèles distinguent à peine mieux que le hasard. Le gain de F1 vient surtout d'un déplacement du seuil (modèle plus « alarmiste »), pas d'une vraie capacité à séparer les classes.</a:t>
+              <a:t>l'arbre a la meilleure accuracy mais ne détecte que 125 cartons sur 1 000 (rappel 12,5 %) — or un modèle trivial « toujours 0 » ferait 90,2 %. Il fait donc moins bien qu'un modèle qui n'apprend rien. Le rééquilibrage porte le rappel de RF et GB à ~40 %. Meilleur F1 : Random Forest (0,181).</a:t>
             </a:r>
           </a:p>
         </p:txBody>
@@ -6692,7 +7801,7 @@
                 </a:solidFill>
                 <a:latin typeface="Calibri"/>
               </a:rPr>
-              <a:t>PARTIE 2 — INTERPRÉTABILITÉ</a:t>
+              <a:t>PARTIE 1 — ERREURS</a:t>
             </a:r>
           </a:p>
         </p:txBody>
@@ -6734,151 +7843,14 @@
                 </a:solidFill>
                 <a:latin typeface="Calibri"/>
               </a:rPr>
-              <a:t>Importance des variables &amp; SHAP</a:t>
-            </a:r>
-          </a:p>
-        </p:txBody>
-      </p:sp>
-      <p:sp>
-        <p:nvSpPr>
-          <p:cNvPr id="6" name="TextBox 5"/>
-          <p:cNvSpPr txBox="1"/>
-          <p:nvPr/>
-        </p:nvSpPr>
-        <p:spPr>
-          <a:xfrm>
-            <a:off x="548640" y="1280160"/>
-            <a:ext cx="5760720" cy="4572000"/>
-          </a:xfrm>
-          <a:prstGeom prst="rect">
-            <a:avLst/>
-          </a:prstGeom>
-          <a:noFill/>
-        </p:spPr>
-        <p:txBody>
-          <a:bodyPr wrap="square" anchor="t">
-            <a:spAutoFit/>
-          </a:bodyPr>
-          <a:lstStyle/>
-          <a:p>
-            <a:pPr algn="l">
-              <a:spcBef>
-                <a:spcPts val="0"/>
-              </a:spcBef>
-              <a:spcAft>
-                <a:spcPts val="1000"/>
-              </a:spcAft>
-            </a:pPr>
-            <a:r>
-              <a:rPr sz="1500" b="0">
-                <a:solidFill>
-                  <a:srgbClr val="1A2B4A"/>
-                </a:solidFill>
-                <a:latin typeface="Calibri"/>
-              </a:rPr>
-              <a:t>•  Importance native (Gini) : jersey_number en tête… sans aucun sens.</a:t>
-            </a:r>
-          </a:p>
-          <a:p>
-            <a:pPr algn="l">
-              <a:spcBef>
-                <a:spcPts val="0"/>
-              </a:spcBef>
-              <a:spcAft>
-                <a:spcPts val="1000"/>
-              </a:spcAft>
-            </a:pPr>
-            <a:r>
-              <a:rPr sz="1300" b="0">
-                <a:solidFill>
-                  <a:srgbClr val="555555"/>
-                </a:solidFill>
-                <a:latin typeface="Calibri"/>
-              </a:rPr>
-              <a:t>–  Biais de cardinalité : les variables à nombreuses valeurs sont sur-notées.</a:t>
-            </a:r>
-          </a:p>
-          <a:p>
-            <a:pPr algn="l">
-              <a:spcBef>
-                <a:spcPts val="0"/>
-              </a:spcBef>
-              <a:spcAft>
-                <a:spcPts val="1000"/>
-              </a:spcAft>
-            </a:pPr>
-            <a:r>
-              <a:rPr sz="1500" b="0">
-                <a:solidFill>
-                  <a:srgbClr val="1A2B4A"/>
-                </a:solidFill>
-                <a:latin typeface="Calibri"/>
-              </a:rPr>
-              <a:t>•  Importance par permutation : tout s'effondre (0,128 → 0,008).</a:t>
-            </a:r>
-          </a:p>
-          <a:p>
-            <a:pPr algn="l">
-              <a:spcBef>
-                <a:spcPts val="0"/>
-              </a:spcBef>
-              <a:spcAft>
-                <a:spcPts val="1000"/>
-              </a:spcAft>
-            </a:pPr>
-            <a:r>
-              <a:rPr sz="1300" b="0">
-                <a:solidFill>
-                  <a:srgbClr val="555555"/>
-                </a:solidFill>
-                <a:latin typeface="Calibri"/>
-              </a:rPr>
-              <a:t>–  → Aucune variable n'a d'effet marquant.</a:t>
-            </a:r>
-          </a:p>
-          <a:p>
-            <a:pPr algn="l">
-              <a:spcBef>
-                <a:spcPts val="0"/>
-              </a:spcBef>
-              <a:spcAft>
-                <a:spcPts val="1000"/>
-              </a:spcAft>
-            </a:pPr>
-            <a:r>
-              <a:rPr sz="1500" b="0">
-                <a:solidFill>
-                  <a:srgbClr val="1A2B4A"/>
-                </a:solidFill>
-                <a:latin typeface="Calibri"/>
-              </a:rPr>
-              <a:t>•  SHAP : defensive_contribution / defensive_actions les plus cohérentes.</a:t>
-            </a:r>
-          </a:p>
-          <a:p>
-            <a:pPr algn="l">
-              <a:spcBef>
-                <a:spcPts val="0"/>
-              </a:spcBef>
-              <a:spcAft>
-                <a:spcPts val="1000"/>
-              </a:spcAft>
-            </a:pPr>
-            <a:r>
-              <a:rPr sz="1300" b="0">
-                <a:solidFill>
-                  <a:srgbClr val="555555"/>
-                </a:solidFill>
-                <a:latin typeface="Calibri"/>
-              </a:rPr>
-              <a:t>–  Plus d'engagement défensif → risque un peu plus élevé (échelle très faible).</a:t>
+              <a:t>Matrices de confusion</a:t>
             </a:r>
           </a:p>
         </p:txBody>
       </p:sp>
       <p:pic>
         <p:nvPicPr>
-          <p:cNvPr id="7" name="Picture 6" descr="shap_summary_plot.png"/>
+          <p:cNvPr id="6" name="Picture 5" descr="comparaison_matrices_confusion.png"/>
           <p:cNvPicPr>
             <a:picLocks noChangeAspect="1"/>
           </p:cNvPicPr>
@@ -6892,8 +7864,8 @@
         </p:blipFill>
         <p:spPr>
           <a:xfrm>
-            <a:off x="7020145" y="1280160"/>
-            <a:ext cx="4156269" cy="4937760"/>
+            <a:off x="1143000" y="1371600"/>
+            <a:ext cx="9875520" cy="3291840"/>
           </a:xfrm>
           <a:prstGeom prst="rect">
             <a:avLst/>
@@ -6902,14 +7874,14 @@
       </p:pic>
       <p:sp>
         <p:nvSpPr>
-          <p:cNvPr id="8" name="TextBox 7"/>
+          <p:cNvPr id="7" name="TextBox 6"/>
           <p:cNvSpPr txBox="1"/>
           <p:nvPr/>
         </p:nvSpPr>
         <p:spPr>
           <a:xfrm>
-            <a:off x="6400800" y="6263640"/>
-            <a:ext cx="5394960" cy="365760"/>
+            <a:off x="548640" y="4846320"/>
+            <a:ext cx="11064240" cy="1325880"/>
           </a:xfrm>
           <a:prstGeom prst="rect">
             <a:avLst/>
@@ -6922,22 +7894,31 @@
           </a:bodyPr>
           <a:lstStyle/>
           <a:p>
-            <a:pPr algn="ctr">
-              <a:spcBef>
-                <a:spcPts val="0"/>
-              </a:spcBef>
-              <a:spcAft>
-                <a:spcPts val="600"/>
-              </a:spcAft>
-            </a:pPr>
-            <a:r>
-              <a:rPr sz="1100" b="0">
-                <a:solidFill>
-                  <a:srgbClr val="555555"/>
-                </a:solidFill>
-                <a:latin typeface="Calibri"/>
-              </a:rPr>
-              <a:t>SHAP summary plot (Random Forest)</a:t>
+            <a:pPr algn="l">
+              <a:spcBef>
+                <a:spcPts val="0"/>
+              </a:spcBef>
+              <a:spcAft>
+                <a:spcPts val="400"/>
+              </a:spcAft>
+            </a:pPr>
+            <a:r>
+              <a:rPr sz="1500" b="1">
+                <a:solidFill>
+                  <a:srgbClr val="2563EB"/>
+                </a:solidFill>
+                <a:latin typeface="Calibri"/>
+              </a:rPr>
+              <a:t>Comment lire : </a:t>
+            </a:r>
+            <a:r>
+              <a:rPr sz="1500" b="0">
+                <a:solidFill>
+                  <a:srgbClr val="1A2B4A"/>
+                </a:solidFill>
+                <a:latin typeface="Calibri"/>
+              </a:rPr>
+              <a:t>diagonale = bonnes prédictions. Hors-diagonale : en haut à droite les faux positifs (carton annoncé à tort), en bas à gauche les faux négatifs (carton non anticipé).</a:t>
             </a:r>
           </a:p>
         </p:txBody>
@@ -7085,7 +8066,7 @@
                 </a:solidFill>
                 <a:latin typeface="Calibri"/>
               </a:rPr>
-              <a:t>PARTIE 2 — CAS INDIVIDUEL</a:t>
+              <a:t>PARTIE 1 — INTERPRÉTATION</a:t>
             </a:r>
           </a:p>
         </p:txBody>
@@ -7127,45 +8108,21 @@
                 </a:solidFill>
                 <a:latin typeface="Calibri"/>
               </a:rPr>
-              <a:t>SHAP waterfall — un joueur</a:t>
-            </a:r>
-          </a:p>
-        </p:txBody>
-      </p:sp>
-      <p:pic>
-        <p:nvPicPr>
-          <p:cNvPr id="6" name="Picture 5" descr="shap_waterfall_joueur0.png"/>
-          <p:cNvPicPr>
-            <a:picLocks noChangeAspect="1"/>
-          </p:cNvPicPr>
-          <p:nvPr/>
-        </p:nvPicPr>
-        <p:blipFill>
-          <a:blip r:embed="rId2"/>
-          <a:stretch>
-            <a:fillRect/>
-          </a:stretch>
-        </p:blipFill>
+              <a:t>Faux positifs vs faux négatifs</a:t>
+            </a:r>
+          </a:p>
+        </p:txBody>
+      </p:sp>
+      <p:sp>
+        <p:nvSpPr>
+          <p:cNvPr id="6" name="TextBox 5"/>
+          <p:cNvSpPr txBox="1"/>
+          <p:nvPr/>
+        </p:nvSpPr>
         <p:spPr>
           <a:xfrm>
             <a:off x="640080" y="1371600"/>
-            <a:ext cx="6284821" cy="4754880"/>
-          </a:xfrm>
-          <a:prstGeom prst="rect">
-            <a:avLst/>
-          </a:prstGeom>
-        </p:spPr>
-      </p:pic>
-      <p:sp>
-        <p:nvSpPr>
-          <p:cNvPr id="7" name="TextBox 6"/>
-          <p:cNvSpPr txBox="1"/>
-          <p:nvPr/>
-        </p:nvSpPr>
-        <p:spPr>
-          <a:xfrm>
-            <a:off x="7498079" y="1463040"/>
-            <a:ext cx="4206240" cy="4572000"/>
+            <a:ext cx="10972800" cy="4937760"/>
           </a:xfrm>
           <a:prstGeom prst="rect">
             <a:avLst/>
@@ -7183,17 +8140,17 @@
                 <a:spcPts val="0"/>
               </a:spcBef>
               <a:spcAft>
-                <a:spcPts val="1000"/>
-              </a:spcAft>
-            </a:pPr>
-            <a:r>
-              <a:rPr sz="1700" b="1">
-                <a:solidFill>
-                  <a:srgbClr val="2563EB"/>
-                </a:solidFill>
-                <a:latin typeface="Calibri"/>
-              </a:rPr>
-              <a:t>Comment lire</a:t>
+                <a:spcPts val="900"/>
+              </a:spcAft>
+            </a:pPr>
+            <a:r>
+              <a:rPr sz="1600" b="0">
+                <a:solidFill>
+                  <a:srgbClr val="1A2B4A"/>
+                </a:solidFill>
+                <a:latin typeface="Calibri"/>
+              </a:rPr>
+              <a:t>•  Faux positif = signaler à tort un joueur · Faux négatif = rater un vrai carton.</a:t>
             </a:r>
           </a:p>
           <a:p>
@@ -7202,17 +8159,36 @@
                 <a:spcPts val="0"/>
               </a:spcBef>
               <a:spcAft>
-                <a:spcPts val="1000"/>
-              </a:spcAft>
-            </a:pPr>
-            <a:r>
-              <a:rPr sz="1400" b="0">
+                <a:spcPts val="900"/>
+              </a:spcAft>
+            </a:pPr>
+            <a:r>
+              <a:rPr sz="1450" b="0">
+                <a:solidFill>
+                  <a:srgbClr val="555555"/>
+                </a:solidFill>
+                <a:latin typeface="Calibri"/>
+              </a:rPr>
+              <a:t>–  Dans ce contexte, le faux positif est le plus grave : on ne veut pas pénaliser injustement.</a:t>
+            </a:r>
+          </a:p>
+          <a:p>
+            <a:pPr algn="l">
+              <a:spcBef>
+                <a:spcPts val="0"/>
+              </a:spcBef>
+              <a:spcAft>
+                <a:spcPts val="900"/>
+              </a:spcAft>
+            </a:pPr>
+            <a:r>
+              <a:rPr sz="1600" b="0">
                 <a:solidFill>
                   <a:srgbClr val="1A2B4A"/>
                 </a:solidFill>
                 <a:latin typeface="Calibri"/>
               </a:rPr>
-              <a:t>On part de la prédiction moyenne (0,5) pour arriver à la prédiction du joueur (0,443).</a:t>
+              <a:t>•  Or Random Forest : 3 098 faux positifs contre 593 faux négatifs.</a:t>
             </a:r>
           </a:p>
           <a:p>
@@ -7221,17 +8197,17 @@
                 <a:spcPts val="0"/>
               </a:spcBef>
               <a:spcAft>
-                <a:spcPts val="1000"/>
-              </a:spcAft>
-            </a:pPr>
-            <a:r>
-              <a:rPr sz="1400" b="1">
-                <a:solidFill>
-                  <a:srgbClr val="1D4ED8"/>
-                </a:solidFill>
-                <a:latin typeface="Calibri"/>
-              </a:rPr>
-              <a:t>Bleu → pousse vers « pas de carton »</a:t>
+                <a:spcPts val="900"/>
+              </a:spcAft>
+            </a:pPr>
+            <a:r>
+              <a:rPr sz="1450" b="0">
+                <a:solidFill>
+                  <a:srgbClr val="555555"/>
+                </a:solidFill>
+                <a:latin typeface="Calibri"/>
+              </a:rPr>
+              <a:t>–  Elle se trompe 5 fois plus souvent dans le sens jugé le plus grave.</a:t>
             </a:r>
           </a:p>
           <a:p>
@@ -7240,17 +8216,17 @@
                 <a:spcPts val="0"/>
               </a:spcBef>
               <a:spcAft>
-                <a:spcPts val="1000"/>
-              </a:spcAft>
-            </a:pPr>
-            <a:r>
-              <a:rPr sz="1400" b="1">
-                <a:solidFill>
-                  <a:srgbClr val="C02A2A"/>
-                </a:solidFill>
-                <a:latin typeface="Calibri"/>
-              </a:rPr>
-              <a:t>Rouge → pousse vers « carton »</a:t>
+                <a:spcPts val="900"/>
+              </a:spcAft>
+            </a:pPr>
+            <a:r>
+              <a:rPr sz="1450" b="0">
+                <a:solidFill>
+                  <a:srgbClr val="555555"/>
+                </a:solidFill>
+                <a:latin typeface="Calibri"/>
+              </a:rPr>
+              <a:t>–  Sur 3 505 alertes « carton », seules 407 sont justes → ~9 alertes sur 10 sont infondées.</a:t>
             </a:r>
           </a:p>
           <a:p>
@@ -7259,17 +8235,36 @@
                 <a:spcPts val="0"/>
               </a:spcBef>
               <a:spcAft>
-                <a:spcPts val="1000"/>
-              </a:spcAft>
-            </a:pPr>
-            <a:r>
-              <a:rPr sz="1400" b="0">
+                <a:spcPts val="900"/>
+              </a:spcAft>
+            </a:pPr>
+            <a:r>
+              <a:rPr sz="1600" b="0">
                 <a:solidFill>
                   <a:srgbClr val="1A2B4A"/>
                 </a:solidFill>
                 <a:latin typeface="Calibri"/>
               </a:rPr>
-              <a:t>Ici : forte créativité de jeu (creativity_score) → risque réduit. total_minutes_tournament pousse légèrement vers le carton, effet négligeable.</a:t>
+              <a:t>•  → Le F1 n'est pas aligné sur la priorité métier.</a:t>
+            </a:r>
+          </a:p>
+          <a:p>
+            <a:pPr algn="l">
+              <a:spcBef>
+                <a:spcPts val="0"/>
+              </a:spcBef>
+              <a:spcAft>
+                <a:spcPts val="900"/>
+              </a:spcAft>
+            </a:pPr>
+            <a:r>
+              <a:rPr sz="1450" b="0">
+                <a:solidFill>
+                  <a:srgbClr val="555555"/>
+                </a:solidFill>
+                <a:latin typeface="Calibri"/>
+              </a:rPr>
+              <a:t>–  Viser la précision, ou relever le seuil de décision, serait préférable pour cet usage.</a:t>
             </a:r>
           </a:p>
         </p:txBody>
@@ -7417,7 +8412,7 @@
                 </a:solidFill>
                 <a:latin typeface="Calibri"/>
               </a:rPr>
-              <a:t>PARTIE 3 — NON SUPERVISÉ</a:t>
+              <a:t>PARTIE 1 — ROC / AUC</a:t>
             </a:r>
           </a:p>
         </p:txBody>
@@ -7459,94 +8454,14 @@
                 </a:solidFill>
                 <a:latin typeface="Calibri"/>
               </a:rPr>
-              <a:t>PCA — réduction de dimension</a:t>
-            </a:r>
-          </a:p>
-        </p:txBody>
-      </p:sp>
-      <p:sp>
-        <p:nvSpPr>
-          <p:cNvPr id="6" name="TextBox 5"/>
-          <p:cNvSpPr txBox="1"/>
-          <p:nvPr/>
-        </p:nvSpPr>
-        <p:spPr>
-          <a:xfrm>
-            <a:off x="548640" y="1234440"/>
-            <a:ext cx="11155680" cy="1371600"/>
-          </a:xfrm>
-          <a:prstGeom prst="rect">
-            <a:avLst/>
-          </a:prstGeom>
-          <a:noFill/>
-        </p:spPr>
-        <p:txBody>
-          <a:bodyPr wrap="square" anchor="t">
-            <a:spAutoFit/>
-          </a:bodyPr>
-          <a:lstStyle/>
-          <a:p>
-            <a:pPr algn="l">
-              <a:spcBef>
-                <a:spcPts val="0"/>
-              </a:spcBef>
-              <a:spcAft>
-                <a:spcPts val="1000"/>
-              </a:spcAft>
-            </a:pPr>
-            <a:r>
-              <a:rPr sz="1500" b="0">
-                <a:solidFill>
-                  <a:srgbClr val="1A2B4A"/>
-                </a:solidFill>
-                <a:latin typeface="Calibri"/>
-              </a:rPr>
-              <a:t>•  La cible n'est pas utilisée ; elle sert seulement à interpréter après coup.</a:t>
-            </a:r>
-          </a:p>
-          <a:p>
-            <a:pPr algn="l">
-              <a:spcBef>
-                <a:spcPts val="0"/>
-              </a:spcBef>
-              <a:spcAft>
-                <a:spcPts val="1000"/>
-              </a:spcAft>
-            </a:pPr>
-            <a:r>
-              <a:rPr sz="1500" b="0">
-                <a:solidFill>
-                  <a:srgbClr val="1A2B4A"/>
-                </a:solidFill>
-                <a:latin typeface="Calibri"/>
-              </a:rPr>
-              <a:t>•  2 composantes ne conservent que 30,8 % de l'information (72 variables peu corrélées).</a:t>
-            </a:r>
-          </a:p>
-          <a:p>
-            <a:pPr algn="l">
-              <a:spcBef>
-                <a:spcPts val="0"/>
-              </a:spcBef>
-              <a:spcAft>
-                <a:spcPts val="1000"/>
-              </a:spcAft>
-            </a:pPr>
-            <a:r>
-              <a:rPr sz="1500" b="0">
-                <a:solidFill>
-                  <a:srgbClr val="1A2B4A"/>
-                </a:solidFill>
-                <a:latin typeface="Calibri"/>
-              </a:rPr>
-              <a:t>•  Structure visible, en partie liée au poste : les gardiens se détachent nettement.</a:t>
+              <a:t>La capacité de discrimination, tous seuils confondus</a:t>
             </a:r>
           </a:p>
         </p:txBody>
       </p:sp>
       <p:pic>
         <p:nvPicPr>
-          <p:cNvPr id="7" name="Picture 6" descr="pca_projection.png"/>
+          <p:cNvPr id="6" name="Picture 5" descr="courbe_roc.png"/>
           <p:cNvPicPr>
             <a:picLocks noChangeAspect="1"/>
           </p:cNvPicPr>
@@ -7560,48 +8475,24 @@
         </p:blipFill>
         <p:spPr>
           <a:xfrm>
-            <a:off x="1054694" y="2651760"/>
-            <a:ext cx="4565732" cy="3566160"/>
+            <a:off x="640080" y="1371600"/>
+            <a:ext cx="5394960" cy="4624251"/>
           </a:xfrm>
           <a:prstGeom prst="rect">
             <a:avLst/>
           </a:prstGeom>
         </p:spPr>
       </p:pic>
-      <p:pic>
-        <p:nvPicPr>
-          <p:cNvPr id="8" name="Picture 7" descr="pca_par_poste.png"/>
-          <p:cNvPicPr>
-            <a:picLocks noChangeAspect="1"/>
-          </p:cNvPicPr>
-          <p:nvPr/>
-        </p:nvPicPr>
-        <p:blipFill>
-          <a:blip r:embed="rId3"/>
-          <a:stretch>
-            <a:fillRect/>
-          </a:stretch>
-        </p:blipFill>
-        <p:spPr>
-          <a:xfrm>
-            <a:off x="6726765" y="2651760"/>
-            <a:ext cx="4560150" cy="3566160"/>
-          </a:xfrm>
-          <a:prstGeom prst="rect">
-            <a:avLst/>
-          </a:prstGeom>
-        </p:spPr>
-      </p:pic>
-      <p:sp>
-        <p:nvSpPr>
-          <p:cNvPr id="9" name="TextBox 8"/>
+      <p:sp>
+        <p:nvSpPr>
+          <p:cNvPr id="7" name="TextBox 6"/>
           <p:cNvSpPr txBox="1"/>
           <p:nvPr/>
         </p:nvSpPr>
         <p:spPr>
           <a:xfrm>
-            <a:off x="640080" y="6263640"/>
-            <a:ext cx="5394960" cy="365760"/>
+            <a:off x="6492240" y="1645920"/>
+            <a:ext cx="5212080" cy="4572000"/>
           </a:xfrm>
           <a:prstGeom prst="rect">
             <a:avLst/>
@@ -7614,64 +8505,79 @@
           </a:bodyPr>
           <a:lstStyle/>
           <a:p>
-            <a:pPr algn="ctr">
-              <a:spcBef>
-                <a:spcPts val="0"/>
-              </a:spcBef>
-              <a:spcAft>
-                <a:spcPts val="600"/>
-              </a:spcAft>
-            </a:pPr>
-            <a:r>
-              <a:rPr sz="1100" b="0">
-                <a:solidFill>
-                  <a:srgbClr val="555555"/>
-                </a:solidFill>
-                <a:latin typeface="Calibri"/>
-              </a:rPr>
-              <a:t>Projection brute</a:t>
-            </a:r>
-          </a:p>
-        </p:txBody>
-      </p:sp>
-      <p:sp>
-        <p:nvSpPr>
-          <p:cNvPr id="10" name="TextBox 9"/>
-          <p:cNvSpPr txBox="1"/>
-          <p:nvPr/>
-        </p:nvSpPr>
-        <p:spPr>
-          <a:xfrm>
-            <a:off x="6309360" y="6263640"/>
-            <a:ext cx="5394960" cy="365760"/>
-          </a:xfrm>
-          <a:prstGeom prst="rect">
-            <a:avLst/>
-          </a:prstGeom>
-          <a:noFill/>
-        </p:spPr>
-        <p:txBody>
-          <a:bodyPr wrap="square" anchor="t">
-            <a:spAutoFit/>
-          </a:bodyPr>
-          <a:lstStyle/>
-          <a:p>
-            <a:pPr algn="ctr">
-              <a:spcBef>
-                <a:spcPts val="0"/>
-              </a:spcBef>
-              <a:spcAft>
-                <a:spcPts val="600"/>
-              </a:spcAft>
-            </a:pPr>
-            <a:r>
-              <a:rPr sz="1100" b="0">
-                <a:solidFill>
-                  <a:srgbClr val="555555"/>
-                </a:solidFill>
-                <a:latin typeface="Calibri"/>
-              </a:rPr>
-              <a:t>Colorée par poste (gardiens en rose, isolés)</a:t>
+            <a:pPr algn="l">
+              <a:spcBef>
+                <a:spcPts val="0"/>
+              </a:spcBef>
+              <a:spcAft>
+                <a:spcPts val="1100"/>
+              </a:spcAft>
+            </a:pPr>
+            <a:r>
+              <a:rPr sz="1800" b="1">
+                <a:solidFill>
+                  <a:srgbClr val="2563EB"/>
+                </a:solidFill>
+                <a:latin typeface="Calibri"/>
+              </a:rPr>
+              <a:t>AUC ≈ 0,5 : à peine mieux que le hasard</a:t>
+            </a:r>
+          </a:p>
+          <a:p>
+            <a:pPr algn="l">
+              <a:spcBef>
+                <a:spcPts val="0"/>
+              </a:spcBef>
+              <a:spcAft>
+                <a:spcPts val="1100"/>
+              </a:spcAft>
+            </a:pPr>
+            <a:r>
+              <a:rPr sz="1500" b="0">
+                <a:solidFill>
+                  <a:srgbClr val="1A2B4A"/>
+                </a:solidFill>
+                <a:latin typeface="Calibri"/>
+              </a:rPr>
+              <a:t>0,506 · 0,546 · 0,543 — les trois courbes frôlent la diagonale.</a:t>
+            </a:r>
+          </a:p>
+          <a:p>
+            <a:pPr algn="l">
+              <a:spcBef>
+                <a:spcPts val="0"/>
+              </a:spcBef>
+              <a:spcAft>
+                <a:spcPts val="1100"/>
+              </a:spcAft>
+            </a:pPr>
+            <a:r>
+              <a:rPr sz="1500" b="0">
+                <a:solidFill>
+                  <a:srgbClr val="1A2B4A"/>
+                </a:solidFill>
+                <a:latin typeface="Calibri"/>
+              </a:rPr>
+              <a:t>L'éclairage décisif : la ROC teste tous les seuils, pas seulement 50 %.</a:t>
+            </a:r>
+          </a:p>
+          <a:p>
+            <a:pPr algn="l">
+              <a:spcBef>
+                <a:spcPts val="0"/>
+              </a:spcBef>
+              <a:spcAft>
+                <a:spcPts val="1100"/>
+              </a:spcAft>
+            </a:pPr>
+            <a:r>
+              <a:rPr sz="1500" b="0">
+                <a:solidFill>
+                  <a:srgbClr val="1A2B4A"/>
+                </a:solidFill>
+                <a:latin typeface="Calibri"/>
+              </a:rPr>
+              <a:t>Le gain de F1 obtenu par rééquilibrage traduisait donc surtout un déplacement du seuil (modèle plus « alarmiste »), pas une vraie capacité à séparer les classes.</a:t>
             </a:r>
           </a:p>
         </p:txBody>

</xml_diff>

<commit_message>
Partie 3 : ajoute ICA et t-SNE, et compare les trois reductions de dimension
L'enonce exige au moins deux techniques de reduction de dimension : seule PCA
etait faite. Ajoute ICA et t-SNE avec une comparaison quantitative par score de
silhouette, plus le tableau des meilleurs hyperparametres egalement exige.
Rapport porte a 13 pages, presentation a 18 slides.
</commit_message>
<xml_diff>
--- a/Cours_IA/Machine_learning/Cartons_Jaunes_FIFA2026/Presentation_ML_FIFA.pptx
+++ b/Cours_IA/Machine_learning/Cartons_Jaunes_FIFA2026/Presentation_ML_FIFA.pptx
@@ -20,6 +20,9 @@
     <p:sldId id="268" r:id="rId19"/>
     <p:sldId id="269" r:id="rId20"/>
     <p:sldId id="270" r:id="rId21"/>
+    <p:sldId id="271" r:id="rId22"/>
+    <p:sldId id="272" r:id="rId23"/>
+    <p:sldId id="273" r:id="rId24"/>
   </p:sldIdLst>
   <p:sldSz cx="12191695" cy="6858000" type="screen4x3"/>
   <p:notesSz cx="6858000" cy="9144000"/>
@@ -3539,7 +3542,7 @@
                 </a:solidFill>
                 <a:latin typeface="Calibri"/>
               </a:rPr>
-              <a:t>PARTIE 2 — INTERPRÉTABILITÉ</a:t>
+              <a:t>PARTIE 1 — ROC / AUC</a:t>
             </a:r>
           </a:p>
         </p:txBody>
@@ -3581,14 +3584,14 @@
                 </a:solidFill>
                 <a:latin typeface="Calibri"/>
               </a:rPr>
-              <a:t>Un piège : le biais de cardinalité</a:t>
+              <a:t>La capacité de discrimination, tous seuils confondus</a:t>
             </a:r>
           </a:p>
         </p:txBody>
       </p:sp>
       <p:pic>
         <p:nvPicPr>
-          <p:cNvPr id="6" name="Picture 5" descr="importance_comparaison.png"/>
+          <p:cNvPr id="6" name="Picture 5" descr="courbe_roc.png"/>
           <p:cNvPicPr>
             <a:picLocks noChangeAspect="1"/>
           </p:cNvPicPr>
@@ -3602,8 +3605,8 @@
         </p:blipFill>
         <p:spPr>
           <a:xfrm>
-            <a:off x="1949572" y="1371600"/>
-            <a:ext cx="8262375" cy="3566160"/>
+            <a:off x="640080" y="1371600"/>
+            <a:ext cx="5394960" cy="4624251"/>
           </a:xfrm>
           <a:prstGeom prst="rect">
             <a:avLst/>
@@ -3618,8 +3621,8 @@
         </p:nvSpPr>
         <p:spPr>
           <a:xfrm>
-            <a:off x="457200" y="5120640"/>
-            <a:ext cx="11247120" cy="1325880"/>
+            <a:off x="6492240" y="1645920"/>
+            <a:ext cx="5212080" cy="4572000"/>
           </a:xfrm>
           <a:prstGeom prst="rect">
             <a:avLst/>
@@ -3637,18 +3640,28 @@
                 <a:spcPts val="0"/>
               </a:spcBef>
               <a:spcAft>
-                <a:spcPts val="400"/>
-              </a:spcAft>
-            </a:pPr>
-            <a:r>
-              <a:rPr sz="1500" b="1">
+                <a:spcPts val="1100"/>
+              </a:spcAft>
+            </a:pPr>
+            <a:r>
+              <a:rPr sz="1800" b="1">
                 <a:solidFill>
                   <a:srgbClr val="2563EB"/>
                 </a:solidFill>
                 <a:latin typeface="Calibri"/>
               </a:rPr>
-              <a:t>Le diagnostic : </a:t>
-            </a:r>
+              <a:t>AUC ≈ 0,5 : à peine mieux que le hasard</a:t>
+            </a:r>
+          </a:p>
+          <a:p>
+            <a:pPr algn="l">
+              <a:spcBef>
+                <a:spcPts val="0"/>
+              </a:spcBef>
+              <a:spcAft>
+                <a:spcPts val="1100"/>
+              </a:spcAft>
+            </a:pPr>
             <a:r>
               <a:rPr sz="1500" b="0">
                 <a:solidFill>
@@ -3656,7 +3669,45 @@
                 </a:solidFill>
                 <a:latin typeface="Calibri"/>
               </a:rPr>
-              <a:t>l'importance native place jersey_number en tête — aucun sens footballistique. Cette mesure favorise les variables à nombreuses valeurs distinctes. L'importance par permutation tranche : 0,128 → 0,008, un effondrement d'un facteur ~16. Aucune variable n'a d'effet réellement marquant.</a:t>
+              <a:t>0,506 · 0,546 · 0,543 — les trois courbes frôlent la diagonale.</a:t>
+            </a:r>
+          </a:p>
+          <a:p>
+            <a:pPr algn="l">
+              <a:spcBef>
+                <a:spcPts val="0"/>
+              </a:spcBef>
+              <a:spcAft>
+                <a:spcPts val="1100"/>
+              </a:spcAft>
+            </a:pPr>
+            <a:r>
+              <a:rPr sz="1500" b="0">
+                <a:solidFill>
+                  <a:srgbClr val="1A2B4A"/>
+                </a:solidFill>
+                <a:latin typeface="Calibri"/>
+              </a:rPr>
+              <a:t>L'éclairage décisif : la ROC teste tous les seuils, pas seulement 50 %.</a:t>
+            </a:r>
+          </a:p>
+          <a:p>
+            <a:pPr algn="l">
+              <a:spcBef>
+                <a:spcPts val="0"/>
+              </a:spcBef>
+              <a:spcAft>
+                <a:spcPts val="1100"/>
+              </a:spcAft>
+            </a:pPr>
+            <a:r>
+              <a:rPr sz="1500" b="0">
+                <a:solidFill>
+                  <a:srgbClr val="1A2B4A"/>
+                </a:solidFill>
+                <a:latin typeface="Calibri"/>
+              </a:rPr>
+              <a:t>Le gain de F1 obtenu par rééquilibrage traduisait donc surtout un déplacement du seuil (modèle plus « alarmiste »), pas une vraie capacité à séparer les classes.</a:t>
             </a:r>
           </a:p>
         </p:txBody>
@@ -3804,7 +3855,7 @@
                 </a:solidFill>
                 <a:latin typeface="Calibri"/>
               </a:rPr>
-              <a:t>PARTIE 2 — SHAP</a:t>
+              <a:t>PARTIE 2 — INTERPRÉTABILITÉ</a:t>
             </a:r>
           </a:p>
         </p:txBody>
@@ -3846,14 +3897,14 @@
                 </a:solidFill>
                 <a:latin typeface="Calibri"/>
               </a:rPr>
-              <a:t>Interprétation globale</a:t>
+              <a:t>Un piège : le biais de cardinalité</a:t>
             </a:r>
           </a:p>
         </p:txBody>
       </p:sp>
       <p:pic>
         <p:nvPicPr>
-          <p:cNvPr id="6" name="Picture 5" descr="shap_summary_plot.png"/>
+          <p:cNvPr id="6" name="Picture 5" descr="importance_comparaison.png"/>
           <p:cNvPicPr>
             <a:picLocks noChangeAspect="1"/>
           </p:cNvPicPr>
@@ -3867,8 +3918,8 @@
         </p:blipFill>
         <p:spPr>
           <a:xfrm>
-            <a:off x="1045297" y="1280160"/>
-            <a:ext cx="4310205" cy="5120640"/>
+            <a:off x="1949572" y="1371600"/>
+            <a:ext cx="8262375" cy="3566160"/>
           </a:xfrm>
           <a:prstGeom prst="rect">
             <a:avLst/>
@@ -3883,8 +3934,8 @@
         </p:nvSpPr>
         <p:spPr>
           <a:xfrm>
-            <a:off x="6126480" y="1554480"/>
-            <a:ext cx="5577840" cy="4572000"/>
+            <a:off x="457200" y="5120640"/>
+            <a:ext cx="11247120" cy="1325880"/>
           </a:xfrm>
           <a:prstGeom prst="rect">
             <a:avLst/>
@@ -3902,28 +3953,18 @@
                 <a:spcPts val="0"/>
               </a:spcBef>
               <a:spcAft>
-                <a:spcPts val="1000"/>
-              </a:spcAft>
-            </a:pPr>
-            <a:r>
-              <a:rPr sz="1800" b="1">
+                <a:spcPts val="400"/>
+              </a:spcAft>
+            </a:pPr>
+            <a:r>
+              <a:rPr sz="1500" b="1">
                 <a:solidFill>
                   <a:srgbClr val="2563EB"/>
                 </a:solidFill>
                 <a:latin typeface="Calibri"/>
               </a:rPr>
-              <a:t>Comment lire</a:t>
-            </a:r>
-          </a:p>
-          <a:p>
-            <a:pPr algn="l">
-              <a:spcBef>
-                <a:spcPts val="0"/>
-              </a:spcBef>
-              <a:spcAft>
-                <a:spcPts val="1000"/>
-              </a:spcAft>
-            </a:pPr>
+              <a:t>Le diagnostic : </a:t>
+            </a:r>
             <a:r>
               <a:rPr sz="1500" b="0">
                 <a:solidFill>
@@ -3931,64 +3972,7 @@
                 </a:solidFill>
                 <a:latin typeface="Calibri"/>
               </a:rPr>
-              <a:t>Chaque point = un joueur. Rouge = valeur haute de la variable, bleu = valeur basse.</a:t>
-            </a:r>
-          </a:p>
-          <a:p>
-            <a:pPr algn="l">
-              <a:spcBef>
-                <a:spcPts val="0"/>
-              </a:spcBef>
-              <a:spcAft>
-                <a:spcPts val="1000"/>
-              </a:spcAft>
-            </a:pPr>
-            <a:r>
-              <a:rPr sz="1500" b="0">
-                <a:solidFill>
-                  <a:srgbClr val="1A2B4A"/>
-                </a:solidFill>
-                <a:latin typeface="Calibri"/>
-              </a:rPr>
-              <a:t>À droite = pousse vers « carton », à gauche = vers « pas de carton ».</a:t>
-            </a:r>
-          </a:p>
-          <a:p>
-            <a:pPr algn="l">
-              <a:spcBef>
-                <a:spcPts val="0"/>
-              </a:spcBef>
-              <a:spcAft>
-                <a:spcPts val="1000"/>
-              </a:spcAft>
-            </a:pPr>
-            <a:r>
-              <a:rPr sz="1500" b="0">
-                <a:solidFill>
-                  <a:srgbClr val="1A2B4A"/>
-                </a:solidFill>
-                <a:latin typeface="Calibri"/>
-              </a:rPr>
-              <a:t>defensive_contribution donne la relation la plus cohérente : rouge à droite, bleu à gauche — plus d'engagement défensif, plus de risque.</a:t>
-            </a:r>
-          </a:p>
-          <a:p>
-            <a:pPr algn="l">
-              <a:spcBef>
-                <a:spcPts val="0"/>
-              </a:spcBef>
-              <a:spcAft>
-                <a:spcPts val="1000"/>
-              </a:spcAft>
-            </a:pPr>
-            <a:r>
-              <a:rPr sz="1500" b="1">
-                <a:solidFill>
-                  <a:srgbClr val="1A2B4A"/>
-                </a:solidFill>
-                <a:latin typeface="Calibri"/>
-              </a:rPr>
-              <a:t>Mais l'échelle (−0,04 à +0,03) confirme un signal très faible.</a:t>
+              <a:t>l'importance native place jersey_number en tête — aucun sens footballistique. Cette mesure favorise les variables à nombreuses valeurs distinctes. L'importance par permutation tranche : 0,128 → 0,008, un effondrement d'un facteur ~16. Aucune variable n'a d'effet réellement marquant.</a:t>
             </a:r>
           </a:p>
         </p:txBody>
@@ -4136,7 +4120,7 @@
                 </a:solidFill>
                 <a:latin typeface="Calibri"/>
               </a:rPr>
-              <a:t>PARTIE 2 — CAS INDIVIDUEL</a:t>
+              <a:t>PARTIE 2 — SHAP</a:t>
             </a:r>
           </a:p>
         </p:txBody>
@@ -4178,14 +4162,14 @@
                 </a:solidFill>
                 <a:latin typeface="Calibri"/>
               </a:rPr>
-              <a:t>SHAP waterfall — un joueur</a:t>
+              <a:t>Interprétation globale</a:t>
             </a:r>
           </a:p>
         </p:txBody>
       </p:sp>
       <p:pic>
         <p:nvPicPr>
-          <p:cNvPr id="6" name="Picture 5" descr="shap_waterfall_joueur0.png"/>
+          <p:cNvPr id="6" name="Picture 5" descr="shap_summary_plot.png"/>
           <p:cNvPicPr>
             <a:picLocks noChangeAspect="1"/>
           </p:cNvPicPr>
@@ -4199,8 +4183,8 @@
         </p:blipFill>
         <p:spPr>
           <a:xfrm>
-            <a:off x="640080" y="1371600"/>
-            <a:ext cx="6284821" cy="4754880"/>
+            <a:off x="1045297" y="1280160"/>
+            <a:ext cx="4310205" cy="5120640"/>
           </a:xfrm>
           <a:prstGeom prst="rect">
             <a:avLst/>
@@ -4215,8 +4199,8 @@
         </p:nvSpPr>
         <p:spPr>
           <a:xfrm>
-            <a:off x="7498079" y="1463040"/>
-            <a:ext cx="4206240" cy="4572000"/>
+            <a:off x="6126480" y="1554480"/>
+            <a:ext cx="5577840" cy="4572000"/>
           </a:xfrm>
           <a:prstGeom prst="rect">
             <a:avLst/>
@@ -4263,7 +4247,7 @@
                 </a:solidFill>
                 <a:latin typeface="Calibri"/>
               </a:rPr>
-              <a:t>On part de la prédiction moyenne (0,5) pour arriver à celle du joueur (0,443).</a:t>
+              <a:t>Chaque point = un joueur. Rouge = valeur haute de la variable, bleu = valeur basse.</a:t>
             </a:r>
           </a:p>
           <a:p>
@@ -4276,51 +4260,51 @@
               </a:spcAft>
             </a:pPr>
             <a:r>
+              <a:rPr sz="1500" b="0">
+                <a:solidFill>
+                  <a:srgbClr val="1A2B4A"/>
+                </a:solidFill>
+                <a:latin typeface="Calibri"/>
+              </a:rPr>
+              <a:t>À droite = pousse vers « carton », à gauche = vers « pas de carton ».</a:t>
+            </a:r>
+          </a:p>
+          <a:p>
+            <a:pPr algn="l">
+              <a:spcBef>
+                <a:spcPts val="0"/>
+              </a:spcBef>
+              <a:spcAft>
+                <a:spcPts val="1000"/>
+              </a:spcAft>
+            </a:pPr>
+            <a:r>
+              <a:rPr sz="1500" b="0">
+                <a:solidFill>
+                  <a:srgbClr val="1A2B4A"/>
+                </a:solidFill>
+                <a:latin typeface="Calibri"/>
+              </a:rPr>
+              <a:t>defensive_contribution donne la relation la plus cohérente : rouge à droite, bleu à gauche — plus d'engagement défensif, plus de risque.</a:t>
+            </a:r>
+          </a:p>
+          <a:p>
+            <a:pPr algn="l">
+              <a:spcBef>
+                <a:spcPts val="0"/>
+              </a:spcBef>
+              <a:spcAft>
+                <a:spcPts val="1000"/>
+              </a:spcAft>
+            </a:pPr>
+            <a:r>
               <a:rPr sz="1500" b="1">
                 <a:solidFill>
-                  <a:srgbClr val="1D4ED8"/>
-                </a:solidFill>
-                <a:latin typeface="Calibri"/>
-              </a:rPr>
-              <a:t>Bleu → pousse vers « pas de carton »</a:t>
-            </a:r>
-          </a:p>
-          <a:p>
-            <a:pPr algn="l">
-              <a:spcBef>
-                <a:spcPts val="0"/>
-              </a:spcBef>
-              <a:spcAft>
-                <a:spcPts val="1000"/>
-              </a:spcAft>
-            </a:pPr>
-            <a:r>
-              <a:rPr sz="1500" b="1">
-                <a:solidFill>
-                  <a:srgbClr val="C02A2A"/>
-                </a:solidFill>
-                <a:latin typeface="Calibri"/>
-              </a:rPr>
-              <a:t>Rouge → pousse vers « carton »</a:t>
-            </a:r>
-          </a:p>
-          <a:p>
-            <a:pPr algn="l">
-              <a:spcBef>
-                <a:spcPts val="0"/>
-              </a:spcBef>
-              <a:spcAft>
-                <a:spcPts val="1000"/>
-              </a:spcAft>
-            </a:pPr>
-            <a:r>
-              <a:rPr sz="1500" b="0">
-                <a:solidFill>
                   <a:srgbClr val="1A2B4A"/>
                 </a:solidFill>
                 <a:latin typeface="Calibri"/>
               </a:rPr>
-              <a:t>Ici : un creativity_score très élevé (99) réduit le risque. total_minutes_tournament pousse en sens inverse, mais de façon négligeable.</a:t>
+              <a:t>Mais l'échelle (−0,04 à +0,03) confirme un signal très faible.</a:t>
             </a:r>
           </a:p>
         </p:txBody>
@@ -4468,7 +4452,7 @@
                 </a:solidFill>
                 <a:latin typeface="Calibri"/>
               </a:rPr>
-              <a:t>PARTIE 3 — NON SUPERVISÉ</a:t>
+              <a:t>PARTIE 2 — CAS INDIVIDUEL</a:t>
             </a:r>
           </a:p>
         </p:txBody>
@@ -4510,14 +4494,14 @@
                 </a:solidFill>
                 <a:latin typeface="Calibri"/>
               </a:rPr>
-              <a:t>PCA — réduction de dimension</a:t>
+              <a:t>SHAP waterfall — un joueur</a:t>
             </a:r>
           </a:p>
         </p:txBody>
       </p:sp>
       <p:pic>
         <p:nvPicPr>
-          <p:cNvPr id="6" name="Picture 5" descr="pca_variance_expliquee.png"/>
+          <p:cNvPr id="6" name="Picture 5" descr="shap_waterfall_joueur0.png"/>
           <p:cNvPicPr>
             <a:picLocks noChangeAspect="1"/>
           </p:cNvPicPr>
@@ -4531,48 +4515,24 @@
         </p:blipFill>
         <p:spPr>
           <a:xfrm>
-            <a:off x="548640" y="1325880"/>
-            <a:ext cx="5394960" cy="3220656"/>
+            <a:off x="640080" y="1371600"/>
+            <a:ext cx="6284821" cy="4754880"/>
           </a:xfrm>
           <a:prstGeom prst="rect">
             <a:avLst/>
           </a:prstGeom>
         </p:spPr>
       </p:pic>
-      <p:pic>
-        <p:nvPicPr>
-          <p:cNvPr id="7" name="Picture 6" descr="pca_par_poste.png"/>
-          <p:cNvPicPr>
-            <a:picLocks noChangeAspect="1"/>
-          </p:cNvPicPr>
-          <p:nvPr/>
-        </p:nvPicPr>
-        <p:blipFill>
-          <a:blip r:embed="rId3"/>
-          <a:stretch>
-            <a:fillRect/>
-          </a:stretch>
-        </p:blipFill>
-        <p:spPr>
-          <a:xfrm>
-            <a:off x="6726765" y="1325880"/>
-            <a:ext cx="4560150" cy="3566160"/>
-          </a:xfrm>
-          <a:prstGeom prst="rect">
-            <a:avLst/>
-          </a:prstGeom>
-        </p:spPr>
-      </p:pic>
-      <p:sp>
-        <p:nvSpPr>
-          <p:cNvPr id="8" name="TextBox 7"/>
+      <p:sp>
+        <p:nvSpPr>
+          <p:cNvPr id="7" name="TextBox 6"/>
           <p:cNvSpPr txBox="1"/>
           <p:nvPr/>
         </p:nvSpPr>
         <p:spPr>
           <a:xfrm>
-            <a:off x="548640" y="5029200"/>
-            <a:ext cx="5394960" cy="365760"/>
+            <a:off x="7498079" y="1463040"/>
+            <a:ext cx="4206240" cy="4572000"/>
           </a:xfrm>
           <a:prstGeom prst="rect">
             <a:avLst/>
@@ -4585,107 +4545,90 @@
           </a:bodyPr>
           <a:lstStyle/>
           <a:p>
-            <a:pPr algn="ctr">
-              <a:spcBef>
-                <a:spcPts val="0"/>
-              </a:spcBef>
-              <a:spcAft>
-                <a:spcPts val="600"/>
-              </a:spcAft>
-            </a:pPr>
-            <a:r>
-              <a:rPr sz="1100" b="0">
-                <a:solidFill>
-                  <a:srgbClr val="555555"/>
-                </a:solidFill>
-                <a:latin typeface="Calibri"/>
-              </a:rPr>
-              <a:t>2 composantes = 30,8 % de l'information</a:t>
-            </a:r>
-          </a:p>
-        </p:txBody>
-      </p:sp>
-      <p:sp>
-        <p:nvSpPr>
-          <p:cNvPr id="9" name="TextBox 8"/>
-          <p:cNvSpPr txBox="1"/>
-          <p:nvPr/>
-        </p:nvSpPr>
-        <p:spPr>
-          <a:xfrm>
-            <a:off x="6309360" y="5029200"/>
-            <a:ext cx="5394960" cy="365760"/>
-          </a:xfrm>
-          <a:prstGeom prst="rect">
-            <a:avLst/>
-          </a:prstGeom>
-          <a:noFill/>
-        </p:spPr>
-        <p:txBody>
-          <a:bodyPr wrap="square" anchor="t">
-            <a:spAutoFit/>
-          </a:bodyPr>
-          <a:lstStyle/>
-          <a:p>
-            <a:pPr algn="ctr">
-              <a:spcBef>
-                <a:spcPts val="0"/>
-              </a:spcBef>
-              <a:spcAft>
-                <a:spcPts val="600"/>
-              </a:spcAft>
-            </a:pPr>
-            <a:r>
-              <a:rPr sz="1100" b="0">
-                <a:solidFill>
-                  <a:srgbClr val="555555"/>
-                </a:solidFill>
-                <a:latin typeface="Calibri"/>
-              </a:rPr>
-              <a:t>Coloré par poste : les gardiens (rose) se détachent</a:t>
-            </a:r>
-          </a:p>
-        </p:txBody>
-      </p:sp>
-      <p:sp>
-        <p:nvSpPr>
-          <p:cNvPr id="10" name="TextBox 9"/>
-          <p:cNvSpPr txBox="1"/>
-          <p:nvPr/>
-        </p:nvSpPr>
-        <p:spPr>
-          <a:xfrm>
-            <a:off x="548640" y="5321808"/>
-            <a:ext cx="11155680" cy="1325880"/>
-          </a:xfrm>
-          <a:prstGeom prst="rect">
-            <a:avLst/>
-          </a:prstGeom>
-          <a:noFill/>
-        </p:spPr>
-        <p:txBody>
-          <a:bodyPr wrap="square" anchor="t">
-            <a:spAutoFit/>
-          </a:bodyPr>
-          <a:lstStyle/>
-          <a:p>
             <a:pPr algn="l">
               <a:spcBef>
                 <a:spcPts val="0"/>
               </a:spcBef>
               <a:spcAft>
-                <a:spcPts val="400"/>
+                <a:spcPts val="1000"/>
+              </a:spcAft>
+            </a:pPr>
+            <a:r>
+              <a:rPr sz="1800" b="1">
+                <a:solidFill>
+                  <a:srgbClr val="2563EB"/>
+                </a:solidFill>
+                <a:latin typeface="Calibri"/>
+              </a:rPr>
+              <a:t>Comment lire</a:t>
+            </a:r>
+          </a:p>
+          <a:p>
+            <a:pPr algn="l">
+              <a:spcBef>
+                <a:spcPts val="0"/>
+              </a:spcBef>
+              <a:spcAft>
+                <a:spcPts val="1000"/>
+              </a:spcAft>
+            </a:pPr>
+            <a:r>
+              <a:rPr sz="1500" b="0">
+                <a:solidFill>
+                  <a:srgbClr val="1A2B4A"/>
+                </a:solidFill>
+                <a:latin typeface="Calibri"/>
+              </a:rPr>
+              <a:t>On part de la prédiction moyenne (0,5) pour arriver à celle du joueur (0,443).</a:t>
+            </a:r>
+          </a:p>
+          <a:p>
+            <a:pPr algn="l">
+              <a:spcBef>
+                <a:spcPts val="0"/>
+              </a:spcBef>
+              <a:spcAft>
+                <a:spcPts val="1000"/>
               </a:spcAft>
             </a:pPr>
             <a:r>
               <a:rPr sz="1500" b="1">
                 <a:solidFill>
-                  <a:srgbClr val="2563EB"/>
-                </a:solidFill>
-                <a:latin typeface="Calibri"/>
-              </a:rPr>
-              <a:t>À retenir : </a:t>
-            </a:r>
+                  <a:srgbClr val="1D4ED8"/>
+                </a:solidFill>
+                <a:latin typeface="Calibri"/>
+              </a:rPr>
+              <a:t>Bleu → pousse vers « pas de carton »</a:t>
+            </a:r>
+          </a:p>
+          <a:p>
+            <a:pPr algn="l">
+              <a:spcBef>
+                <a:spcPts val="0"/>
+              </a:spcBef>
+              <a:spcAft>
+                <a:spcPts val="1000"/>
+              </a:spcAft>
+            </a:pPr>
+            <a:r>
+              <a:rPr sz="1500" b="1">
+                <a:solidFill>
+                  <a:srgbClr val="C02A2A"/>
+                </a:solidFill>
+                <a:latin typeface="Calibri"/>
+              </a:rPr>
+              <a:t>Rouge → pousse vers « carton »</a:t>
+            </a:r>
+          </a:p>
+          <a:p>
+            <a:pPr algn="l">
+              <a:spcBef>
+                <a:spcPts val="0"/>
+              </a:spcBef>
+              <a:spcAft>
+                <a:spcPts val="1000"/>
+              </a:spcAft>
+            </a:pPr>
             <a:r>
               <a:rPr sz="1500" b="0">
                 <a:solidFill>
@@ -4693,7 +4636,7 @@
                 </a:solidFill>
                 <a:latin typeface="Calibri"/>
               </a:rPr>
-              <a:t>la cible n'est pas utilisée pour construire les groupes — elle ne sert qu'à interpréter après coup. Malgré 70 % d'information perdue, une structure nette apparaît, expliquée par le poste des joueurs.</a:t>
+              <a:t>Ici : un creativity_score très élevé (99) réduit le risque. total_minutes_tournament pousse en sens inverse, mais de façon négligeable.</a:t>
             </a:r>
           </a:p>
         </p:txBody>
@@ -4841,7 +4784,7 @@
                 </a:solidFill>
                 <a:latin typeface="Calibri"/>
               </a:rPr>
-              <a:t>PARTIE 3 — CLUSTERING</a:t>
+              <a:t>PARTIE 3 — NON SUPERVISÉ</a:t>
             </a:r>
           </a:p>
         </p:txBody>
@@ -4883,14 +4826,14 @@
                 </a:solidFill>
                 <a:latin typeface="Calibri"/>
               </a:rPr>
-              <a:t>KMeans vs DBSCAN</a:t>
+              <a:t>Trois techniques de réduction de dimension</a:t>
             </a:r>
           </a:p>
         </p:txBody>
       </p:sp>
       <p:pic>
         <p:nvPicPr>
-          <p:cNvPr id="6" name="Picture 5" descr="kmeans_clusters.png"/>
+          <p:cNvPr id="6" name="Picture 5" descr="comparaison_reduction_dimension.png"/>
           <p:cNvPicPr>
             <a:picLocks noChangeAspect="1"/>
           </p:cNvPicPr>
@@ -4904,48 +4847,24 @@
         </p:blipFill>
         <p:spPr>
           <a:xfrm>
-            <a:off x="1151674" y="1325880"/>
-            <a:ext cx="4097452" cy="3200400"/>
+            <a:off x="939417" y="1325880"/>
+            <a:ext cx="10282686" cy="3657600"/>
           </a:xfrm>
           <a:prstGeom prst="rect">
             <a:avLst/>
           </a:prstGeom>
         </p:spPr>
       </p:pic>
-      <p:pic>
-        <p:nvPicPr>
-          <p:cNvPr id="7" name="Picture 6" descr="dbscan_clusters.png"/>
-          <p:cNvPicPr>
-            <a:picLocks noChangeAspect="1"/>
-          </p:cNvPicPr>
-          <p:nvPr/>
-        </p:nvPicPr>
-        <p:blipFill>
-          <a:blip r:embed="rId3"/>
-          <a:stretch>
-            <a:fillRect/>
-          </a:stretch>
-        </p:blipFill>
-        <p:spPr>
-          <a:xfrm>
-            <a:off x="6820954" y="1325880"/>
-            <a:ext cx="4097452" cy="3200400"/>
-          </a:xfrm>
-          <a:prstGeom prst="rect">
-            <a:avLst/>
-          </a:prstGeom>
-        </p:spPr>
-      </p:pic>
-      <p:sp>
-        <p:nvSpPr>
-          <p:cNvPr id="8" name="TextBox 7"/>
+      <p:sp>
+        <p:nvSpPr>
+          <p:cNvPr id="7" name="TextBox 6"/>
           <p:cNvSpPr txBox="1"/>
           <p:nvPr/>
         </p:nvSpPr>
         <p:spPr>
           <a:xfrm>
-            <a:off x="640080" y="4617720"/>
-            <a:ext cx="5120640" cy="365760"/>
+            <a:off x="457200" y="5120640"/>
+            <a:ext cx="11247120" cy="1325880"/>
           </a:xfrm>
           <a:prstGeom prst="rect">
             <a:avLst/>
@@ -4958,98 +4877,23 @@
           </a:bodyPr>
           <a:lstStyle/>
           <a:p>
-            <a:pPr algn="ctr">
-              <a:spcBef>
-                <a:spcPts val="0"/>
-              </a:spcBef>
-              <a:spcAft>
-                <a:spcPts val="600"/>
-              </a:spcAft>
-            </a:pPr>
-            <a:r>
-              <a:rPr sz="1100" b="0">
-                <a:solidFill>
-                  <a:srgbClr val="555555"/>
-                </a:solidFill>
-                <a:latin typeface="Calibri"/>
-              </a:rPr>
-              <a:t>KMeans (k=4) — silhouette 0,135 : groupes chevauchants</a:t>
-            </a:r>
-          </a:p>
-        </p:txBody>
-      </p:sp>
-      <p:sp>
-        <p:nvSpPr>
-          <p:cNvPr id="9" name="TextBox 8"/>
-          <p:cNvSpPr txBox="1"/>
-          <p:nvPr/>
-        </p:nvSpPr>
-        <p:spPr>
-          <a:xfrm>
-            <a:off x="6309360" y="4617720"/>
-            <a:ext cx="5120640" cy="365760"/>
-          </a:xfrm>
-          <a:prstGeom prst="rect">
-            <a:avLst/>
-          </a:prstGeom>
-          <a:noFill/>
-        </p:spPr>
-        <p:txBody>
-          <a:bodyPr wrap="square" anchor="t">
-            <a:spAutoFit/>
-          </a:bodyPr>
-          <a:lstStyle/>
-          <a:p>
-            <a:pPr algn="ctr">
-              <a:spcBef>
-                <a:spcPts val="0"/>
-              </a:spcBef>
-              <a:spcAft>
-                <a:spcPts val="600"/>
-              </a:spcAft>
-            </a:pPr>
-            <a:r>
-              <a:rPr sz="1100" b="0">
-                <a:solidFill>
-                  <a:srgbClr val="555555"/>
-                </a:solidFill>
-                <a:latin typeface="Calibri"/>
-              </a:rPr>
-              <a:t>DBSCAN — 2 clusters nets + 27 points de bruit</a:t>
-            </a:r>
-          </a:p>
-        </p:txBody>
-      </p:sp>
-      <p:sp>
-        <p:nvSpPr>
-          <p:cNvPr id="10" name="TextBox 9"/>
-          <p:cNvSpPr txBox="1"/>
-          <p:nvPr/>
-        </p:nvSpPr>
-        <p:spPr>
-          <a:xfrm>
-            <a:off x="640080" y="5074920"/>
-            <a:ext cx="11064240" cy="1554480"/>
-          </a:xfrm>
-          <a:prstGeom prst="rect">
-            <a:avLst/>
-          </a:prstGeom>
-          <a:noFill/>
-        </p:spPr>
-        <p:txBody>
-          <a:bodyPr wrap="square" anchor="t">
-            <a:spAutoFit/>
-          </a:bodyPr>
-          <a:lstStyle/>
-          <a:p>
             <a:pPr algn="l">
               <a:spcBef>
                 <a:spcPts val="0"/>
               </a:spcBef>
               <a:spcAft>
-                <a:spcPts val="500"/>
-              </a:spcAft>
-            </a:pPr>
+                <a:spcPts val="400"/>
+              </a:spcAft>
+            </a:pPr>
+            <a:r>
+              <a:rPr sz="1500" b="1">
+                <a:solidFill>
+                  <a:srgbClr val="2563EB"/>
+                </a:solidFill>
+                <a:latin typeface="Calibri"/>
+              </a:rPr>
+              <a:t>Ce qu'on voit : </a:t>
+            </a:r>
             <a:r>
               <a:rPr sz="1500" b="0">
                 <a:solidFill>
@@ -5057,26 +4901,7 @@
                 </a:solidFill>
                 <a:latin typeface="Calibri"/>
               </a:rPr>
-              <a:t>KMeans cherche des groupes convexes de taille comparable : il ne retrouve pas les postes réels. DBSCAN raisonne par densité et isole 2 clusters nets.</a:t>
-            </a:r>
-          </a:p>
-          <a:p>
-            <a:pPr algn="l">
-              <a:spcBef>
-                <a:spcPts val="0"/>
-              </a:spcBef>
-              <a:spcAft>
-                <a:spcPts val="500"/>
-              </a:spcAft>
-            </a:pPr>
-            <a:r>
-              <a:rPr sz="1500" b="1">
-                <a:solidFill>
-                  <a:srgbClr val="1A2B4A"/>
-                </a:solidFill>
-                <a:latin typeface="Calibri"/>
-              </a:rPr>
-              <a:t>Le cluster isolé est 3× plus riche en gardiens (18,2 % contre 6,7 %) — mais le taux de cartons y est quasi identique (9,9 % vs 9,6 %) : la structure reflète le poste, pas les cartons.</a:t>
+              <a:t>PCA (variance maximale) isole les gardiens mais mélange les autres postes · ICA (composantes indépendantes) fait apparaître des bandes nettes par rôle · t-SNE (non linéaire, voisinage local) éclate les données en micro-groupes. Les couleurs viennent des postes réels — usage post-hoc uniquement.</a:t>
             </a:r>
           </a:p>
         </p:txBody>
@@ -5224,6 +5049,1094 @@
                 </a:solidFill>
                 <a:latin typeface="Calibri"/>
               </a:rPr>
+              <a:t>PARTIE 3 — COMPARAISON</a:t>
+            </a:r>
+          </a:p>
+        </p:txBody>
+      </p:sp>
+      <p:sp>
+        <p:nvSpPr>
+          <p:cNvPr id="5" name="TextBox 4"/>
+          <p:cNvSpPr txBox="1"/>
+          <p:nvPr/>
+        </p:nvSpPr>
+        <p:spPr>
+          <a:xfrm>
+            <a:off x="548640" y="384048"/>
+            <a:ext cx="11155680" cy="640080"/>
+          </a:xfrm>
+          <a:prstGeom prst="rect">
+            <a:avLst/>
+          </a:prstGeom>
+          <a:noFill/>
+        </p:spPr>
+        <p:txBody>
+          <a:bodyPr wrap="square" anchor="t">
+            <a:spAutoFit/>
+          </a:bodyPr>
+          <a:lstStyle/>
+          <a:p>
+            <a:pPr algn="l">
+              <a:spcBef>
+                <a:spcPts val="0"/>
+              </a:spcBef>
+              <a:spcAft>
+                <a:spcPts val="600"/>
+              </a:spcAft>
+            </a:pPr>
+            <a:r>
+              <a:rPr sz="2600" b="1">
+                <a:solidFill>
+                  <a:srgbClr val="FFFFFF"/>
+                </a:solidFill>
+                <a:latin typeface="Calibri"/>
+              </a:rPr>
+              <a:t>Laquelle choisir ? La mesure tranche</a:t>
+            </a:r>
+          </a:p>
+        </p:txBody>
+      </p:sp>
+      <p:pic>
+        <p:nvPicPr>
+          <p:cNvPr id="6" name="Picture 5" descr="comparaison_silhouette_reduction.png"/>
+          <p:cNvPicPr>
+            <a:picLocks noChangeAspect="1"/>
+          </p:cNvPicPr>
+          <p:nvPr/>
+        </p:nvPicPr>
+        <p:blipFill>
+          <a:blip r:embed="rId2"/>
+          <a:stretch>
+            <a:fillRect/>
+          </a:stretch>
+        </p:blipFill>
+        <p:spPr>
+          <a:xfrm>
+            <a:off x="548640" y="1371600"/>
+            <a:ext cx="5852160" cy="3156591"/>
+          </a:xfrm>
+          <a:prstGeom prst="rect">
+            <a:avLst/>
+          </a:prstGeom>
+        </p:spPr>
+      </p:pic>
+      <p:sp>
+        <p:nvSpPr>
+          <p:cNvPr id="7" name="TextBox 6"/>
+          <p:cNvSpPr txBox="1"/>
+          <p:nvPr/>
+        </p:nvSpPr>
+        <p:spPr>
+          <a:xfrm>
+            <a:off x="6675120" y="1463040"/>
+            <a:ext cx="5029200" cy="4937760"/>
+          </a:xfrm>
+          <a:prstGeom prst="rect">
+            <a:avLst/>
+          </a:prstGeom>
+          <a:noFill/>
+        </p:spPr>
+        <p:txBody>
+          <a:bodyPr wrap="square" anchor="t">
+            <a:spAutoFit/>
+          </a:bodyPr>
+          <a:lstStyle/>
+          <a:p>
+            <a:pPr algn="l">
+              <a:spcBef>
+                <a:spcPts val="0"/>
+              </a:spcBef>
+              <a:spcAft>
+                <a:spcPts val="900"/>
+              </a:spcAft>
+            </a:pPr>
+            <a:r>
+              <a:rPr sz="1800" b="1">
+                <a:solidFill>
+                  <a:srgbClr val="2563EB"/>
+                </a:solidFill>
+                <a:latin typeface="Calibri"/>
+              </a:rPr>
+              <a:t>Trois enseignements</a:t>
+            </a:r>
+          </a:p>
+          <a:p>
+            <a:pPr algn="l">
+              <a:spcBef>
+                <a:spcPts val="0"/>
+              </a:spcBef>
+              <a:spcAft>
+                <a:spcPts val="900"/>
+              </a:spcAft>
+            </a:pPr>
+            <a:r>
+              <a:rPr sz="1400" b="0">
+                <a:solidFill>
+                  <a:srgbClr val="1A2B4A"/>
+                </a:solidFill>
+                <a:latin typeface="Calibri"/>
+              </a:rPr>
+              <a:t>1. ICA sépare le mieux les postes (0,138 vs 0,078) — chercher des composantes indépendantes est ici plus pertinent que la variance maximale.</a:t>
+            </a:r>
+          </a:p>
+          <a:p>
+            <a:pPr algn="l">
+              <a:spcBef>
+                <a:spcPts val="0"/>
+              </a:spcBef>
+              <a:spcAft>
+                <a:spcPts val="900"/>
+              </a:spcAft>
+            </a:pPr>
+            <a:r>
+              <a:rPr sz="1400" b="0">
+                <a:solidFill>
+                  <a:srgbClr val="1A2B4A"/>
+                </a:solidFill>
+                <a:latin typeface="Calibri"/>
+              </a:rPr>
+              <a:t>2. t-SNE fragmente en micro-groupes : spectaculaire, mais ces amas ne correspondent pas aux postes (0,108).</a:t>
+            </a:r>
+          </a:p>
+          <a:p>
+            <a:pPr algn="l">
+              <a:spcBef>
+                <a:spcPts val="0"/>
+              </a:spcBef>
+              <a:spcAft>
+                <a:spcPts val="900"/>
+              </a:spcAft>
+            </a:pPr>
+            <a:r>
+              <a:rPr sz="1400" b="0">
+                <a:solidFill>
+                  <a:srgbClr val="1A2B4A"/>
+                </a:solidFill>
+                <a:latin typeface="Calibri"/>
+              </a:rPr>
+              <a:t>3. PCA garde la meilleure cohésion KMeans (0,468) et reste la plus rapide sur les 54 600 lignes → c'est elle qu'on retient pour la suite.</a:t>
+            </a:r>
+          </a:p>
+          <a:p>
+            <a:pPr algn="l">
+              <a:spcBef>
+                <a:spcPts val="0"/>
+              </a:spcBef>
+              <a:spcAft>
+                <a:spcPts val="900"/>
+              </a:spcAft>
+            </a:pPr>
+            <a:r>
+              <a:rPr sz="1400" b="1">
+                <a:solidFill>
+                  <a:srgbClr val="2563EB"/>
+                </a:solidFill>
+                <a:latin typeface="Calibri"/>
+              </a:rPr>
+              <a:t>Aucune des trois ne révèle de structure liée aux cartons jaunes.</a:t>
+            </a:r>
+          </a:p>
+        </p:txBody>
+      </p:sp>
+    </p:spTree>
+  </p:cSld>
+  <p:clrMapOvr>
+    <a:masterClrMapping/>
+  </p:clrMapOvr>
+</p:sld>
+</file>
+
+<file path=ppt/slides/slide16.xml><?xml version="1.0" encoding="utf-8"?>
+<p:sld xmlns:a="http://schemas.openxmlformats.org/drawingml/2006/main" xmlns:p="http://schemas.openxmlformats.org/presentationml/2006/main" xmlns:r="http://schemas.openxmlformats.org/officeDocument/2006/relationships">
+  <p:cSld>
+    <p:spTree>
+      <p:nvGrpSpPr>
+        <p:cNvPr id="1" name=""/>
+        <p:cNvGrpSpPr/>
+        <p:nvPr/>
+      </p:nvGrpSpPr>
+      <p:grpSpPr/>
+      <p:sp>
+        <p:nvSpPr>
+          <p:cNvPr id="2" name="Rectangle 1"/>
+          <p:cNvSpPr/>
+          <p:nvPr/>
+        </p:nvSpPr>
+        <p:spPr>
+          <a:xfrm>
+            <a:off x="0" y="0"/>
+            <a:ext cx="12191695" cy="1051560"/>
+          </a:xfrm>
+          <a:prstGeom prst="rect">
+            <a:avLst/>
+          </a:prstGeom>
+          <a:solidFill>
+            <a:srgbClr val="1A2B4A"/>
+          </a:solidFill>
+          <a:ln>
+            <a:noFill/>
+          </a:ln>
+          <a:effectLst/>
+        </p:spPr>
+        <p:style>
+          <a:lnRef idx="1">
+            <a:schemeClr val="accent1"/>
+          </a:lnRef>
+          <a:fillRef idx="3">
+            <a:schemeClr val="accent1"/>
+          </a:fillRef>
+          <a:effectRef idx="2">
+            <a:schemeClr val="accent1"/>
+          </a:effectRef>
+          <a:fontRef idx="minor">
+            <a:schemeClr val="lt1"/>
+          </a:fontRef>
+        </p:style>
+        <p:txBody>
+          <a:bodyPr rtlCol="0" anchor="ctr"/>
+          <a:lstStyle/>
+          <a:p>
+            <a:pPr algn="ctr"/>
+          </a:p>
+        </p:txBody>
+      </p:sp>
+      <p:sp>
+        <p:nvSpPr>
+          <p:cNvPr id="3" name="Rectangle 2"/>
+          <p:cNvSpPr/>
+          <p:nvPr/>
+        </p:nvSpPr>
+        <p:spPr>
+          <a:xfrm>
+            <a:off x="0" y="1051560"/>
+            <a:ext cx="12191695" cy="50800"/>
+          </a:xfrm>
+          <a:prstGeom prst="rect">
+            <a:avLst/>
+          </a:prstGeom>
+          <a:solidFill>
+            <a:srgbClr val="2563EB"/>
+          </a:solidFill>
+          <a:ln>
+            <a:noFill/>
+          </a:ln>
+          <a:effectLst/>
+        </p:spPr>
+        <p:style>
+          <a:lnRef idx="1">
+            <a:schemeClr val="accent1"/>
+          </a:lnRef>
+          <a:fillRef idx="3">
+            <a:schemeClr val="accent1"/>
+          </a:fillRef>
+          <a:effectRef idx="2">
+            <a:schemeClr val="accent1"/>
+          </a:effectRef>
+          <a:fontRef idx="minor">
+            <a:schemeClr val="lt1"/>
+          </a:fontRef>
+        </p:style>
+        <p:txBody>
+          <a:bodyPr rtlCol="0" anchor="ctr"/>
+          <a:lstStyle/>
+          <a:p>
+            <a:pPr algn="ctr"/>
+          </a:p>
+        </p:txBody>
+      </p:sp>
+      <p:sp>
+        <p:nvSpPr>
+          <p:cNvPr id="4" name="TextBox 3"/>
+          <p:cNvSpPr txBox="1"/>
+          <p:nvPr/>
+        </p:nvSpPr>
+        <p:spPr>
+          <a:xfrm>
+            <a:off x="548640" y="109728"/>
+            <a:ext cx="10972800" cy="365760"/>
+          </a:xfrm>
+          <a:prstGeom prst="rect">
+            <a:avLst/>
+          </a:prstGeom>
+          <a:noFill/>
+        </p:spPr>
+        <p:txBody>
+          <a:bodyPr wrap="square" anchor="t">
+            <a:spAutoFit/>
+          </a:bodyPr>
+          <a:lstStyle/>
+          <a:p>
+            <a:pPr algn="l">
+              <a:spcBef>
+                <a:spcPts val="0"/>
+              </a:spcBef>
+              <a:spcAft>
+                <a:spcPts val="600"/>
+              </a:spcAft>
+            </a:pPr>
+            <a:r>
+              <a:rPr sz="1300" b="1">
+                <a:solidFill>
+                  <a:srgbClr val="9DB8E8"/>
+                </a:solidFill>
+                <a:latin typeface="Calibri"/>
+              </a:rPr>
+              <a:t>PARTIE 3 — NON SUPERVISÉ</a:t>
+            </a:r>
+          </a:p>
+        </p:txBody>
+      </p:sp>
+      <p:sp>
+        <p:nvSpPr>
+          <p:cNvPr id="5" name="TextBox 4"/>
+          <p:cNvSpPr txBox="1"/>
+          <p:nvPr/>
+        </p:nvSpPr>
+        <p:spPr>
+          <a:xfrm>
+            <a:off x="548640" y="384048"/>
+            <a:ext cx="11155680" cy="640080"/>
+          </a:xfrm>
+          <a:prstGeom prst="rect">
+            <a:avLst/>
+          </a:prstGeom>
+          <a:noFill/>
+        </p:spPr>
+        <p:txBody>
+          <a:bodyPr wrap="square" anchor="t">
+            <a:spAutoFit/>
+          </a:bodyPr>
+          <a:lstStyle/>
+          <a:p>
+            <a:pPr algn="l">
+              <a:spcBef>
+                <a:spcPts val="0"/>
+              </a:spcBef>
+              <a:spcAft>
+                <a:spcPts val="600"/>
+              </a:spcAft>
+            </a:pPr>
+            <a:r>
+              <a:rPr sz="2600" b="1">
+                <a:solidFill>
+                  <a:srgbClr val="FFFFFF"/>
+                </a:solidFill>
+                <a:latin typeface="Calibri"/>
+              </a:rPr>
+              <a:t>PCA — réduction de dimension</a:t>
+            </a:r>
+          </a:p>
+        </p:txBody>
+      </p:sp>
+      <p:pic>
+        <p:nvPicPr>
+          <p:cNvPr id="6" name="Picture 5" descr="pca_variance_expliquee.png"/>
+          <p:cNvPicPr>
+            <a:picLocks noChangeAspect="1"/>
+          </p:cNvPicPr>
+          <p:nvPr/>
+        </p:nvPicPr>
+        <p:blipFill>
+          <a:blip r:embed="rId2"/>
+          <a:stretch>
+            <a:fillRect/>
+          </a:stretch>
+        </p:blipFill>
+        <p:spPr>
+          <a:xfrm>
+            <a:off x="548640" y="1325880"/>
+            <a:ext cx="5394960" cy="3220656"/>
+          </a:xfrm>
+          <a:prstGeom prst="rect">
+            <a:avLst/>
+          </a:prstGeom>
+        </p:spPr>
+      </p:pic>
+      <p:pic>
+        <p:nvPicPr>
+          <p:cNvPr id="7" name="Picture 6" descr="pca_par_poste.png"/>
+          <p:cNvPicPr>
+            <a:picLocks noChangeAspect="1"/>
+          </p:cNvPicPr>
+          <p:nvPr/>
+        </p:nvPicPr>
+        <p:blipFill>
+          <a:blip r:embed="rId3"/>
+          <a:stretch>
+            <a:fillRect/>
+          </a:stretch>
+        </p:blipFill>
+        <p:spPr>
+          <a:xfrm>
+            <a:off x="6726765" y="1325880"/>
+            <a:ext cx="4560150" cy="3566160"/>
+          </a:xfrm>
+          <a:prstGeom prst="rect">
+            <a:avLst/>
+          </a:prstGeom>
+        </p:spPr>
+      </p:pic>
+      <p:sp>
+        <p:nvSpPr>
+          <p:cNvPr id="8" name="TextBox 7"/>
+          <p:cNvSpPr txBox="1"/>
+          <p:nvPr/>
+        </p:nvSpPr>
+        <p:spPr>
+          <a:xfrm>
+            <a:off x="548640" y="5029200"/>
+            <a:ext cx="5394960" cy="365760"/>
+          </a:xfrm>
+          <a:prstGeom prst="rect">
+            <a:avLst/>
+          </a:prstGeom>
+          <a:noFill/>
+        </p:spPr>
+        <p:txBody>
+          <a:bodyPr wrap="square" anchor="t">
+            <a:spAutoFit/>
+          </a:bodyPr>
+          <a:lstStyle/>
+          <a:p>
+            <a:pPr algn="ctr">
+              <a:spcBef>
+                <a:spcPts val="0"/>
+              </a:spcBef>
+              <a:spcAft>
+                <a:spcPts val="600"/>
+              </a:spcAft>
+            </a:pPr>
+            <a:r>
+              <a:rPr sz="1100" b="0">
+                <a:solidFill>
+                  <a:srgbClr val="555555"/>
+                </a:solidFill>
+                <a:latin typeface="Calibri"/>
+              </a:rPr>
+              <a:t>2 composantes = 30,8 % de l'information</a:t>
+            </a:r>
+          </a:p>
+        </p:txBody>
+      </p:sp>
+      <p:sp>
+        <p:nvSpPr>
+          <p:cNvPr id="9" name="TextBox 8"/>
+          <p:cNvSpPr txBox="1"/>
+          <p:nvPr/>
+        </p:nvSpPr>
+        <p:spPr>
+          <a:xfrm>
+            <a:off x="6309360" y="5029200"/>
+            <a:ext cx="5394960" cy="365760"/>
+          </a:xfrm>
+          <a:prstGeom prst="rect">
+            <a:avLst/>
+          </a:prstGeom>
+          <a:noFill/>
+        </p:spPr>
+        <p:txBody>
+          <a:bodyPr wrap="square" anchor="t">
+            <a:spAutoFit/>
+          </a:bodyPr>
+          <a:lstStyle/>
+          <a:p>
+            <a:pPr algn="ctr">
+              <a:spcBef>
+                <a:spcPts val="0"/>
+              </a:spcBef>
+              <a:spcAft>
+                <a:spcPts val="600"/>
+              </a:spcAft>
+            </a:pPr>
+            <a:r>
+              <a:rPr sz="1100" b="0">
+                <a:solidFill>
+                  <a:srgbClr val="555555"/>
+                </a:solidFill>
+                <a:latin typeface="Calibri"/>
+              </a:rPr>
+              <a:t>Coloré par poste : les gardiens (rose) se détachent</a:t>
+            </a:r>
+          </a:p>
+        </p:txBody>
+      </p:sp>
+      <p:sp>
+        <p:nvSpPr>
+          <p:cNvPr id="10" name="TextBox 9"/>
+          <p:cNvSpPr txBox="1"/>
+          <p:nvPr/>
+        </p:nvSpPr>
+        <p:spPr>
+          <a:xfrm>
+            <a:off x="548640" y="5321808"/>
+            <a:ext cx="11155680" cy="1325880"/>
+          </a:xfrm>
+          <a:prstGeom prst="rect">
+            <a:avLst/>
+          </a:prstGeom>
+          <a:noFill/>
+        </p:spPr>
+        <p:txBody>
+          <a:bodyPr wrap="square" anchor="t">
+            <a:spAutoFit/>
+          </a:bodyPr>
+          <a:lstStyle/>
+          <a:p>
+            <a:pPr algn="l">
+              <a:spcBef>
+                <a:spcPts val="0"/>
+              </a:spcBef>
+              <a:spcAft>
+                <a:spcPts val="400"/>
+              </a:spcAft>
+            </a:pPr>
+            <a:r>
+              <a:rPr sz="1500" b="1">
+                <a:solidFill>
+                  <a:srgbClr val="2563EB"/>
+                </a:solidFill>
+                <a:latin typeface="Calibri"/>
+              </a:rPr>
+              <a:t>À retenir : </a:t>
+            </a:r>
+            <a:r>
+              <a:rPr sz="1500" b="0">
+                <a:solidFill>
+                  <a:srgbClr val="1A2B4A"/>
+                </a:solidFill>
+                <a:latin typeface="Calibri"/>
+              </a:rPr>
+              <a:t>la cible n'est pas utilisée pour construire les groupes — elle ne sert qu'à interpréter après coup. Malgré 70 % d'information perdue, une structure nette apparaît, expliquée par le poste des joueurs.</a:t>
+            </a:r>
+          </a:p>
+        </p:txBody>
+      </p:sp>
+    </p:spTree>
+  </p:cSld>
+  <p:clrMapOvr>
+    <a:masterClrMapping/>
+  </p:clrMapOvr>
+</p:sld>
+</file>
+
+<file path=ppt/slides/slide17.xml><?xml version="1.0" encoding="utf-8"?>
+<p:sld xmlns:a="http://schemas.openxmlformats.org/drawingml/2006/main" xmlns:p="http://schemas.openxmlformats.org/presentationml/2006/main" xmlns:r="http://schemas.openxmlformats.org/officeDocument/2006/relationships">
+  <p:cSld>
+    <p:spTree>
+      <p:nvGrpSpPr>
+        <p:cNvPr id="1" name=""/>
+        <p:cNvGrpSpPr/>
+        <p:nvPr/>
+      </p:nvGrpSpPr>
+      <p:grpSpPr/>
+      <p:sp>
+        <p:nvSpPr>
+          <p:cNvPr id="2" name="Rectangle 1"/>
+          <p:cNvSpPr/>
+          <p:nvPr/>
+        </p:nvSpPr>
+        <p:spPr>
+          <a:xfrm>
+            <a:off x="0" y="0"/>
+            <a:ext cx="12191695" cy="1051560"/>
+          </a:xfrm>
+          <a:prstGeom prst="rect">
+            <a:avLst/>
+          </a:prstGeom>
+          <a:solidFill>
+            <a:srgbClr val="1A2B4A"/>
+          </a:solidFill>
+          <a:ln>
+            <a:noFill/>
+          </a:ln>
+          <a:effectLst/>
+        </p:spPr>
+        <p:style>
+          <a:lnRef idx="1">
+            <a:schemeClr val="accent1"/>
+          </a:lnRef>
+          <a:fillRef idx="3">
+            <a:schemeClr val="accent1"/>
+          </a:fillRef>
+          <a:effectRef idx="2">
+            <a:schemeClr val="accent1"/>
+          </a:effectRef>
+          <a:fontRef idx="minor">
+            <a:schemeClr val="lt1"/>
+          </a:fontRef>
+        </p:style>
+        <p:txBody>
+          <a:bodyPr rtlCol="0" anchor="ctr"/>
+          <a:lstStyle/>
+          <a:p>
+            <a:pPr algn="ctr"/>
+          </a:p>
+        </p:txBody>
+      </p:sp>
+      <p:sp>
+        <p:nvSpPr>
+          <p:cNvPr id="3" name="Rectangle 2"/>
+          <p:cNvSpPr/>
+          <p:nvPr/>
+        </p:nvSpPr>
+        <p:spPr>
+          <a:xfrm>
+            <a:off x="0" y="1051560"/>
+            <a:ext cx="12191695" cy="50800"/>
+          </a:xfrm>
+          <a:prstGeom prst="rect">
+            <a:avLst/>
+          </a:prstGeom>
+          <a:solidFill>
+            <a:srgbClr val="2563EB"/>
+          </a:solidFill>
+          <a:ln>
+            <a:noFill/>
+          </a:ln>
+          <a:effectLst/>
+        </p:spPr>
+        <p:style>
+          <a:lnRef idx="1">
+            <a:schemeClr val="accent1"/>
+          </a:lnRef>
+          <a:fillRef idx="3">
+            <a:schemeClr val="accent1"/>
+          </a:fillRef>
+          <a:effectRef idx="2">
+            <a:schemeClr val="accent1"/>
+          </a:effectRef>
+          <a:fontRef idx="minor">
+            <a:schemeClr val="lt1"/>
+          </a:fontRef>
+        </p:style>
+        <p:txBody>
+          <a:bodyPr rtlCol="0" anchor="ctr"/>
+          <a:lstStyle/>
+          <a:p>
+            <a:pPr algn="ctr"/>
+          </a:p>
+        </p:txBody>
+      </p:sp>
+      <p:sp>
+        <p:nvSpPr>
+          <p:cNvPr id="4" name="TextBox 3"/>
+          <p:cNvSpPr txBox="1"/>
+          <p:nvPr/>
+        </p:nvSpPr>
+        <p:spPr>
+          <a:xfrm>
+            <a:off x="548640" y="109728"/>
+            <a:ext cx="10972800" cy="365760"/>
+          </a:xfrm>
+          <a:prstGeom prst="rect">
+            <a:avLst/>
+          </a:prstGeom>
+          <a:noFill/>
+        </p:spPr>
+        <p:txBody>
+          <a:bodyPr wrap="square" anchor="t">
+            <a:spAutoFit/>
+          </a:bodyPr>
+          <a:lstStyle/>
+          <a:p>
+            <a:pPr algn="l">
+              <a:spcBef>
+                <a:spcPts val="0"/>
+              </a:spcBef>
+              <a:spcAft>
+                <a:spcPts val="600"/>
+              </a:spcAft>
+            </a:pPr>
+            <a:r>
+              <a:rPr sz="1300" b="1">
+                <a:solidFill>
+                  <a:srgbClr val="9DB8E8"/>
+                </a:solidFill>
+                <a:latin typeface="Calibri"/>
+              </a:rPr>
+              <a:t>PARTIE 3 — CLUSTERING</a:t>
+            </a:r>
+          </a:p>
+        </p:txBody>
+      </p:sp>
+      <p:sp>
+        <p:nvSpPr>
+          <p:cNvPr id="5" name="TextBox 4"/>
+          <p:cNvSpPr txBox="1"/>
+          <p:nvPr/>
+        </p:nvSpPr>
+        <p:spPr>
+          <a:xfrm>
+            <a:off x="548640" y="384048"/>
+            <a:ext cx="11155680" cy="640080"/>
+          </a:xfrm>
+          <a:prstGeom prst="rect">
+            <a:avLst/>
+          </a:prstGeom>
+          <a:noFill/>
+        </p:spPr>
+        <p:txBody>
+          <a:bodyPr wrap="square" anchor="t">
+            <a:spAutoFit/>
+          </a:bodyPr>
+          <a:lstStyle/>
+          <a:p>
+            <a:pPr algn="l">
+              <a:spcBef>
+                <a:spcPts val="0"/>
+              </a:spcBef>
+              <a:spcAft>
+                <a:spcPts val="600"/>
+              </a:spcAft>
+            </a:pPr>
+            <a:r>
+              <a:rPr sz="2600" b="1">
+                <a:solidFill>
+                  <a:srgbClr val="FFFFFF"/>
+                </a:solidFill>
+                <a:latin typeface="Calibri"/>
+              </a:rPr>
+              <a:t>KMeans vs DBSCAN</a:t>
+            </a:r>
+          </a:p>
+        </p:txBody>
+      </p:sp>
+      <p:pic>
+        <p:nvPicPr>
+          <p:cNvPr id="6" name="Picture 5" descr="kmeans_clusters.png"/>
+          <p:cNvPicPr>
+            <a:picLocks noChangeAspect="1"/>
+          </p:cNvPicPr>
+          <p:nvPr/>
+        </p:nvPicPr>
+        <p:blipFill>
+          <a:blip r:embed="rId2"/>
+          <a:stretch>
+            <a:fillRect/>
+          </a:stretch>
+        </p:blipFill>
+        <p:spPr>
+          <a:xfrm>
+            <a:off x="1151674" y="1325880"/>
+            <a:ext cx="4097452" cy="3200400"/>
+          </a:xfrm>
+          <a:prstGeom prst="rect">
+            <a:avLst/>
+          </a:prstGeom>
+        </p:spPr>
+      </p:pic>
+      <p:pic>
+        <p:nvPicPr>
+          <p:cNvPr id="7" name="Picture 6" descr="dbscan_clusters.png"/>
+          <p:cNvPicPr>
+            <a:picLocks noChangeAspect="1"/>
+          </p:cNvPicPr>
+          <p:nvPr/>
+        </p:nvPicPr>
+        <p:blipFill>
+          <a:blip r:embed="rId3"/>
+          <a:stretch>
+            <a:fillRect/>
+          </a:stretch>
+        </p:blipFill>
+        <p:spPr>
+          <a:xfrm>
+            <a:off x="6820954" y="1325880"/>
+            <a:ext cx="4097452" cy="3200400"/>
+          </a:xfrm>
+          <a:prstGeom prst="rect">
+            <a:avLst/>
+          </a:prstGeom>
+        </p:spPr>
+      </p:pic>
+      <p:sp>
+        <p:nvSpPr>
+          <p:cNvPr id="8" name="TextBox 7"/>
+          <p:cNvSpPr txBox="1"/>
+          <p:nvPr/>
+        </p:nvSpPr>
+        <p:spPr>
+          <a:xfrm>
+            <a:off x="640080" y="4617720"/>
+            <a:ext cx="5120640" cy="365760"/>
+          </a:xfrm>
+          <a:prstGeom prst="rect">
+            <a:avLst/>
+          </a:prstGeom>
+          <a:noFill/>
+        </p:spPr>
+        <p:txBody>
+          <a:bodyPr wrap="square" anchor="t">
+            <a:spAutoFit/>
+          </a:bodyPr>
+          <a:lstStyle/>
+          <a:p>
+            <a:pPr algn="ctr">
+              <a:spcBef>
+                <a:spcPts val="0"/>
+              </a:spcBef>
+              <a:spcAft>
+                <a:spcPts val="600"/>
+              </a:spcAft>
+            </a:pPr>
+            <a:r>
+              <a:rPr sz="1100" b="0">
+                <a:solidFill>
+                  <a:srgbClr val="555555"/>
+                </a:solidFill>
+                <a:latin typeface="Calibri"/>
+              </a:rPr>
+              <a:t>KMeans (k=4) — silhouette 0,135 : groupes chevauchants</a:t>
+            </a:r>
+          </a:p>
+        </p:txBody>
+      </p:sp>
+      <p:sp>
+        <p:nvSpPr>
+          <p:cNvPr id="9" name="TextBox 8"/>
+          <p:cNvSpPr txBox="1"/>
+          <p:nvPr/>
+        </p:nvSpPr>
+        <p:spPr>
+          <a:xfrm>
+            <a:off x="6309360" y="4617720"/>
+            <a:ext cx="5120640" cy="365760"/>
+          </a:xfrm>
+          <a:prstGeom prst="rect">
+            <a:avLst/>
+          </a:prstGeom>
+          <a:noFill/>
+        </p:spPr>
+        <p:txBody>
+          <a:bodyPr wrap="square" anchor="t">
+            <a:spAutoFit/>
+          </a:bodyPr>
+          <a:lstStyle/>
+          <a:p>
+            <a:pPr algn="ctr">
+              <a:spcBef>
+                <a:spcPts val="0"/>
+              </a:spcBef>
+              <a:spcAft>
+                <a:spcPts val="600"/>
+              </a:spcAft>
+            </a:pPr>
+            <a:r>
+              <a:rPr sz="1100" b="0">
+                <a:solidFill>
+                  <a:srgbClr val="555555"/>
+                </a:solidFill>
+                <a:latin typeface="Calibri"/>
+              </a:rPr>
+              <a:t>DBSCAN — 2 clusters nets + 27 points de bruit</a:t>
+            </a:r>
+          </a:p>
+        </p:txBody>
+      </p:sp>
+      <p:sp>
+        <p:nvSpPr>
+          <p:cNvPr id="10" name="TextBox 9"/>
+          <p:cNvSpPr txBox="1"/>
+          <p:nvPr/>
+        </p:nvSpPr>
+        <p:spPr>
+          <a:xfrm>
+            <a:off x="640080" y="5074920"/>
+            <a:ext cx="11064240" cy="1554480"/>
+          </a:xfrm>
+          <a:prstGeom prst="rect">
+            <a:avLst/>
+          </a:prstGeom>
+          <a:noFill/>
+        </p:spPr>
+        <p:txBody>
+          <a:bodyPr wrap="square" anchor="t">
+            <a:spAutoFit/>
+          </a:bodyPr>
+          <a:lstStyle/>
+          <a:p>
+            <a:pPr algn="l">
+              <a:spcBef>
+                <a:spcPts val="0"/>
+              </a:spcBef>
+              <a:spcAft>
+                <a:spcPts val="500"/>
+              </a:spcAft>
+            </a:pPr>
+            <a:r>
+              <a:rPr sz="1500" b="0">
+                <a:solidFill>
+                  <a:srgbClr val="1A2B4A"/>
+                </a:solidFill>
+                <a:latin typeface="Calibri"/>
+              </a:rPr>
+              <a:t>KMeans cherche des groupes convexes de taille comparable : il ne retrouve pas les postes réels. DBSCAN raisonne par densité et isole 2 clusters nets.</a:t>
+            </a:r>
+          </a:p>
+          <a:p>
+            <a:pPr algn="l">
+              <a:spcBef>
+                <a:spcPts val="0"/>
+              </a:spcBef>
+              <a:spcAft>
+                <a:spcPts val="500"/>
+              </a:spcAft>
+            </a:pPr>
+            <a:r>
+              <a:rPr sz="1500" b="1">
+                <a:solidFill>
+                  <a:srgbClr val="1A2B4A"/>
+                </a:solidFill>
+                <a:latin typeface="Calibri"/>
+              </a:rPr>
+              <a:t>Le cluster isolé est 3× plus riche en gardiens (18,2 % contre 6,7 %) — mais le taux de cartons y est quasi identique (9,9 % vs 9,6 %) : la structure reflète le poste, pas les cartons.</a:t>
+            </a:r>
+          </a:p>
+        </p:txBody>
+      </p:sp>
+    </p:spTree>
+  </p:cSld>
+  <p:clrMapOvr>
+    <a:masterClrMapping/>
+  </p:clrMapOvr>
+</p:sld>
+</file>
+
+<file path=ppt/slides/slide18.xml><?xml version="1.0" encoding="utf-8"?>
+<p:sld xmlns:a="http://schemas.openxmlformats.org/drawingml/2006/main" xmlns:p="http://schemas.openxmlformats.org/presentationml/2006/main" xmlns:r="http://schemas.openxmlformats.org/officeDocument/2006/relationships">
+  <p:cSld>
+    <p:spTree>
+      <p:nvGrpSpPr>
+        <p:cNvPr id="1" name=""/>
+        <p:cNvGrpSpPr/>
+        <p:nvPr/>
+      </p:nvGrpSpPr>
+      <p:grpSpPr/>
+      <p:sp>
+        <p:nvSpPr>
+          <p:cNvPr id="2" name="Rectangle 1"/>
+          <p:cNvSpPr/>
+          <p:nvPr/>
+        </p:nvSpPr>
+        <p:spPr>
+          <a:xfrm>
+            <a:off x="0" y="0"/>
+            <a:ext cx="12191695" cy="1051560"/>
+          </a:xfrm>
+          <a:prstGeom prst="rect">
+            <a:avLst/>
+          </a:prstGeom>
+          <a:solidFill>
+            <a:srgbClr val="1A2B4A"/>
+          </a:solidFill>
+          <a:ln>
+            <a:noFill/>
+          </a:ln>
+          <a:effectLst/>
+        </p:spPr>
+        <p:style>
+          <a:lnRef idx="1">
+            <a:schemeClr val="accent1"/>
+          </a:lnRef>
+          <a:fillRef idx="3">
+            <a:schemeClr val="accent1"/>
+          </a:fillRef>
+          <a:effectRef idx="2">
+            <a:schemeClr val="accent1"/>
+          </a:effectRef>
+          <a:fontRef idx="minor">
+            <a:schemeClr val="lt1"/>
+          </a:fontRef>
+        </p:style>
+        <p:txBody>
+          <a:bodyPr rtlCol="0" anchor="ctr"/>
+          <a:lstStyle/>
+          <a:p>
+            <a:pPr algn="ctr"/>
+          </a:p>
+        </p:txBody>
+      </p:sp>
+      <p:sp>
+        <p:nvSpPr>
+          <p:cNvPr id="3" name="Rectangle 2"/>
+          <p:cNvSpPr/>
+          <p:nvPr/>
+        </p:nvSpPr>
+        <p:spPr>
+          <a:xfrm>
+            <a:off x="0" y="1051560"/>
+            <a:ext cx="12191695" cy="50800"/>
+          </a:xfrm>
+          <a:prstGeom prst="rect">
+            <a:avLst/>
+          </a:prstGeom>
+          <a:solidFill>
+            <a:srgbClr val="2563EB"/>
+          </a:solidFill>
+          <a:ln>
+            <a:noFill/>
+          </a:ln>
+          <a:effectLst/>
+        </p:spPr>
+        <p:style>
+          <a:lnRef idx="1">
+            <a:schemeClr val="accent1"/>
+          </a:lnRef>
+          <a:fillRef idx="3">
+            <a:schemeClr val="accent1"/>
+          </a:fillRef>
+          <a:effectRef idx="2">
+            <a:schemeClr val="accent1"/>
+          </a:effectRef>
+          <a:fontRef idx="minor">
+            <a:schemeClr val="lt1"/>
+          </a:fontRef>
+        </p:style>
+        <p:txBody>
+          <a:bodyPr rtlCol="0" anchor="ctr"/>
+          <a:lstStyle/>
+          <a:p>
+            <a:pPr algn="ctr"/>
+          </a:p>
+        </p:txBody>
+      </p:sp>
+      <p:sp>
+        <p:nvSpPr>
+          <p:cNvPr id="4" name="TextBox 3"/>
+          <p:cNvSpPr txBox="1"/>
+          <p:nvPr/>
+        </p:nvSpPr>
+        <p:spPr>
+          <a:xfrm>
+            <a:off x="548640" y="109728"/>
+            <a:ext cx="10972800" cy="365760"/>
+          </a:xfrm>
+          <a:prstGeom prst="rect">
+            <a:avLst/>
+          </a:prstGeom>
+          <a:noFill/>
+        </p:spPr>
+        <p:txBody>
+          <a:bodyPr wrap="square" anchor="t">
+            <a:spAutoFit/>
+          </a:bodyPr>
+          <a:lstStyle/>
+          <a:p>
+            <a:pPr algn="l">
+              <a:spcBef>
+                <a:spcPts val="0"/>
+              </a:spcBef>
+              <a:spcAft>
+                <a:spcPts val="600"/>
+              </a:spcAft>
+            </a:pPr>
+            <a:r>
+              <a:rPr sz="1300" b="1">
+                <a:solidFill>
+                  <a:srgbClr val="9DB8E8"/>
+                </a:solidFill>
+                <a:latin typeface="Calibri"/>
+              </a:rPr>
               <a:t>CONCLUSION</a:t>
             </a:r>
           </a:p>
@@ -6834,6 +7747,546 @@
 </file>
 
 <file path=ppt/slides/slide6.xml><?xml version="1.0" encoding="utf-8"?>
+<p:sld xmlns:a="http://schemas.openxmlformats.org/drawingml/2006/main" xmlns:p="http://schemas.openxmlformats.org/presentationml/2006/main" xmlns:r="http://schemas.openxmlformats.org/officeDocument/2006/relationships">
+  <p:cSld>
+    <p:spTree>
+      <p:nvGrpSpPr>
+        <p:cNvPr id="1" name=""/>
+        <p:cNvGrpSpPr/>
+        <p:nvPr/>
+      </p:nvGrpSpPr>
+      <p:grpSpPr/>
+      <p:sp>
+        <p:nvSpPr>
+          <p:cNvPr id="2" name="Rectangle 1"/>
+          <p:cNvSpPr/>
+          <p:nvPr/>
+        </p:nvSpPr>
+        <p:spPr>
+          <a:xfrm>
+            <a:off x="0" y="0"/>
+            <a:ext cx="12191695" cy="1051560"/>
+          </a:xfrm>
+          <a:prstGeom prst="rect">
+            <a:avLst/>
+          </a:prstGeom>
+          <a:solidFill>
+            <a:srgbClr val="1A2B4A"/>
+          </a:solidFill>
+          <a:ln>
+            <a:noFill/>
+          </a:ln>
+          <a:effectLst/>
+        </p:spPr>
+        <p:style>
+          <a:lnRef idx="1">
+            <a:schemeClr val="accent1"/>
+          </a:lnRef>
+          <a:fillRef idx="3">
+            <a:schemeClr val="accent1"/>
+          </a:fillRef>
+          <a:effectRef idx="2">
+            <a:schemeClr val="accent1"/>
+          </a:effectRef>
+          <a:fontRef idx="minor">
+            <a:schemeClr val="lt1"/>
+          </a:fontRef>
+        </p:style>
+        <p:txBody>
+          <a:bodyPr rtlCol="0" anchor="ctr"/>
+          <a:lstStyle/>
+          <a:p>
+            <a:pPr algn="ctr"/>
+          </a:p>
+        </p:txBody>
+      </p:sp>
+      <p:sp>
+        <p:nvSpPr>
+          <p:cNvPr id="3" name="Rectangle 2"/>
+          <p:cNvSpPr/>
+          <p:nvPr/>
+        </p:nvSpPr>
+        <p:spPr>
+          <a:xfrm>
+            <a:off x="0" y="1051560"/>
+            <a:ext cx="12191695" cy="50800"/>
+          </a:xfrm>
+          <a:prstGeom prst="rect">
+            <a:avLst/>
+          </a:prstGeom>
+          <a:solidFill>
+            <a:srgbClr val="2563EB"/>
+          </a:solidFill>
+          <a:ln>
+            <a:noFill/>
+          </a:ln>
+          <a:effectLst/>
+        </p:spPr>
+        <p:style>
+          <a:lnRef idx="1">
+            <a:schemeClr val="accent1"/>
+          </a:lnRef>
+          <a:fillRef idx="3">
+            <a:schemeClr val="accent1"/>
+          </a:fillRef>
+          <a:effectRef idx="2">
+            <a:schemeClr val="accent1"/>
+          </a:effectRef>
+          <a:fontRef idx="minor">
+            <a:schemeClr val="lt1"/>
+          </a:fontRef>
+        </p:style>
+        <p:txBody>
+          <a:bodyPr rtlCol="0" anchor="ctr"/>
+          <a:lstStyle/>
+          <a:p>
+            <a:pPr algn="ctr"/>
+          </a:p>
+        </p:txBody>
+      </p:sp>
+      <p:sp>
+        <p:nvSpPr>
+          <p:cNvPr id="4" name="TextBox 3"/>
+          <p:cNvSpPr txBox="1"/>
+          <p:nvPr/>
+        </p:nvSpPr>
+        <p:spPr>
+          <a:xfrm>
+            <a:off x="548640" y="109728"/>
+            <a:ext cx="10972800" cy="365760"/>
+          </a:xfrm>
+          <a:prstGeom prst="rect">
+            <a:avLst/>
+          </a:prstGeom>
+          <a:noFill/>
+        </p:spPr>
+        <p:txBody>
+          <a:bodyPr wrap="square" anchor="t">
+            <a:spAutoFit/>
+          </a:bodyPr>
+          <a:lstStyle/>
+          <a:p>
+            <a:pPr algn="l">
+              <a:spcBef>
+                <a:spcPts val="0"/>
+              </a:spcBef>
+              <a:spcAft>
+                <a:spcPts val="600"/>
+              </a:spcAft>
+            </a:pPr>
+            <a:r>
+              <a:rPr sz="1300" b="1">
+                <a:solidFill>
+                  <a:srgbClr val="9DB8E8"/>
+                </a:solidFill>
+                <a:latin typeface="Calibri"/>
+              </a:rPr>
+              <a:t>PARTIE 1 — RÉGLAGE</a:t>
+            </a:r>
+          </a:p>
+        </p:txBody>
+      </p:sp>
+      <p:sp>
+        <p:nvSpPr>
+          <p:cNvPr id="5" name="TextBox 4"/>
+          <p:cNvSpPr txBox="1"/>
+          <p:nvPr/>
+        </p:nvSpPr>
+        <p:spPr>
+          <a:xfrm>
+            <a:off x="548640" y="384048"/>
+            <a:ext cx="11155680" cy="640080"/>
+          </a:xfrm>
+          <a:prstGeom prst="rect">
+            <a:avLst/>
+          </a:prstGeom>
+          <a:noFill/>
+        </p:spPr>
+        <p:txBody>
+          <a:bodyPr wrap="square" anchor="t">
+            <a:spAutoFit/>
+          </a:bodyPr>
+          <a:lstStyle/>
+          <a:p>
+            <a:pPr algn="l">
+              <a:spcBef>
+                <a:spcPts val="0"/>
+              </a:spcBef>
+              <a:spcAft>
+                <a:spcPts val="600"/>
+              </a:spcAft>
+            </a:pPr>
+            <a:r>
+              <a:rPr sz="2600" b="1">
+                <a:solidFill>
+                  <a:srgbClr val="FFFFFF"/>
+                </a:solidFill>
+                <a:latin typeface="Calibri"/>
+              </a:rPr>
+              <a:t>Meilleurs hyperparamètres trouvés</a:t>
+            </a:r>
+          </a:p>
+        </p:txBody>
+      </p:sp>
+      <p:graphicFrame>
+        <p:nvGraphicFramePr>
+          <p:cNvPr id="6" name="Table 5"/>
+          <p:cNvGraphicFramePr>
+            <a:graphicFrameLocks noGrp="1"/>
+          </p:cNvGraphicFramePr>
+          <p:nvPr/>
+        </p:nvGraphicFramePr>
+        <p:xfrm>
+          <a:off x="548640" y="1463040"/>
+          <a:ext cx="11064240" cy="2651760"/>
+        </p:xfrm>
+        <a:graphic>
+          <a:graphicData uri="http://schemas.openxmlformats.org/drawingml/2006/table">
+            <a:tbl>
+              <a:tblPr firstRow="1" bandRow="1">
+                <a:tableStyleId>{5C22544A-7EE6-4342-B048-85BDC9FD1C3A}</a:tableStyleId>
+              </a:tblPr>
+              <a:tblGrid>
+                <a:gridCol w="3688080"/>
+                <a:gridCol w="3688080"/>
+                <a:gridCol w="3688080"/>
+              </a:tblGrid>
+              <a:tr h="662940">
+                <a:tc>
+                  <a:txBody>
+                    <a:bodyPr/>
+                    <a:lstStyle/>
+                    <a:p>
+                      <a:pPr algn="ctr"/>
+                      <a:r>
+                        <a:rPr sz="1300" b="1">
+                          <a:solidFill>
+                            <a:srgbClr val="FFFFFF"/>
+                          </a:solidFill>
+                        </a:rPr>
+                        <a:t>Modèle</a:t>
+                      </a:r>
+                    </a:p>
+                  </a:txBody>
+                  <a:tcPr>
+                    <a:solidFill>
+                      <a:srgbClr val="1A2B4A"/>
+                    </a:solidFill>
+                  </a:tcPr>
+                </a:tc>
+                <a:tc>
+                  <a:txBody>
+                    <a:bodyPr/>
+                    <a:lstStyle/>
+                    <a:p>
+                      <a:pPr algn="ctr"/>
+                      <a:r>
+                        <a:rPr sz="1300" b="1">
+                          <a:solidFill>
+                            <a:srgbClr val="FFFFFF"/>
+                          </a:solidFill>
+                        </a:rPr>
+                        <a:t>Meilleurs hyperparamètres</a:t>
+                      </a:r>
+                    </a:p>
+                  </a:txBody>
+                  <a:tcPr>
+                    <a:solidFill>
+                      <a:srgbClr val="1A2B4A"/>
+                    </a:solidFill>
+                  </a:tcPr>
+                </a:tc>
+                <a:tc>
+                  <a:txBody>
+                    <a:bodyPr/>
+                    <a:lstStyle/>
+                    <a:p>
+                      <a:pPr algn="ctr"/>
+                      <a:r>
+                        <a:rPr sz="1300" b="1">
+                          <a:solidFill>
+                            <a:srgbClr val="FFFFFF"/>
+                          </a:solidFill>
+                        </a:rPr>
+                        <a:t>F1 (validation croisée)</a:t>
+                      </a:r>
+                    </a:p>
+                  </a:txBody>
+                  <a:tcPr>
+                    <a:solidFill>
+                      <a:srgbClr val="1A2B4A"/>
+                    </a:solidFill>
+                  </a:tcPr>
+                </a:tc>
+              </a:tr>
+              <a:tr h="662940">
+                <a:tc>
+                  <a:txBody>
+                    <a:bodyPr/>
+                    <a:lstStyle/>
+                    <a:p>
+                      <a:pPr algn="l"/>
+                      <a:r>
+                        <a:rPr sz="1150" b="1">
+                          <a:solidFill>
+                            <a:srgbClr val="1A2B4A"/>
+                          </a:solidFill>
+                        </a:rPr>
+                        <a:t>Arbre de décision</a:t>
+                      </a:r>
+                    </a:p>
+                  </a:txBody>
+                  <a:tcPr>
+                    <a:solidFill>
+                      <a:srgbClr val="EEF2F9"/>
+                    </a:solidFill>
+                  </a:tcPr>
+                </a:tc>
+                <a:tc>
+                  <a:txBody>
+                    <a:bodyPr/>
+                    <a:lstStyle/>
+                    <a:p>
+                      <a:pPr algn="l"/>
+                      <a:r>
+                        <a:rPr sz="1150" b="0">
+                          <a:solidFill>
+                            <a:srgbClr val="1A2B4A"/>
+                          </a:solidFill>
+                        </a:rPr>
+                        <a:t>max_depth = None · min_samples_leaf = 1</a:t>
+                      </a:r>
+                    </a:p>
+                  </a:txBody>
+                  <a:tcPr>
+                    <a:solidFill>
+                      <a:srgbClr val="FFFFFF"/>
+                    </a:solidFill>
+                  </a:tcPr>
+                </a:tc>
+                <a:tc>
+                  <a:txBody>
+                    <a:bodyPr/>
+                    <a:lstStyle/>
+                    <a:p>
+                      <a:pPr algn="ctr"/>
+                      <a:r>
+                        <a:rPr sz="1150" b="0">
+                          <a:solidFill>
+                            <a:srgbClr val="1A2B4A"/>
+                          </a:solidFill>
+                        </a:rPr>
+                        <a:t>0,113</a:t>
+                      </a:r>
+                    </a:p>
+                  </a:txBody>
+                  <a:tcPr>
+                    <a:solidFill>
+                      <a:srgbClr val="FFFFFF"/>
+                    </a:solidFill>
+                  </a:tcPr>
+                </a:tc>
+              </a:tr>
+              <a:tr h="662940">
+                <a:tc>
+                  <a:txBody>
+                    <a:bodyPr/>
+                    <a:lstStyle/>
+                    <a:p>
+                      <a:pPr algn="l"/>
+                      <a:r>
+                        <a:rPr sz="1150" b="1">
+                          <a:solidFill>
+                            <a:srgbClr val="1A2B4A"/>
+                          </a:solidFill>
+                        </a:rPr>
+                        <a:t>Random Forest</a:t>
+                      </a:r>
+                    </a:p>
+                  </a:txBody>
+                  <a:tcPr>
+                    <a:solidFill>
+                      <a:srgbClr val="EEF2F9"/>
+                    </a:solidFill>
+                  </a:tcPr>
+                </a:tc>
+                <a:tc>
+                  <a:txBody>
+                    <a:bodyPr/>
+                    <a:lstStyle/>
+                    <a:p>
+                      <a:pPr algn="l"/>
+                      <a:r>
+                        <a:rPr sz="1150" b="0">
+                          <a:solidFill>
+                            <a:srgbClr val="1A2B4A"/>
+                          </a:solidFill>
+                        </a:rPr>
+                        <a:t>n_estimators = 100 · max_depth = 5 · min_samples_leaf = 1 · class_weight = balanced</a:t>
+                      </a:r>
+                    </a:p>
+                  </a:txBody>
+                  <a:tcPr>
+                    <a:solidFill>
+                      <a:srgbClr val="FFFFFF"/>
+                    </a:solidFill>
+                  </a:tcPr>
+                </a:tc>
+                <a:tc>
+                  <a:txBody>
+                    <a:bodyPr/>
+                    <a:lstStyle/>
+                    <a:p>
+                      <a:pPr algn="ctr"/>
+                      <a:r>
+                        <a:rPr sz="1150" b="0">
+                          <a:solidFill>
+                            <a:srgbClr val="1A2B4A"/>
+                          </a:solidFill>
+                        </a:rPr>
+                        <a:t>0,185</a:t>
+                      </a:r>
+                    </a:p>
+                  </a:txBody>
+                  <a:tcPr>
+                    <a:solidFill>
+                      <a:srgbClr val="FFFFFF"/>
+                    </a:solidFill>
+                  </a:tcPr>
+                </a:tc>
+              </a:tr>
+              <a:tr h="662940">
+                <a:tc>
+                  <a:txBody>
+                    <a:bodyPr/>
+                    <a:lstStyle/>
+                    <a:p>
+                      <a:pPr algn="l"/>
+                      <a:r>
+                        <a:rPr sz="1150" b="1">
+                          <a:solidFill>
+                            <a:srgbClr val="1A2B4A"/>
+                          </a:solidFill>
+                        </a:rPr>
+                        <a:t>Gradient Boosting</a:t>
+                      </a:r>
+                    </a:p>
+                  </a:txBody>
+                  <a:tcPr>
+                    <a:solidFill>
+                      <a:srgbClr val="EEF2F9"/>
+                    </a:solidFill>
+                  </a:tcPr>
+                </a:tc>
+                <a:tc>
+                  <a:txBody>
+                    <a:bodyPr/>
+                    <a:lstStyle/>
+                    <a:p>
+                      <a:pPr algn="l"/>
+                      <a:r>
+                        <a:rPr sz="1150" b="0">
+                          <a:solidFill>
+                            <a:srgbClr val="1A2B4A"/>
+                          </a:solidFill>
+                        </a:rPr>
+                        <a:t>n_estimators = 100 · learning_rate = 0,05 · max_depth = 3 · sample_weight équilibré</a:t>
+                      </a:r>
+                    </a:p>
+                  </a:txBody>
+                  <a:tcPr>
+                    <a:solidFill>
+                      <a:srgbClr val="FFFFFF"/>
+                    </a:solidFill>
+                  </a:tcPr>
+                </a:tc>
+                <a:tc>
+                  <a:txBody>
+                    <a:bodyPr/>
+                    <a:lstStyle/>
+                    <a:p>
+                      <a:pPr algn="ctr"/>
+                      <a:r>
+                        <a:rPr sz="1150" b="0">
+                          <a:solidFill>
+                            <a:srgbClr val="1A2B4A"/>
+                          </a:solidFill>
+                        </a:rPr>
+                        <a:t>0,479</a:t>
+                      </a:r>
+                    </a:p>
+                  </a:txBody>
+                  <a:tcPr>
+                    <a:solidFill>
+                      <a:srgbClr val="FFFFFF"/>
+                    </a:solidFill>
+                  </a:tcPr>
+                </a:tc>
+              </a:tr>
+            </a:tbl>
+          </a:graphicData>
+        </a:graphic>
+      </p:graphicFrame>
+      <p:sp>
+        <p:nvSpPr>
+          <p:cNvPr id="7" name="TextBox 6"/>
+          <p:cNvSpPr txBox="1"/>
+          <p:nvPr/>
+        </p:nvSpPr>
+        <p:spPr>
+          <a:xfrm>
+            <a:off x="548640" y="4389120"/>
+            <a:ext cx="11064240" cy="1828800"/>
+          </a:xfrm>
+          <a:prstGeom prst="rect">
+            <a:avLst/>
+          </a:prstGeom>
+          <a:noFill/>
+        </p:spPr>
+        <p:txBody>
+          <a:bodyPr wrap="square" anchor="t">
+            <a:spAutoFit/>
+          </a:bodyPr>
+          <a:lstStyle/>
+          <a:p>
+            <a:pPr algn="l">
+              <a:spcBef>
+                <a:spcPts val="0"/>
+              </a:spcBef>
+              <a:spcAft>
+                <a:spcPts val="400"/>
+              </a:spcAft>
+            </a:pPr>
+            <a:r>
+              <a:rPr sz="1500" b="1">
+                <a:solidFill>
+                  <a:srgbClr val="2563EB"/>
+                </a:solidFill>
+                <a:latin typeface="Calibri"/>
+              </a:rPr>
+              <a:t>Attention au F1 de 0,479 : </a:t>
+            </a:r>
+            <a:r>
+              <a:rPr sz="1500" b="0">
+                <a:solidFill>
+                  <a:srgbClr val="1A2B4A"/>
+                </a:solidFill>
+                <a:latin typeface="Calibri"/>
+              </a:rPr>
+              <a:t>c'est le score de validation croisée du boosting, bien supérieur à son F1 de test (0,175). GridSearchCV découpe ses plis ligne par ligne — un même joueur peut donc se retrouver des deux côtés pendant la validation interne, ce qui gonfle le score. Le test final, séparé par joueur, est plus sévère et donne la mesure honnête.</a:t>
+            </a:r>
+          </a:p>
+        </p:txBody>
+      </p:sp>
+    </p:spTree>
+  </p:cSld>
+  <p:clrMapOvr>
+    <a:masterClrMapping/>
+  </p:clrMapOvr>
+</p:sld>
+</file>
+
+<file path=ppt/slides/slide7.xml><?xml version="1.0" encoding="utf-8"?>
 <p:sld xmlns:a="http://schemas.openxmlformats.org/drawingml/2006/main" xmlns:p="http://schemas.openxmlformats.org/presentationml/2006/main" xmlns:r="http://schemas.openxmlformats.org/officeDocument/2006/relationships">
   <p:cSld>
     <p:spTree>
@@ -7666,271 +9119,6 @@
 </p:sld>
 </file>
 
-<file path=ppt/slides/slide7.xml><?xml version="1.0" encoding="utf-8"?>
-<p:sld xmlns:a="http://schemas.openxmlformats.org/drawingml/2006/main" xmlns:p="http://schemas.openxmlformats.org/presentationml/2006/main" xmlns:r="http://schemas.openxmlformats.org/officeDocument/2006/relationships">
-  <p:cSld>
-    <p:spTree>
-      <p:nvGrpSpPr>
-        <p:cNvPr id="1" name=""/>
-        <p:cNvGrpSpPr/>
-        <p:nvPr/>
-      </p:nvGrpSpPr>
-      <p:grpSpPr/>
-      <p:sp>
-        <p:nvSpPr>
-          <p:cNvPr id="2" name="Rectangle 1"/>
-          <p:cNvSpPr/>
-          <p:nvPr/>
-        </p:nvSpPr>
-        <p:spPr>
-          <a:xfrm>
-            <a:off x="0" y="0"/>
-            <a:ext cx="12191695" cy="1051560"/>
-          </a:xfrm>
-          <a:prstGeom prst="rect">
-            <a:avLst/>
-          </a:prstGeom>
-          <a:solidFill>
-            <a:srgbClr val="1A2B4A"/>
-          </a:solidFill>
-          <a:ln>
-            <a:noFill/>
-          </a:ln>
-          <a:effectLst/>
-        </p:spPr>
-        <p:style>
-          <a:lnRef idx="1">
-            <a:schemeClr val="accent1"/>
-          </a:lnRef>
-          <a:fillRef idx="3">
-            <a:schemeClr val="accent1"/>
-          </a:fillRef>
-          <a:effectRef idx="2">
-            <a:schemeClr val="accent1"/>
-          </a:effectRef>
-          <a:fontRef idx="minor">
-            <a:schemeClr val="lt1"/>
-          </a:fontRef>
-        </p:style>
-        <p:txBody>
-          <a:bodyPr rtlCol="0" anchor="ctr"/>
-          <a:lstStyle/>
-          <a:p>
-            <a:pPr algn="ctr"/>
-          </a:p>
-        </p:txBody>
-      </p:sp>
-      <p:sp>
-        <p:nvSpPr>
-          <p:cNvPr id="3" name="Rectangle 2"/>
-          <p:cNvSpPr/>
-          <p:nvPr/>
-        </p:nvSpPr>
-        <p:spPr>
-          <a:xfrm>
-            <a:off x="0" y="1051560"/>
-            <a:ext cx="12191695" cy="50800"/>
-          </a:xfrm>
-          <a:prstGeom prst="rect">
-            <a:avLst/>
-          </a:prstGeom>
-          <a:solidFill>
-            <a:srgbClr val="2563EB"/>
-          </a:solidFill>
-          <a:ln>
-            <a:noFill/>
-          </a:ln>
-          <a:effectLst/>
-        </p:spPr>
-        <p:style>
-          <a:lnRef idx="1">
-            <a:schemeClr val="accent1"/>
-          </a:lnRef>
-          <a:fillRef idx="3">
-            <a:schemeClr val="accent1"/>
-          </a:fillRef>
-          <a:effectRef idx="2">
-            <a:schemeClr val="accent1"/>
-          </a:effectRef>
-          <a:fontRef idx="minor">
-            <a:schemeClr val="lt1"/>
-          </a:fontRef>
-        </p:style>
-        <p:txBody>
-          <a:bodyPr rtlCol="0" anchor="ctr"/>
-          <a:lstStyle/>
-          <a:p>
-            <a:pPr algn="ctr"/>
-          </a:p>
-        </p:txBody>
-      </p:sp>
-      <p:sp>
-        <p:nvSpPr>
-          <p:cNvPr id="4" name="TextBox 3"/>
-          <p:cNvSpPr txBox="1"/>
-          <p:nvPr/>
-        </p:nvSpPr>
-        <p:spPr>
-          <a:xfrm>
-            <a:off x="548640" y="109728"/>
-            <a:ext cx="10972800" cy="365760"/>
-          </a:xfrm>
-          <a:prstGeom prst="rect">
-            <a:avLst/>
-          </a:prstGeom>
-          <a:noFill/>
-        </p:spPr>
-        <p:txBody>
-          <a:bodyPr wrap="square" anchor="t">
-            <a:spAutoFit/>
-          </a:bodyPr>
-          <a:lstStyle/>
-          <a:p>
-            <a:pPr algn="l">
-              <a:spcBef>
-                <a:spcPts val="0"/>
-              </a:spcBef>
-              <a:spcAft>
-                <a:spcPts val="600"/>
-              </a:spcAft>
-            </a:pPr>
-            <a:r>
-              <a:rPr sz="1300" b="1">
-                <a:solidFill>
-                  <a:srgbClr val="9DB8E8"/>
-                </a:solidFill>
-                <a:latin typeface="Calibri"/>
-              </a:rPr>
-              <a:t>PARTIE 1 — ERREURS</a:t>
-            </a:r>
-          </a:p>
-        </p:txBody>
-      </p:sp>
-      <p:sp>
-        <p:nvSpPr>
-          <p:cNvPr id="5" name="TextBox 4"/>
-          <p:cNvSpPr txBox="1"/>
-          <p:nvPr/>
-        </p:nvSpPr>
-        <p:spPr>
-          <a:xfrm>
-            <a:off x="548640" y="384048"/>
-            <a:ext cx="11155680" cy="640080"/>
-          </a:xfrm>
-          <a:prstGeom prst="rect">
-            <a:avLst/>
-          </a:prstGeom>
-          <a:noFill/>
-        </p:spPr>
-        <p:txBody>
-          <a:bodyPr wrap="square" anchor="t">
-            <a:spAutoFit/>
-          </a:bodyPr>
-          <a:lstStyle/>
-          <a:p>
-            <a:pPr algn="l">
-              <a:spcBef>
-                <a:spcPts val="0"/>
-              </a:spcBef>
-              <a:spcAft>
-                <a:spcPts val="600"/>
-              </a:spcAft>
-            </a:pPr>
-            <a:r>
-              <a:rPr sz="2600" b="1">
-                <a:solidFill>
-                  <a:srgbClr val="FFFFFF"/>
-                </a:solidFill>
-                <a:latin typeface="Calibri"/>
-              </a:rPr>
-              <a:t>Matrices de confusion</a:t>
-            </a:r>
-          </a:p>
-        </p:txBody>
-      </p:sp>
-      <p:pic>
-        <p:nvPicPr>
-          <p:cNvPr id="6" name="Picture 5" descr="comparaison_matrices_confusion.png"/>
-          <p:cNvPicPr>
-            <a:picLocks noChangeAspect="1"/>
-          </p:cNvPicPr>
-          <p:nvPr/>
-        </p:nvPicPr>
-        <p:blipFill>
-          <a:blip r:embed="rId2"/>
-          <a:stretch>
-            <a:fillRect/>
-          </a:stretch>
-        </p:blipFill>
-        <p:spPr>
-          <a:xfrm>
-            <a:off x="1143000" y="1371600"/>
-            <a:ext cx="9875520" cy="3291840"/>
-          </a:xfrm>
-          <a:prstGeom prst="rect">
-            <a:avLst/>
-          </a:prstGeom>
-        </p:spPr>
-      </p:pic>
-      <p:sp>
-        <p:nvSpPr>
-          <p:cNvPr id="7" name="TextBox 6"/>
-          <p:cNvSpPr txBox="1"/>
-          <p:nvPr/>
-        </p:nvSpPr>
-        <p:spPr>
-          <a:xfrm>
-            <a:off x="548640" y="4846320"/>
-            <a:ext cx="11064240" cy="1325880"/>
-          </a:xfrm>
-          <a:prstGeom prst="rect">
-            <a:avLst/>
-          </a:prstGeom>
-          <a:noFill/>
-        </p:spPr>
-        <p:txBody>
-          <a:bodyPr wrap="square" anchor="t">
-            <a:spAutoFit/>
-          </a:bodyPr>
-          <a:lstStyle/>
-          <a:p>
-            <a:pPr algn="l">
-              <a:spcBef>
-                <a:spcPts val="0"/>
-              </a:spcBef>
-              <a:spcAft>
-                <a:spcPts val="400"/>
-              </a:spcAft>
-            </a:pPr>
-            <a:r>
-              <a:rPr sz="1500" b="1">
-                <a:solidFill>
-                  <a:srgbClr val="2563EB"/>
-                </a:solidFill>
-                <a:latin typeface="Calibri"/>
-              </a:rPr>
-              <a:t>Comment lire : </a:t>
-            </a:r>
-            <a:r>
-              <a:rPr sz="1500" b="0">
-                <a:solidFill>
-                  <a:srgbClr val="1A2B4A"/>
-                </a:solidFill>
-                <a:latin typeface="Calibri"/>
-              </a:rPr>
-              <a:t>diagonale = bonnes prédictions. Hors-diagonale : en haut à droite les faux positifs (carton annoncé à tort), en bas à gauche les faux négatifs (carton non anticipé).</a:t>
-            </a:r>
-          </a:p>
-        </p:txBody>
-      </p:sp>
-    </p:spTree>
-  </p:cSld>
-  <p:clrMapOvr>
-    <a:masterClrMapping/>
-  </p:clrMapOvr>
-</p:sld>
-</file>
-
 <file path=ppt/slides/slide8.xml><?xml version="1.0" encoding="utf-8"?>
 <p:sld xmlns:a="http://schemas.openxmlformats.org/drawingml/2006/main" xmlns:p="http://schemas.openxmlformats.org/presentationml/2006/main" xmlns:r="http://schemas.openxmlformats.org/officeDocument/2006/relationships">
   <p:cSld>
@@ -8066,7 +9254,7 @@
                 </a:solidFill>
                 <a:latin typeface="Calibri"/>
               </a:rPr>
-              <a:t>PARTIE 1 — INTERPRÉTATION</a:t>
+              <a:t>PARTIE 1 — ERREURS</a:t>
             </a:r>
           </a:p>
         </p:txBody>
@@ -8108,21 +9296,45 @@
                 </a:solidFill>
                 <a:latin typeface="Calibri"/>
               </a:rPr>
-              <a:t>Faux positifs vs faux négatifs</a:t>
-            </a:r>
-          </a:p>
-        </p:txBody>
-      </p:sp>
-      <p:sp>
-        <p:nvSpPr>
-          <p:cNvPr id="6" name="TextBox 5"/>
+              <a:t>Matrices de confusion</a:t>
+            </a:r>
+          </a:p>
+        </p:txBody>
+      </p:sp>
+      <p:pic>
+        <p:nvPicPr>
+          <p:cNvPr id="6" name="Picture 5" descr="comparaison_matrices_confusion.png"/>
+          <p:cNvPicPr>
+            <a:picLocks noChangeAspect="1"/>
+          </p:cNvPicPr>
+          <p:nvPr/>
+        </p:nvPicPr>
+        <p:blipFill>
+          <a:blip r:embed="rId2"/>
+          <a:stretch>
+            <a:fillRect/>
+          </a:stretch>
+        </p:blipFill>
+        <p:spPr>
+          <a:xfrm>
+            <a:off x="1143000" y="1371600"/>
+            <a:ext cx="9875520" cy="3291840"/>
+          </a:xfrm>
+          <a:prstGeom prst="rect">
+            <a:avLst/>
+          </a:prstGeom>
+        </p:spPr>
+      </p:pic>
+      <p:sp>
+        <p:nvSpPr>
+          <p:cNvPr id="7" name="TextBox 6"/>
           <p:cNvSpPr txBox="1"/>
           <p:nvPr/>
         </p:nvSpPr>
         <p:spPr>
           <a:xfrm>
-            <a:off x="640080" y="1371600"/>
-            <a:ext cx="10972800" cy="4937760"/>
+            <a:off x="548640" y="4846320"/>
+            <a:ext cx="11064240" cy="1325880"/>
           </a:xfrm>
           <a:prstGeom prst="rect">
             <a:avLst/>
@@ -8140,131 +9352,26 @@
                 <a:spcPts val="0"/>
               </a:spcBef>
               <a:spcAft>
-                <a:spcPts val="900"/>
-              </a:spcAft>
-            </a:pPr>
-            <a:r>
-              <a:rPr sz="1600" b="0">
+                <a:spcPts val="400"/>
+              </a:spcAft>
+            </a:pPr>
+            <a:r>
+              <a:rPr sz="1500" b="1">
+                <a:solidFill>
+                  <a:srgbClr val="2563EB"/>
+                </a:solidFill>
+                <a:latin typeface="Calibri"/>
+              </a:rPr>
+              <a:t>Comment lire : </a:t>
+            </a:r>
+            <a:r>
+              <a:rPr sz="1500" b="0">
                 <a:solidFill>
                   <a:srgbClr val="1A2B4A"/>
                 </a:solidFill>
                 <a:latin typeface="Calibri"/>
               </a:rPr>
-              <a:t>•  Faux positif = signaler à tort un joueur · Faux négatif = rater un vrai carton.</a:t>
-            </a:r>
-          </a:p>
-          <a:p>
-            <a:pPr algn="l">
-              <a:spcBef>
-                <a:spcPts val="0"/>
-              </a:spcBef>
-              <a:spcAft>
-                <a:spcPts val="900"/>
-              </a:spcAft>
-            </a:pPr>
-            <a:r>
-              <a:rPr sz="1450" b="0">
-                <a:solidFill>
-                  <a:srgbClr val="555555"/>
-                </a:solidFill>
-                <a:latin typeface="Calibri"/>
-              </a:rPr>
-              <a:t>–  Dans ce contexte, le faux positif est le plus grave : on ne veut pas pénaliser injustement.</a:t>
-            </a:r>
-          </a:p>
-          <a:p>
-            <a:pPr algn="l">
-              <a:spcBef>
-                <a:spcPts val="0"/>
-              </a:spcBef>
-              <a:spcAft>
-                <a:spcPts val="900"/>
-              </a:spcAft>
-            </a:pPr>
-            <a:r>
-              <a:rPr sz="1600" b="0">
-                <a:solidFill>
-                  <a:srgbClr val="1A2B4A"/>
-                </a:solidFill>
-                <a:latin typeface="Calibri"/>
-              </a:rPr>
-              <a:t>•  Or Random Forest : 3 098 faux positifs contre 593 faux négatifs.</a:t>
-            </a:r>
-          </a:p>
-          <a:p>
-            <a:pPr algn="l">
-              <a:spcBef>
-                <a:spcPts val="0"/>
-              </a:spcBef>
-              <a:spcAft>
-                <a:spcPts val="900"/>
-              </a:spcAft>
-            </a:pPr>
-            <a:r>
-              <a:rPr sz="1450" b="0">
-                <a:solidFill>
-                  <a:srgbClr val="555555"/>
-                </a:solidFill>
-                <a:latin typeface="Calibri"/>
-              </a:rPr>
-              <a:t>–  Elle se trompe 5 fois plus souvent dans le sens jugé le plus grave.</a:t>
-            </a:r>
-          </a:p>
-          <a:p>
-            <a:pPr algn="l">
-              <a:spcBef>
-                <a:spcPts val="0"/>
-              </a:spcBef>
-              <a:spcAft>
-                <a:spcPts val="900"/>
-              </a:spcAft>
-            </a:pPr>
-            <a:r>
-              <a:rPr sz="1450" b="0">
-                <a:solidFill>
-                  <a:srgbClr val="555555"/>
-                </a:solidFill>
-                <a:latin typeface="Calibri"/>
-              </a:rPr>
-              <a:t>–  Sur 3 505 alertes « carton », seules 407 sont justes → ~9 alertes sur 10 sont infondées.</a:t>
-            </a:r>
-          </a:p>
-          <a:p>
-            <a:pPr algn="l">
-              <a:spcBef>
-                <a:spcPts val="0"/>
-              </a:spcBef>
-              <a:spcAft>
-                <a:spcPts val="900"/>
-              </a:spcAft>
-            </a:pPr>
-            <a:r>
-              <a:rPr sz="1600" b="0">
-                <a:solidFill>
-                  <a:srgbClr val="1A2B4A"/>
-                </a:solidFill>
-                <a:latin typeface="Calibri"/>
-              </a:rPr>
-              <a:t>•  → Le F1 n'est pas aligné sur la priorité métier.</a:t>
-            </a:r>
-          </a:p>
-          <a:p>
-            <a:pPr algn="l">
-              <a:spcBef>
-                <a:spcPts val="0"/>
-              </a:spcBef>
-              <a:spcAft>
-                <a:spcPts val="900"/>
-              </a:spcAft>
-            </a:pPr>
-            <a:r>
-              <a:rPr sz="1450" b="0">
-                <a:solidFill>
-                  <a:srgbClr val="555555"/>
-                </a:solidFill>
-                <a:latin typeface="Calibri"/>
-              </a:rPr>
-              <a:t>–  Viser la précision, ou relever le seuil de décision, serait préférable pour cet usage.</a:t>
+              <a:t>diagonale = bonnes prédictions. Hors-diagonale : en haut à droite les faux positifs (carton annoncé à tort), en bas à gauche les faux négatifs (carton non anticipé).</a:t>
             </a:r>
           </a:p>
         </p:txBody>
@@ -8412,7 +9519,7 @@
                 </a:solidFill>
                 <a:latin typeface="Calibri"/>
               </a:rPr>
-              <a:t>PARTIE 1 — ROC / AUC</a:t>
+              <a:t>PARTIE 1 — INTERPRÉTATION</a:t>
             </a:r>
           </a:p>
         </p:txBody>
@@ -8454,45 +9561,21 @@
                 </a:solidFill>
                 <a:latin typeface="Calibri"/>
               </a:rPr>
-              <a:t>La capacité de discrimination, tous seuils confondus</a:t>
-            </a:r>
-          </a:p>
-        </p:txBody>
-      </p:sp>
-      <p:pic>
-        <p:nvPicPr>
-          <p:cNvPr id="6" name="Picture 5" descr="courbe_roc.png"/>
-          <p:cNvPicPr>
-            <a:picLocks noChangeAspect="1"/>
-          </p:cNvPicPr>
-          <p:nvPr/>
-        </p:nvPicPr>
-        <p:blipFill>
-          <a:blip r:embed="rId2"/>
-          <a:stretch>
-            <a:fillRect/>
-          </a:stretch>
-        </p:blipFill>
+              <a:t>Faux positifs vs faux négatifs</a:t>
+            </a:r>
+          </a:p>
+        </p:txBody>
+      </p:sp>
+      <p:sp>
+        <p:nvSpPr>
+          <p:cNvPr id="6" name="TextBox 5"/>
+          <p:cNvSpPr txBox="1"/>
+          <p:nvPr/>
+        </p:nvSpPr>
         <p:spPr>
           <a:xfrm>
             <a:off x="640080" y="1371600"/>
-            <a:ext cx="5394960" cy="4624251"/>
-          </a:xfrm>
-          <a:prstGeom prst="rect">
-            <a:avLst/>
-          </a:prstGeom>
-        </p:spPr>
-      </p:pic>
-      <p:sp>
-        <p:nvSpPr>
-          <p:cNvPr id="7" name="TextBox 6"/>
-          <p:cNvSpPr txBox="1"/>
-          <p:nvPr/>
-        </p:nvSpPr>
-        <p:spPr>
-          <a:xfrm>
-            <a:off x="6492240" y="1645920"/>
-            <a:ext cx="5212080" cy="4572000"/>
+            <a:ext cx="10972800" cy="4937760"/>
           </a:xfrm>
           <a:prstGeom prst="rect">
             <a:avLst/>
@@ -8510,17 +9593,17 @@
                 <a:spcPts val="0"/>
               </a:spcBef>
               <a:spcAft>
-                <a:spcPts val="1100"/>
-              </a:spcAft>
-            </a:pPr>
-            <a:r>
-              <a:rPr sz="1800" b="1">
-                <a:solidFill>
-                  <a:srgbClr val="2563EB"/>
-                </a:solidFill>
-                <a:latin typeface="Calibri"/>
-              </a:rPr>
-              <a:t>AUC ≈ 0,5 : à peine mieux que le hasard</a:t>
+                <a:spcPts val="900"/>
+              </a:spcAft>
+            </a:pPr>
+            <a:r>
+              <a:rPr sz="1600" b="0">
+                <a:solidFill>
+                  <a:srgbClr val="1A2B4A"/>
+                </a:solidFill>
+                <a:latin typeface="Calibri"/>
+              </a:rPr>
+              <a:t>•  Faux positif = signaler à tort un joueur · Faux négatif = rater un vrai carton.</a:t>
             </a:r>
           </a:p>
           <a:p>
@@ -8529,17 +9612,36 @@
                 <a:spcPts val="0"/>
               </a:spcBef>
               <a:spcAft>
-                <a:spcPts val="1100"/>
-              </a:spcAft>
-            </a:pPr>
-            <a:r>
-              <a:rPr sz="1500" b="0">
+                <a:spcPts val="900"/>
+              </a:spcAft>
+            </a:pPr>
+            <a:r>
+              <a:rPr sz="1450" b="0">
+                <a:solidFill>
+                  <a:srgbClr val="555555"/>
+                </a:solidFill>
+                <a:latin typeface="Calibri"/>
+              </a:rPr>
+              <a:t>–  Dans ce contexte, le faux positif est le plus grave : on ne veut pas pénaliser injustement.</a:t>
+            </a:r>
+          </a:p>
+          <a:p>
+            <a:pPr algn="l">
+              <a:spcBef>
+                <a:spcPts val="0"/>
+              </a:spcBef>
+              <a:spcAft>
+                <a:spcPts val="900"/>
+              </a:spcAft>
+            </a:pPr>
+            <a:r>
+              <a:rPr sz="1600" b="0">
                 <a:solidFill>
                   <a:srgbClr val="1A2B4A"/>
                 </a:solidFill>
                 <a:latin typeface="Calibri"/>
               </a:rPr>
-              <a:t>0,506 · 0,546 · 0,543 — les trois courbes frôlent la diagonale.</a:t>
+              <a:t>•  Or Random Forest : 3 098 faux positifs contre 593 faux négatifs.</a:t>
             </a:r>
           </a:p>
           <a:p>
@@ -8548,17 +9650,55 @@
                 <a:spcPts val="0"/>
               </a:spcBef>
               <a:spcAft>
-                <a:spcPts val="1100"/>
-              </a:spcAft>
-            </a:pPr>
-            <a:r>
-              <a:rPr sz="1500" b="0">
+                <a:spcPts val="900"/>
+              </a:spcAft>
+            </a:pPr>
+            <a:r>
+              <a:rPr sz="1450" b="0">
+                <a:solidFill>
+                  <a:srgbClr val="555555"/>
+                </a:solidFill>
+                <a:latin typeface="Calibri"/>
+              </a:rPr>
+              <a:t>–  Elle se trompe 5 fois plus souvent dans le sens jugé le plus grave.</a:t>
+            </a:r>
+          </a:p>
+          <a:p>
+            <a:pPr algn="l">
+              <a:spcBef>
+                <a:spcPts val="0"/>
+              </a:spcBef>
+              <a:spcAft>
+                <a:spcPts val="900"/>
+              </a:spcAft>
+            </a:pPr>
+            <a:r>
+              <a:rPr sz="1450" b="0">
+                <a:solidFill>
+                  <a:srgbClr val="555555"/>
+                </a:solidFill>
+                <a:latin typeface="Calibri"/>
+              </a:rPr>
+              <a:t>–  Sur 3 505 alertes « carton », seules 407 sont justes → ~9 alertes sur 10 sont infondées.</a:t>
+            </a:r>
+          </a:p>
+          <a:p>
+            <a:pPr algn="l">
+              <a:spcBef>
+                <a:spcPts val="0"/>
+              </a:spcBef>
+              <a:spcAft>
+                <a:spcPts val="900"/>
+              </a:spcAft>
+            </a:pPr>
+            <a:r>
+              <a:rPr sz="1600" b="0">
                 <a:solidFill>
                   <a:srgbClr val="1A2B4A"/>
                 </a:solidFill>
                 <a:latin typeface="Calibri"/>
               </a:rPr>
-              <a:t>L'éclairage décisif : la ROC teste tous les seuils, pas seulement 50 %.</a:t>
+              <a:t>•  → Le F1 n'est pas aligné sur la priorité métier.</a:t>
             </a:r>
           </a:p>
           <a:p>
@@ -8567,17 +9707,17 @@
                 <a:spcPts val="0"/>
               </a:spcBef>
               <a:spcAft>
-                <a:spcPts val="1100"/>
-              </a:spcAft>
-            </a:pPr>
-            <a:r>
-              <a:rPr sz="1500" b="0">
-                <a:solidFill>
-                  <a:srgbClr val="1A2B4A"/>
-                </a:solidFill>
-                <a:latin typeface="Calibri"/>
-              </a:rPr>
-              <a:t>Le gain de F1 obtenu par rééquilibrage traduisait donc surtout un déplacement du seuil (modèle plus « alarmiste »), pas une vraie capacité à séparer les classes.</a:t>
+                <a:spcPts val="900"/>
+              </a:spcAft>
+            </a:pPr>
+            <a:r>
+              <a:rPr sz="1450" b="0">
+                <a:solidFill>
+                  <a:srgbClr val="555555"/>
+                </a:solidFill>
+                <a:latin typeface="Calibri"/>
+              </a:rPr>
+              <a:t>–  Viser la précision, ou relever le seuil de décision, serait préférable pour cet usage.</a:t>
             </a:r>
           </a:p>
         </p:txBody>

</xml_diff>